<commit_message>
Update rental_film.c, PPTX, dan laporan sesuai kode terbaru
</commit_message>
<xml_diff>
--- a/Presentasi_Rental_Film_Kelompok_3.pptx
+++ b/Presentasi_Rental_Film_Kelompok_3.pptx
@@ -243,14 +243,14 @@
               <a:buNone/>
             </a:pPr>
             <a:r>
-              <a:rPr lang="id-ID" sz="1600" b="0" i="0" dirty="0">
+              <a:rPr lang="id-ID" sz="1500" b="0" i="0" dirty="0">
                 <a:solidFill>
                   <a:srgbClr val="94A3B8"/>
                 </a:solidFill>
                 <a:latin typeface="Calibri"/>
                 <a:cs typeface="Calibri"/>
               </a:rPr>
-              <a:t>Implementasi Bahasa C Menggunakan Struktur Kontrol Dasar (Tanpa Array, Struct, &amp; Pointer)</a:t>
+              <a:t>Implementasi Bahasa C Menggunakan do-while, switch-case, dan if-else (Tanpa Array Data, Struct, &amp; Pointer)</a:t>
             </a:r>
           </a:p>
         </p:txBody>
@@ -354,7 +354,7 @@
                 <a:latin typeface="Calibri"/>
                 <a:cs typeface="Calibri"/>
               </a:rPr>
-              <a:t>    Input ID &amp; nama pelanggan, daftar film, validasi pilihan film (do-while)</a:t>
+              <a:t>    Input ID &amp; nama pelanggan, daftar 5 film, validasi pilihan film (do-while &amp; switch)</a:t>
             </a:r>
           </a:p>
           <a:p>
@@ -390,7 +390,7 @@
                 <a:latin typeface="Calibri"/>
                 <a:cs typeface="Calibri"/>
               </a:rPr>
-              <a:t>    Biaya sewa, lama pinjam, denda keterlambatan &amp; status (if-else &amp; for)</a:t>
+              <a:t>    Input lama pinjam, opsi perpanjangan (y/n), hitung biaya sewa, denda &amp; status (if-else)</a:t>
             </a:r>
           </a:p>
           <a:p>
@@ -426,7 +426,7 @@
                 <a:latin typeface="Calibri"/>
                 <a:cs typeface="Calibri"/>
               </a:rPr>
-              <a:t>    Bukti rental, status film, uji tepat waktu &amp; terlambat, integrasi program</a:t>
+              <a:t>    Menampilkan bukti rental, biaya, denda, total bayar, status, &amp; pengujian program</a:t>
             </a:r>
           </a:p>
         </p:txBody>
@@ -798,8 +798,8 @@
         </p:nvSpPr>
         <p:spPr>
           <a:xfrm>
-            <a:off x="7772400" y="164592"/>
-            <a:ext cx="3886200" cy="320040"/>
+            <a:off x="7498079" y="164592"/>
+            <a:ext cx="4160520" cy="320040"/>
           </a:xfrm>
           <a:prstGeom prst="rect">
             <a:avLst/>
@@ -827,7 +827,7 @@
                 <a:latin typeface="Calibri"/>
                 <a:cs typeface="Calibri"/>
               </a:rPr>
-              <a:t>5.1 Tabel Skenario Pengujian (Valid, Tidak Valid, Nilai Batas, Pembayaran)</a:t>
+              <a:t>5.1 Tabel Skenario Pengujian Program Rental Film</a:t>
             </a:r>
           </a:p>
         </p:txBody>
@@ -1025,7 +1025,7 @@
                 <a:latin typeface="Calibri"/>
                 <a:cs typeface="Calibri"/>
               </a:rPr>
-              <a:t>1. Input Valid (Tepat Waktu)</a:t>
+              <a:t>1. Peminjaman Tepat Waktu</a:t>
             </a:r>
           </a:p>
         </p:txBody>
@@ -1067,7 +1067,7 @@
                 <a:latin typeface="Calibri"/>
                 <a:cs typeface="Calibri"/>
               </a:rPr>
-              <a:t>Input      : Film = 1 (Rp 8.000), Durasi = 3 hari, Lama Pinjam = 3 hari</a:t>
+              <a:t>Input      : Pilih Film = 1 (Avengers Rp5000), Lama = 3 hari, Perpanjang = n, Kembali = hari ke-3</a:t>
             </a:r>
           </a:p>
           <a:p>
@@ -1085,7 +1085,7 @@
                 <a:latin typeface="Calibri"/>
                 <a:cs typeface="Calibri"/>
               </a:rPr>
-              <a:t>Diharapkan: Biaya Rp 24.000, Denda Rp 0, Status TEPAT WAKTU</a:t>
+              <a:t>Diharapkan: Biaya Rp15000, Denda Rp0, Total Rp15000, Status: Tepat waktu</a:t>
             </a:r>
           </a:p>
           <a:p>
@@ -1103,7 +1103,7 @@
                 <a:latin typeface="Calibri"/>
                 <a:cs typeface="Calibri"/>
               </a:rPr>
-              <a:t>Aktual: Biaya Rp 24.000, Denda Rp 0, Status TEPAT WAKTU  [BERHASIL]</a:t>
+              <a:t>Aktual: Biaya Rp15000, Denda Rp0, Total Rp15000, Status: Tepat waktu  [BERHASIL]</a:t>
             </a:r>
           </a:p>
         </p:txBody>
@@ -1195,7 +1195,7 @@
                 <a:latin typeface="Calibri"/>
                 <a:cs typeface="Calibri"/>
               </a:rPr>
-              <a:t>2. Pilihan Film Tidak Valid</a:t>
+              <a:t>2. Pilihan Nomor Tidak Valid</a:t>
             </a:r>
           </a:p>
         </p:txBody>
@@ -1237,7 +1237,7 @@
                 <a:latin typeface="Calibri"/>
                 <a:cs typeface="Calibri"/>
               </a:rPr>
-              <a:t>Input      : Input pilihanFilm = 9 (di luar rentang 1 s/d 5)</a:t>
+              <a:t>Input      : Pilih Nomor Film = 9 (di luar rentang 1-5)</a:t>
             </a:r>
           </a:p>
           <a:p>
@@ -1255,7 +1255,7 @@
                 <a:latin typeface="Calibri"/>
                 <a:cs typeface="Calibri"/>
               </a:rPr>
-              <a:t>Diharapkan: Muncul pesan '[!] Error: Pilihan film tidak valid!' &amp; minta ulang</a:t>
+              <a:t>Diharapkan: Muncul pesan 'Nomor tidak valid, ulangi!' dan meminta input ulang</a:t>
             </a:r>
           </a:p>
           <a:p>
@@ -1273,7 +1273,7 @@
                 <a:latin typeface="Calibri"/>
                 <a:cs typeface="Calibri"/>
               </a:rPr>
-              <a:t>Aktual: Pesan error tampil dan do-while meminta input ulang  [BERHASIL]</a:t>
+              <a:t>Aktual: Muncul 'Nomor tidak valid, ulangi!' dan do-while mengulang input  [BERHASIL]</a:t>
             </a:r>
           </a:p>
         </p:txBody>
@@ -1321,7 +1321,7 @@
             </a:avLst>
           </a:prstGeom>
           <a:solidFill>
-            <a:srgbClr val="7C3AED"/>
+            <a:srgbClr val="D97706"/>
           </a:solidFill>
           <a:ln>
             <a:noFill/>
@@ -1365,7 +1365,7 @@
                 <a:latin typeface="Calibri"/>
                 <a:cs typeface="Calibri"/>
               </a:rPr>
-              <a:t>3. Nilai Batas &amp; Terlambat</a:t>
+              <a:t>3. Pilih Film Sedang Dipinjam</a:t>
             </a:r>
           </a:p>
         </p:txBody>
@@ -1407,7 +1407,7 @@
                 <a:latin typeface="Calibri"/>
                 <a:cs typeface="Calibri"/>
               </a:rPr>
-              <a:t>Input      : Film = 5 (Rp 9.000), Durasi = 2 hari, Lama = 7 hari (Telat 5 hari)</a:t>
+              <a:t>Input      : Pilih Nomor Film = 3 (Interstellar, STOK3 = 0 / Dipinjam)</a:t>
             </a:r>
           </a:p>
           <a:p>
@@ -1425,7 +1425,7 @@
                 <a:latin typeface="Calibri"/>
                 <a:cs typeface="Calibri"/>
               </a:rPr>
-              <a:t>Diharapkan: Biaya Rp 18.000, Denda Rp 35.000 (3x5rb + 2x10rb), Total Rp 53.000</a:t>
+              <a:t>Diharapkan: Ditolak dengan pesan 'Film sedang dipinjam, pilih yang lain!'</a:t>
             </a:r>
           </a:p>
           <a:p>
@@ -1443,7 +1443,7 @@
                 <a:latin typeface="Calibri"/>
                 <a:cs typeface="Calibri"/>
               </a:rPr>
-              <a:t>Aktual: Biaya Rp 18.000, Denda Rp 35.000, Total Rp 53.000, TERLAMBAT  [BERHASIL]</a:t>
+              <a:t>Aktual: Pesan tampil dan pengguna diminta memilih film lain  [BERHASIL]</a:t>
             </a:r>
           </a:p>
         </p:txBody>
@@ -1491,7 +1491,7 @@
             </a:avLst>
           </a:prstGeom>
           <a:solidFill>
-            <a:srgbClr val="D97706"/>
+            <a:srgbClr val="7C3AED"/>
           </a:solidFill>
           <a:ln>
             <a:noFill/>
@@ -1535,7 +1535,7 @@
                 <a:latin typeface="Calibri"/>
                 <a:cs typeface="Calibri"/>
               </a:rPr>
-              <a:t>4. Pembayaran Kurang</a:t>
+              <a:t>4. Perpanjangan Masa Sewa</a:t>
             </a:r>
           </a:p>
         </p:txBody>
@@ -1577,7 +1577,7 @@
                 <a:latin typeface="Calibri"/>
                 <a:cs typeface="Calibri"/>
               </a:rPr>
-              <a:t>Input      : Total Tagihan = Rp 24.000, Input uangBayar = Rp 10.000</a:t>
+              <a:t>Input      : Pilih Film = 2 (Rp6000), Lama awal = 2 hari, Perpanjang = y (+2 hari), Kembali = hari ke-4</a:t>
             </a:r>
           </a:p>
           <a:p>
@@ -1595,7 +1595,7 @@
                 <a:latin typeface="Calibri"/>
                 <a:cs typeface="Calibri"/>
               </a:rPr>
-              <a:t>Diharapkan: Pembayaran ditolak &amp; diminta memasukkan nominal yang cukup</a:t>
+              <a:t>Diharapkan: Lama pinjam jadi 4 hari, Biaya Rp24000, Denda Rp0, Status: Tepat waktu</a:t>
             </a:r>
           </a:p>
           <a:p>
@@ -1613,7 +1613,7 @@
                 <a:latin typeface="Calibri"/>
                 <a:cs typeface="Calibri"/>
               </a:rPr>
-              <a:t>Aktual: Muncul '[!] Error: Uang pembayaran kurang!' &amp; diulang  [BERHASIL]</a:t>
+              <a:t>Aktual: Lama pinjam 4 hari, Biaya Rp24000, Denda Rp0, Tepat waktu  [BERHASIL]</a:t>
             </a:r>
           </a:p>
         </p:txBody>
@@ -1661,7 +1661,7 @@
             </a:avLst>
           </a:prstGeom>
           <a:solidFill>
-            <a:srgbClr val="0F172A"/>
+            <a:srgbClr val="DC2626"/>
           </a:solidFill>
           <a:ln>
             <a:noFill/>
@@ -1705,7 +1705,7 @@
                 <a:latin typeface="Calibri"/>
                 <a:cs typeface="Calibri"/>
               </a:rPr>
-              <a:t>5. Pembayaran Lebih (Kembalian)</a:t>
+              <a:t>5. Pengembalian Terlambat</a:t>
             </a:r>
           </a:p>
         </p:txBody>
@@ -1747,7 +1747,7 @@
                 <a:latin typeface="Calibri"/>
                 <a:cs typeface="Calibri"/>
               </a:rPr>
-              <a:t>Input      : Total Tagihan = Rp 24.000, Input uangBayar = Rp 30.000</a:t>
+              <a:t>Input      : Pilih Film = 5 (Inception Rp6500), Lama = 2 hari, Perpanjang = n, Kembali = hari ke-5</a:t>
             </a:r>
           </a:p>
           <a:p>
@@ -1765,7 +1765,7 @@
                 <a:latin typeface="Calibri"/>
                 <a:cs typeface="Calibri"/>
               </a:rPr>
-              <a:t>Diharapkan: Pembayaran diterima &amp; Kembalian dihitung Rp 6.000</a:t>
+              <a:t>Diharapkan: Terlambat 3 hari -&gt; Denda Rp6000, Biaya Rp13000, Total Rp19000, Terlambat</a:t>
             </a:r>
           </a:p>
           <a:p>
@@ -1783,7 +1783,7 @@
                 <a:latin typeface="Calibri"/>
                 <a:cs typeface="Calibri"/>
               </a:rPr>
-              <a:t>Aktual: Kembalian tercetak Rp 6.000 pada Bukti Rental  [BERHASIL]</a:t>
+              <a:t>Aktual: Biaya Rp13000, Denda Rp6000, Total Rp19000, Status: Terlambat  [BERHASIL]</a:t>
             </a:r>
           </a:p>
         </p:txBody>
@@ -1961,8 +1961,8 @@
         </p:nvSpPr>
         <p:spPr>
           <a:xfrm>
-            <a:off x="7772400" y="164592"/>
-            <a:ext cx="3886200" cy="320040"/>
+            <a:off x="7498079" y="164592"/>
+            <a:ext cx="4160520" cy="320040"/>
           </a:xfrm>
           <a:prstGeom prst="rect">
             <a:avLst/>
@@ -1990,7 +1990,7 @@
                 <a:latin typeface="Calibri"/>
                 <a:cs typeface="Calibri"/>
               </a:rPr>
-              <a:t>5.2 Bukti Running Program pada Menu Pengujian Otomatis</a:t>
+              <a:t>5.2 Hasil Running Program rental_film.c</a:t>
             </a:r>
           </a:p>
         </p:txBody>
@@ -2225,30 +2225,30 @@
             <a:r>
               <a:rPr lang="id-ID" sz="1000" b="0" i="0" dirty="0">
                 <a:solidFill>
-                  <a:srgbClr val="38BDF8"/>
+                  <a:srgbClr val="CBD5E1"/>
                 </a:solidFill>
                 <a:latin typeface="Consolas"/>
                 <a:cs typeface="Consolas"/>
               </a:rPr>
-              <a:t>================================================</a:t>
-            </a:r>
-          </a:p>
-          <a:p>
-            <a:pPr algn="l">
-              <a:spcAft>
-                <a:spcPts val="400"/>
-              </a:spcAft>
-              <a:buNone/>
-            </a:pPr>
-            <a:r>
-              <a:rPr lang="id-ID" sz="1000" b="1" i="0" dirty="0">
-                <a:solidFill>
-                  <a:srgbClr val="FFFFFF"/>
+              <a:t>Masukkan ID pelanggan   : 101</a:t>
+            </a:r>
+          </a:p>
+          <a:p>
+            <a:pPr algn="l">
+              <a:spcAft>
+                <a:spcPts val="400"/>
+              </a:spcAft>
+              <a:buNone/>
+            </a:pPr>
+            <a:r>
+              <a:rPr lang="id-ID" sz="1000" b="0" i="0" dirty="0">
+                <a:solidFill>
+                  <a:srgbClr val="CBD5E1"/>
                 </a:solidFill>
                 <a:latin typeface="Consolas"/>
                 <a:cs typeface="Consolas"/>
               </a:rPr>
-              <a:t>               BUKTI RENTAL FILM</a:t>
+              <a:t>Masukkan nama pelanggan : Budi Santoso</a:t>
             </a:r>
           </a:p>
           <a:p>
@@ -2261,12 +2261,12 @@
             <a:r>
               <a:rPr lang="id-ID" sz="1000" b="0" i="0" dirty="0">
                 <a:solidFill>
-                  <a:srgbClr val="38BDF8"/>
+                  <a:srgbClr val="CBD5E1"/>
                 </a:solidFill>
                 <a:latin typeface="Consolas"/>
                 <a:cs typeface="Consolas"/>
               </a:rPr>
-              <a:t>================================================</a:t>
+              <a:t>Pilih nomor film (1-5)  : 1</a:t>
             </a:r>
           </a:p>
           <a:p>
@@ -2279,12 +2279,12 @@
             <a:r>
               <a:rPr lang="id-ID" sz="1000" b="0" i="0" dirty="0">
                 <a:solidFill>
-                  <a:srgbClr val="E2E8F0"/>
+                  <a:srgbClr val="38BDF8"/>
                 </a:solidFill>
                 <a:latin typeface="Consolas"/>
                 <a:cs typeface="Consolas"/>
               </a:rPr>
-              <a:t>ID Pelanggan      : P001</a:t>
+              <a:t>Anda memilih: Avengers: Endgame (Rp5000/hari)</a:t>
             </a:r>
           </a:p>
           <a:p>
@@ -2297,12 +2297,12 @@
             <a:r>
               <a:rPr lang="id-ID" sz="1000" b="0" i="0" dirty="0">
                 <a:solidFill>
-                  <a:srgbClr val="E2E8F0"/>
+                  <a:srgbClr val="CBD5E1"/>
                 </a:solidFill>
                 <a:latin typeface="Consolas"/>
                 <a:cs typeface="Consolas"/>
               </a:rPr>
-              <a:t>Nama Pelanggan    : Budi Santoso</a:t>
+              <a:t>Lama peminjaman (hari)  : 3</a:t>
             </a:r>
           </a:p>
           <a:p>
@@ -2315,48 +2315,48 @@
             <a:r>
               <a:rPr lang="id-ID" sz="1000" b="0" i="0" dirty="0">
                 <a:solidFill>
-                  <a:srgbClr val="E2E8F0"/>
+                  <a:srgbClr val="CBD5E1"/>
                 </a:solidFill>
                 <a:latin typeface="Consolas"/>
                 <a:cs typeface="Consolas"/>
               </a:rPr>
-              <a:t>Film Disewa       : Avengers: Endgame (F001)</a:t>
-            </a:r>
-          </a:p>
-          <a:p>
-            <a:pPr algn="l">
-              <a:spcAft>
-                <a:spcPts val="400"/>
+              <a:t>Perpanjang peminjaman? (y/n): n</a:t>
+            </a:r>
+          </a:p>
+          <a:p>
+            <a:pPr algn="l">
+              <a:spcAft>
+                <a:spcPts val="600"/>
               </a:spcAft>
               <a:buNone/>
             </a:pPr>
             <a:r>
               <a:rPr lang="id-ID" sz="1000" b="0" i="0" dirty="0">
                 <a:solidFill>
-                  <a:srgbClr val="E2E8F0"/>
+                  <a:srgbClr val="CBD5E1"/>
                 </a:solidFill>
                 <a:latin typeface="Consolas"/>
                 <a:cs typeface="Consolas"/>
               </a:rPr>
-              <a:t>Harga Sewa / Hari : Rp 8000</a:t>
-            </a:r>
-          </a:p>
-          <a:p>
-            <a:pPr algn="l">
-              <a:spcAft>
-                <a:spcPts val="400"/>
-              </a:spcAft>
-              <a:buNone/>
-            </a:pPr>
-            <a:r>
-              <a:rPr lang="id-ID" sz="1000" b="0" i="0" dirty="0">
-                <a:solidFill>
-                  <a:srgbClr val="E2E8F0"/>
+              <a:t>Film dikembalikan pada hari ke-: 3</a:t>
+            </a:r>
+          </a:p>
+          <a:p>
+            <a:pPr algn="l">
+              <a:spcAft>
+                <a:spcPts val="400"/>
+              </a:spcAft>
+              <a:buNone/>
+            </a:pPr>
+            <a:r>
+              <a:rPr lang="id-ID" sz="1000" b="1" i="0" dirty="0">
+                <a:solidFill>
+                  <a:srgbClr val="4ADE80"/>
                 </a:solidFill>
                 <a:latin typeface="Consolas"/>
                 <a:cs typeface="Consolas"/>
               </a:rPr>
-              <a:t>Durasi Sewa       : 3 hari</a:t>
+              <a:t>========== BUKTI RENTAL ==========</a:t>
             </a:r>
           </a:p>
           <a:p>
@@ -2369,12 +2369,12 @@
             <a:r>
               <a:rPr lang="id-ID" sz="1000" b="0" i="0" dirty="0">
                 <a:solidFill>
-                  <a:srgbClr val="E2E8F0"/>
+                  <a:srgbClr val="FFFFFF"/>
                 </a:solidFill>
                 <a:latin typeface="Consolas"/>
                 <a:cs typeface="Consolas"/>
               </a:rPr>
-              <a:t>Lama Peminjaman   : 3 hari (Terlambat: 0 hari)</a:t>
+              <a:t>ID / Nama    : 101 / Budi Santoso</a:t>
             </a:r>
           </a:p>
           <a:p>
@@ -2387,12 +2387,12 @@
             <a:r>
               <a:rPr lang="id-ID" sz="1000" b="0" i="0" dirty="0">
                 <a:solidFill>
-                  <a:srgbClr val="64748B"/>
+                  <a:srgbClr val="FFFFFF"/>
                 </a:solidFill>
                 <a:latin typeface="Consolas"/>
                 <a:cs typeface="Consolas"/>
               </a:rPr>
-              <a:t>------------------------------------------------</a:t>
+              <a:t>Film         : Avengers: Endgame</a:t>
             </a:r>
           </a:p>
           <a:p>
@@ -2405,12 +2405,12 @@
             <a:r>
               <a:rPr lang="id-ID" sz="1000" b="0" i="0" dirty="0">
                 <a:solidFill>
-                  <a:srgbClr val="E2E8F0"/>
+                  <a:srgbClr val="FFFFFF"/>
                 </a:solidFill>
                 <a:latin typeface="Consolas"/>
                 <a:cs typeface="Consolas"/>
               </a:rPr>
-              <a:t>Biaya Sewa        : Rp 24000</a:t>
+              <a:t>Biaya/hari   : Rp5000</a:t>
             </a:r>
           </a:p>
           <a:p>
@@ -2423,30 +2423,30 @@
             <a:r>
               <a:rPr lang="id-ID" sz="1000" b="0" i="0" dirty="0">
                 <a:solidFill>
-                  <a:srgbClr val="E2E8F0"/>
+                  <a:srgbClr val="FFFFFF"/>
                 </a:solidFill>
                 <a:latin typeface="Consolas"/>
                 <a:cs typeface="Consolas"/>
               </a:rPr>
-              <a:t>Denda Terlambat   : Rp 0</a:t>
-            </a:r>
-          </a:p>
-          <a:p>
-            <a:pPr algn="l">
-              <a:spcAft>
-                <a:spcPts val="400"/>
-              </a:spcAft>
-              <a:buNone/>
-            </a:pPr>
-            <a:r>
-              <a:rPr lang="id-ID" sz="1000" b="1" i="0" dirty="0">
-                <a:solidFill>
-                  <a:srgbClr val="4ADE80"/>
+              <a:t>Lama pinjam  : 3 hari</a:t>
+            </a:r>
+          </a:p>
+          <a:p>
+            <a:pPr algn="l">
+              <a:spcAft>
+                <a:spcPts val="400"/>
+              </a:spcAft>
+              <a:buNone/>
+            </a:pPr>
+            <a:r>
+              <a:rPr lang="id-ID" sz="1000" b="0" i="0" dirty="0">
+                <a:solidFill>
+                  <a:srgbClr val="FFFFFF"/>
                 </a:solidFill>
                 <a:latin typeface="Consolas"/>
                 <a:cs typeface="Consolas"/>
               </a:rPr>
-              <a:t>TOTAL BAYAR       : Rp 24000 (Bayar: Rp 30000)</a:t>
+              <a:t>Dikembalikan : hari ke-3</a:t>
             </a:r>
           </a:p>
           <a:p>
@@ -2459,48 +2459,48 @@
             <a:r>
               <a:rPr lang="id-ID" sz="1000" b="0" i="0" dirty="0">
                 <a:solidFill>
-                  <a:srgbClr val="E2E8F0"/>
+                  <a:srgbClr val="FFFFFF"/>
                 </a:solidFill>
                 <a:latin typeface="Consolas"/>
                 <a:cs typeface="Consolas"/>
               </a:rPr>
-              <a:t>Kembalian         : Rp 6000</a:t>
-            </a:r>
-          </a:p>
-          <a:p>
-            <a:pPr algn="l">
-              <a:spcAft>
-                <a:spcPts val="400"/>
-              </a:spcAft>
-              <a:buNone/>
-            </a:pPr>
-            <a:r>
-              <a:rPr lang="id-ID" sz="1000" b="1" i="0" dirty="0">
-                <a:solidFill>
-                  <a:srgbClr val="4ADE80"/>
+              <a:t>Biaya sewa   : Rp15000</a:t>
+            </a:r>
+          </a:p>
+          <a:p>
+            <a:pPr algn="l">
+              <a:spcAft>
+                <a:spcPts val="400"/>
+              </a:spcAft>
+              <a:buNone/>
+            </a:pPr>
+            <a:r>
+              <a:rPr lang="id-ID" sz="1000" b="0" i="0" dirty="0">
+                <a:solidFill>
+                  <a:srgbClr val="FFFFFF"/>
                 </a:solidFill>
                 <a:latin typeface="Consolas"/>
                 <a:cs typeface="Consolas"/>
               </a:rPr>
-              <a:t>Status Kembali    : TEPAT WAKTU</a:t>
-            </a:r>
-          </a:p>
-          <a:p>
-            <a:pPr algn="l">
-              <a:spcAft>
-                <a:spcPts val="400"/>
-              </a:spcAft>
-              <a:buNone/>
-            </a:pPr>
-            <a:r>
-              <a:rPr lang="id-ID" sz="1000" b="0" i="0" dirty="0">
-                <a:solidFill>
-                  <a:srgbClr val="E2E8F0"/>
+              <a:t>Denda        : Rp0</a:t>
+            </a:r>
+          </a:p>
+          <a:p>
+            <a:pPr algn="l">
+              <a:spcAft>
+                <a:spcPts val="400"/>
+              </a:spcAft>
+              <a:buNone/>
+            </a:pPr>
+            <a:r>
+              <a:rPr lang="id-ID" sz="1000" b="1" i="0" dirty="0">
+                <a:solidFill>
+                  <a:srgbClr val="4ADE80"/>
                 </a:solidFill>
                 <a:latin typeface="Consolas"/>
                 <a:cs typeface="Consolas"/>
               </a:rPr>
-              <a:t>Status Film       : Tersedia (Sudah Dikembalikan)</a:t>
+              <a:t>Total bayar  : Rp15000</a:t>
             </a:r>
           </a:p>
           <a:p>
@@ -2513,12 +2513,30 @@
             <a:r>
               <a:rPr lang="id-ID" sz="1000" b="1" i="0" dirty="0">
                 <a:solidFill>
-                  <a:srgbClr val="38BDF8"/>
+                  <a:srgbClr val="4ADE80"/>
                 </a:solidFill>
                 <a:latin typeface="Consolas"/>
                 <a:cs typeface="Consolas"/>
               </a:rPr>
-              <a:t>&gt;&gt; HASIL UJI 1 (TEPAT WAKTU): BERHASIL / LULUS</a:t>
+              <a:t>Status       : Tepat waktu</a:t>
+            </a:r>
+          </a:p>
+          <a:p>
+            <a:pPr algn="l">
+              <a:spcAft>
+                <a:spcPts val="400"/>
+              </a:spcAft>
+              <a:buNone/>
+            </a:pPr>
+            <a:r>
+              <a:rPr lang="id-ID" sz="1000" b="0" i="0" dirty="0">
+                <a:solidFill>
+                  <a:srgbClr val="4ADE80"/>
+                </a:solidFill>
+                <a:latin typeface="Consolas"/>
+                <a:cs typeface="Consolas"/>
+              </a:rPr>
+              <a:t>==================================</a:t>
             </a:r>
           </a:p>
         </p:txBody>
@@ -2610,7 +2628,7 @@
                 <a:latin typeface="Calibri"/>
                 <a:cs typeface="Calibri"/>
               </a:rPr>
-              <a:t>Pengujian 2 — Peminjaman Terlambat</a:t>
+              <a:t>Pengujian 2 — Validasi Stok &amp; Pengembalian Terlambat</a:t>
             </a:r>
           </a:p>
         </p:txBody>
@@ -2647,30 +2665,30 @@
             <a:r>
               <a:rPr lang="id-ID" sz="1000" b="0" i="0" dirty="0">
                 <a:solidFill>
-                  <a:srgbClr val="F87171"/>
+                  <a:srgbClr val="CBD5E1"/>
                 </a:solidFill>
                 <a:latin typeface="Consolas"/>
                 <a:cs typeface="Consolas"/>
               </a:rPr>
-              <a:t>================================================</a:t>
-            </a:r>
-          </a:p>
-          <a:p>
-            <a:pPr algn="l">
-              <a:spcAft>
-                <a:spcPts val="400"/>
-              </a:spcAft>
-              <a:buNone/>
-            </a:pPr>
-            <a:r>
-              <a:rPr lang="id-ID" sz="1000" b="1" i="0" dirty="0">
-                <a:solidFill>
-                  <a:srgbClr val="FFFFFF"/>
+              <a:t>Masukkan ID pelanggan   : 102</a:t>
+            </a:r>
+          </a:p>
+          <a:p>
+            <a:pPr algn="l">
+              <a:spcAft>
+                <a:spcPts val="400"/>
+              </a:spcAft>
+              <a:buNone/>
+            </a:pPr>
+            <a:r>
+              <a:rPr lang="id-ID" sz="1000" b="0" i="0" dirty="0">
+                <a:solidFill>
+                  <a:srgbClr val="CBD5E1"/>
                 </a:solidFill>
                 <a:latin typeface="Consolas"/>
                 <a:cs typeface="Consolas"/>
               </a:rPr>
-              <a:t>               BUKTI RENTAL FILM</a:t>
+              <a:t>Masukkan nama pelanggan : Siti Aminah</a:t>
             </a:r>
           </a:p>
           <a:p>
@@ -2683,12 +2701,12 @@
             <a:r>
               <a:rPr lang="id-ID" sz="1000" b="0" i="0" dirty="0">
                 <a:solidFill>
-                  <a:srgbClr val="F87171"/>
+                  <a:srgbClr val="CBD5E1"/>
                 </a:solidFill>
                 <a:latin typeface="Consolas"/>
                 <a:cs typeface="Consolas"/>
               </a:rPr>
-              <a:t>================================================</a:t>
+              <a:t>Pilih nomor film (1-5)  : 3</a:t>
             </a:r>
           </a:p>
           <a:p>
@@ -2701,12 +2719,12 @@
             <a:r>
               <a:rPr lang="id-ID" sz="1000" b="0" i="0" dirty="0">
                 <a:solidFill>
-                  <a:srgbClr val="E2E8F0"/>
+                  <a:srgbClr val="F87171"/>
                 </a:solidFill>
                 <a:latin typeface="Consolas"/>
                 <a:cs typeface="Consolas"/>
               </a:rPr>
-              <a:t>ID Pelanggan      : P002</a:t>
+              <a:t>Film sedang dipinjam, pilih yang lain!</a:t>
             </a:r>
           </a:p>
           <a:p>
@@ -2719,48 +2737,48 @@
             <a:r>
               <a:rPr lang="id-ID" sz="1000" b="0" i="0" dirty="0">
                 <a:solidFill>
-                  <a:srgbClr val="E2E8F0"/>
+                  <a:srgbClr val="CBD5E1"/>
                 </a:solidFill>
                 <a:latin typeface="Consolas"/>
                 <a:cs typeface="Consolas"/>
               </a:rPr>
-              <a:t>Nama Pelanggan    : Siti Aminah</a:t>
-            </a:r>
-          </a:p>
-          <a:p>
-            <a:pPr algn="l">
-              <a:spcAft>
-                <a:spcPts val="400"/>
+              <a:t>Pilih nomor film (1-5)  : 5</a:t>
+            </a:r>
+          </a:p>
+          <a:p>
+            <a:pPr algn="l">
+              <a:spcAft>
+                <a:spcPts val="600"/>
               </a:spcAft>
               <a:buNone/>
             </a:pPr>
             <a:r>
               <a:rPr lang="id-ID" sz="1000" b="0" i="0" dirty="0">
                 <a:solidFill>
-                  <a:srgbClr val="E2E8F0"/>
+                  <a:srgbClr val="CBD5E1"/>
                 </a:solidFill>
                 <a:latin typeface="Consolas"/>
                 <a:cs typeface="Consolas"/>
               </a:rPr>
-              <a:t>Film Disewa       : Interstellar (F005)</a:t>
-            </a:r>
-          </a:p>
-          <a:p>
-            <a:pPr algn="l">
-              <a:spcAft>
-                <a:spcPts val="400"/>
-              </a:spcAft>
-              <a:buNone/>
-            </a:pPr>
-            <a:r>
-              <a:rPr lang="id-ID" sz="1000" b="0" i="0" dirty="0">
-                <a:solidFill>
-                  <a:srgbClr val="E2E8F0"/>
+              <a:t>Lama peminjaman: 2 | Perpanjang: n | Kembali: hari ke-5</a:t>
+            </a:r>
+          </a:p>
+          <a:p>
+            <a:pPr algn="l">
+              <a:spcAft>
+                <a:spcPts val="400"/>
+              </a:spcAft>
+              <a:buNone/>
+            </a:pPr>
+            <a:r>
+              <a:rPr lang="id-ID" sz="1000" b="1" i="0" dirty="0">
+                <a:solidFill>
+                  <a:srgbClr val="F87171"/>
                 </a:solidFill>
                 <a:latin typeface="Consolas"/>
                 <a:cs typeface="Consolas"/>
               </a:rPr>
-              <a:t>Harga Sewa / Hari : Rp 9000</a:t>
+              <a:t>========== BUKTI RENTAL ==========</a:t>
             </a:r>
           </a:p>
           <a:p>
@@ -2773,12 +2791,12 @@
             <a:r>
               <a:rPr lang="id-ID" sz="1000" b="0" i="0" dirty="0">
                 <a:solidFill>
-                  <a:srgbClr val="E2E8F0"/>
+                  <a:srgbClr val="FFFFFF"/>
                 </a:solidFill>
                 <a:latin typeface="Consolas"/>
                 <a:cs typeface="Consolas"/>
               </a:rPr>
-              <a:t>Durasi Sewa       : 2 hari</a:t>
+              <a:t>ID / Nama    : 102 / Siti Aminah</a:t>
             </a:r>
           </a:p>
           <a:p>
@@ -2791,12 +2809,12 @@
             <a:r>
               <a:rPr lang="id-ID" sz="1000" b="0" i="0" dirty="0">
                 <a:solidFill>
-                  <a:srgbClr val="FCA5A5"/>
+                  <a:srgbClr val="FFFFFF"/>
                 </a:solidFill>
                 <a:latin typeface="Consolas"/>
                 <a:cs typeface="Consolas"/>
               </a:rPr>
-              <a:t>Lama Peminjaman   : 7 hari (Terlambat: 5 hari)</a:t>
+              <a:t>Film         : Inception</a:t>
             </a:r>
           </a:p>
           <a:p>
@@ -2809,12 +2827,12 @@
             <a:r>
               <a:rPr lang="id-ID" sz="1000" b="0" i="0" dirty="0">
                 <a:solidFill>
-                  <a:srgbClr val="64748B"/>
+                  <a:srgbClr val="FFFFFF"/>
                 </a:solidFill>
                 <a:latin typeface="Consolas"/>
                 <a:cs typeface="Consolas"/>
               </a:rPr>
-              <a:t>------------------------------------------------</a:t>
+              <a:t>Biaya/hari   : Rp6500</a:t>
             </a:r>
           </a:p>
           <a:p>
@@ -2827,12 +2845,12 @@
             <a:r>
               <a:rPr lang="id-ID" sz="1000" b="0" i="0" dirty="0">
                 <a:solidFill>
-                  <a:srgbClr val="E2E8F0"/>
+                  <a:srgbClr val="FFFFFF"/>
                 </a:solidFill>
                 <a:latin typeface="Consolas"/>
                 <a:cs typeface="Consolas"/>
               </a:rPr>
-              <a:t>Biaya Sewa        : Rp 18000</a:t>
+              <a:t>Lama pinjam  : 2 hari</a:t>
             </a:r>
           </a:p>
           <a:p>
@@ -2850,25 +2868,25 @@
                 <a:latin typeface="Consolas"/>
                 <a:cs typeface="Consolas"/>
               </a:rPr>
-              <a:t>Denda Terlambat   : Rp 35000 (3x5rb + 2x10rb)</a:t>
-            </a:r>
-          </a:p>
-          <a:p>
-            <a:pPr algn="l">
-              <a:spcAft>
-                <a:spcPts val="400"/>
-              </a:spcAft>
-              <a:buNone/>
-            </a:pPr>
-            <a:r>
-              <a:rPr lang="id-ID" sz="1000" b="1" i="0" dirty="0">
-                <a:solidFill>
-                  <a:srgbClr val="FBBF24"/>
+              <a:t>Dikembalikan : hari ke-5</a:t>
+            </a:r>
+          </a:p>
+          <a:p>
+            <a:pPr algn="l">
+              <a:spcAft>
+                <a:spcPts val="400"/>
+              </a:spcAft>
+              <a:buNone/>
+            </a:pPr>
+            <a:r>
+              <a:rPr lang="id-ID" sz="1000" b="0" i="0" dirty="0">
+                <a:solidFill>
+                  <a:srgbClr val="FFFFFF"/>
                 </a:solidFill>
                 <a:latin typeface="Consolas"/>
                 <a:cs typeface="Consolas"/>
               </a:rPr>
-              <a:t>TOTAL BAYAR       : Rp 53000 (Bayar: Rp 60000)</a:t>
+              <a:t>Biaya sewa   : Rp13000</a:t>
             </a:r>
           </a:p>
           <a:p>
@@ -2881,12 +2899,12 @@
             <a:r>
               <a:rPr lang="id-ID" sz="1000" b="0" i="0" dirty="0">
                 <a:solidFill>
-                  <a:srgbClr val="E2E8F0"/>
+                  <a:srgbClr val="FCA5A5"/>
                 </a:solidFill>
                 <a:latin typeface="Consolas"/>
                 <a:cs typeface="Consolas"/>
               </a:rPr>
-              <a:t>Kembalian         : Rp 7000</a:t>
+              <a:t>Denda        : Rp6000</a:t>
             </a:r>
           </a:p>
           <a:p>
@@ -2899,48 +2917,48 @@
             <a:r>
               <a:rPr lang="id-ID" sz="1000" b="1" i="0" dirty="0">
                 <a:solidFill>
-                  <a:srgbClr val="F87171"/>
+                  <a:srgbClr val="FBBF24"/>
                 </a:solidFill>
                 <a:latin typeface="Consolas"/>
                 <a:cs typeface="Consolas"/>
               </a:rPr>
-              <a:t>Status Kembali    : TERLAMBAT</a:t>
-            </a:r>
-          </a:p>
-          <a:p>
-            <a:pPr algn="l">
-              <a:spcAft>
-                <a:spcPts val="400"/>
-              </a:spcAft>
-              <a:buNone/>
-            </a:pPr>
-            <a:r>
-              <a:rPr lang="id-ID" sz="1000" b="0" i="0" dirty="0">
-                <a:solidFill>
-                  <a:srgbClr val="E2E8F0"/>
+              <a:t>Total bayar  : Rp19000</a:t>
+            </a:r>
+          </a:p>
+          <a:p>
+            <a:pPr algn="l">
+              <a:spcAft>
+                <a:spcPts val="400"/>
+              </a:spcAft>
+              <a:buNone/>
+            </a:pPr>
+            <a:r>
+              <a:rPr lang="id-ID" sz="1000" b="1" i="0" dirty="0">
+                <a:solidFill>
+                  <a:srgbClr val="F87171"/>
                 </a:solidFill>
                 <a:latin typeface="Consolas"/>
                 <a:cs typeface="Consolas"/>
               </a:rPr>
-              <a:t>Status Film       : Tersedia (Sudah Dikembalikan)</a:t>
-            </a:r>
-          </a:p>
-          <a:p>
-            <a:pPr algn="l">
-              <a:spcAft>
-                <a:spcPts val="400"/>
-              </a:spcAft>
-              <a:buNone/>
-            </a:pPr>
-            <a:r>
-              <a:rPr lang="id-ID" sz="1000" b="1" i="0" dirty="0">
-                <a:solidFill>
-                  <a:srgbClr val="38BDF8"/>
+              <a:t>Status       : Terlambat</a:t>
+            </a:r>
+          </a:p>
+          <a:p>
+            <a:pPr algn="l">
+              <a:spcAft>
+                <a:spcPts val="400"/>
+              </a:spcAft>
+              <a:buNone/>
+            </a:pPr>
+            <a:r>
+              <a:rPr lang="id-ID" sz="1000" b="0" i="0" dirty="0">
+                <a:solidFill>
+                  <a:srgbClr val="F87171"/>
                 </a:solidFill>
                 <a:latin typeface="Consolas"/>
                 <a:cs typeface="Consolas"/>
               </a:rPr>
-              <a:t>&gt;&gt; HASIL UJI 2 (TERLAMBAT)  : BERHASIL / LULUS</a:t>
+              <a:t>==================================</a:t>
             </a:r>
           </a:p>
         </p:txBody>
@@ -3118,8 +3136,8 @@
         </p:nvSpPr>
         <p:spPr>
           <a:xfrm>
-            <a:off x="7772400" y="164592"/>
-            <a:ext cx="3886200" cy="320040"/>
+            <a:off x="7498079" y="164592"/>
+            <a:ext cx="4160520" cy="320040"/>
           </a:xfrm>
           <a:prstGeom prst="rect">
             <a:avLst/>
@@ -3387,7 +3405,7 @@
                 <a:latin typeface="Calibri"/>
                 <a:cs typeface="Calibri"/>
               </a:rPr>
-              <a:t>Hasil Program: Program berhasil berjalan secara interaktif, memvalidasi input, menghitung sewa &amp; denda, dan menampilkan bukti rental dengan tepat.</a:t>
+              <a:t>Hasil Program: Program berhasil memvalidasi pilihan film, menghitung perpanjangan sewa, menghitung denda keterlambatan, dan menampilkan bukti rental.</a:t>
             </a:r>
           </a:p>
           <a:p>
@@ -3405,7 +3423,7 @@
                 <a:latin typeface="Calibri"/>
                 <a:cs typeface="Calibri"/>
               </a:rPr>
-              <a:t>if : Mengecek validitas input dan kecukupan pembayaran.</a:t>
+              <a:t>if : Mengecek apakah pengguna memilih perpanjangan sewa (jawab == 'y' || jawab == 'Y').</a:t>
             </a:r>
           </a:p>
           <a:p>
@@ -3423,7 +3441,7 @@
                 <a:latin typeface="Calibri"/>
                 <a:cs typeface="Calibri"/>
               </a:rPr>
-              <a:t>if-else : Menentukan harga film (1-5), menentukan status TEPAT WAKTU vs TERLAMBAT, dan memilih tarif denda harian.</a:t>
+              <a:t>if-else : Mengecek stok film (STOK1..5) serta menentukan denda dan status ('Terlambat' vs 'Tepat waktu').</a:t>
             </a:r>
           </a:p>
           <a:p>
@@ -3441,7 +3459,7 @@
                 <a:latin typeface="Calibri"/>
                 <a:cs typeface="Calibri"/>
               </a:rPr>
-              <a:t>while : Membersihkan sisa karakter input pada buffer stdin.</a:t>
+              <a:t>switch-case : Memilih film ke-1 s/d ke-5 berdasarkan input pengguna.</a:t>
             </a:r>
           </a:p>
           <a:p>
@@ -3459,25 +3477,7 @@
                 <a:latin typeface="Calibri"/>
                 <a:cs typeface="Calibri"/>
               </a:rPr>
-              <a:t>do-while : Mengulang input saat tidak valid &amp; mengulang transaksi.</a:t>
-            </a:r>
-          </a:p>
-          <a:p>
-            <a:pPr algn="l" marL="228600" indent="-228600">
-              <a:spcAft>
-                <a:spcPts val="500"/>
-              </a:spcAft>
-              <a:buChar char="•"/>
-            </a:pPr>
-            <a:r>
-              <a:rPr lang="id-ID" sz="1200" b="0" i="0" dirty="0">
-                <a:solidFill>
-                  <a:srgbClr val="1E293B"/>
-                </a:solidFill>
-                <a:latin typeface="Calibri"/>
-                <a:cs typeface="Calibri"/>
-              </a:rPr>
-              <a:t>for : Mengakumulasi denda per hari keterlambatan &amp; mencetak daftar film.</a:t>
+              <a:t>do-while : Mengulang input pilihan film selama nomor tidak valid atau film sedang dipinjam (!valid).</a:t>
             </a:r>
           </a:p>
         </p:txBody>
@@ -3611,7 +3611,7 @@
                 <a:latin typeface="Calibri"/>
                 <a:cs typeface="Calibri"/>
               </a:rPr>
-              <a:t>Kendala 1: Input pilihan film di luar nomor 1-5 atau film sedang dipinjam.</a:t>
+              <a:t>Kendala 1: Pengguna memilih nomor film di luar 1-5 atau film yang sedang dipinjam (STOK = 0).</a:t>
             </a:r>
           </a:p>
           <a:p>
@@ -3629,7 +3629,7 @@
                 <a:latin typeface="Calibri"/>
                 <a:cs typeface="Calibri"/>
               </a:rPr>
-              <a:t>Solusi 1 : Menambahkan validasi bertingkat di dalam perulangan do-while.</a:t>
+              <a:t>Solusi 1 : Menggunakan perulangan do-while dengan variabel penanda valid dan percabangan switch-case.</a:t>
             </a:r>
           </a:p>
           <a:p>
@@ -3647,7 +3647,7 @@
                 <a:latin typeface="Calibri"/>
                 <a:cs typeface="Calibri"/>
               </a:rPr>
-              <a:t>Kendala 2: Menyimpan status 5 film tanpa menggunakan array maupun struct.</a:t>
+              <a:t>Kendala 2: Menyimpan data 5 film tanpa menggunakan array maupun struct.</a:t>
             </a:r>
           </a:p>
           <a:p>
@@ -3665,7 +3665,7 @@
                 <a:latin typeface="Calibri"/>
                 <a:cs typeface="Calibri"/>
               </a:rPr>
-              <a:t>Solusi 2 : Menggunakan 5 variabel global (film1_tersedia s/d film5_tersedia) dan fungsi pemilihan if-else.</a:t>
+              <a:t>Solusi 2 : Mendefinisikan konstanta makro #define JUDUL1..5, HARGA1..5, dan STOK1..5 di bagian atas program.</a:t>
             </a:r>
           </a:p>
           <a:p>
@@ -3683,7 +3683,7 @@
                 <a:latin typeface="Calibri"/>
                 <a:cs typeface="Calibri"/>
               </a:rPr>
-              <a:t>Kendala 3: Uang pembayaran kurang dari total biaya sewa + denda.</a:t>
+              <a:t>Kendala 3: Membaca nama pelanggan yang mengandung spasi menggunakan scanf.</a:t>
             </a:r>
           </a:p>
           <a:p>
@@ -3701,43 +3701,7 @@
                 <a:latin typeface="Calibri"/>
                 <a:cs typeface="Calibri"/>
               </a:rPr>
-              <a:t>Solusi 3 : Menambahkan pengecekan if (uangBayar &lt; totalBayar) di dalam do-while agar pengguna mengulang pembayaran.</a:t>
-            </a:r>
-          </a:p>
-          <a:p>
-            <a:pPr algn="l" marL="228600" indent="-228600">
-              <a:spcAft>
-                <a:spcPts val="500"/>
-              </a:spcAft>
-              <a:buChar char="•"/>
-            </a:pPr>
-            <a:r>
-              <a:rPr lang="id-ID" sz="1200" b="0" i="0" dirty="0">
-                <a:solidFill>
-                  <a:srgbClr val="1E293B"/>
-                </a:solidFill>
-                <a:latin typeface="Calibri"/>
-                <a:cs typeface="Calibri"/>
-              </a:rPr>
-              <a:t>Kendala 4: Program langsung tertutup setelah 1 transaksi selesai.</a:t>
-            </a:r>
-          </a:p>
-          <a:p>
-            <a:pPr algn="l" marL="228600" indent="-228600">
-              <a:spcAft>
-                <a:spcPts val="500"/>
-              </a:spcAft>
-              <a:buChar char="•"/>
-            </a:pPr>
-            <a:r>
-              <a:rPr lang="id-ID" sz="1200" b="0" i="0" dirty="0">
-                <a:solidFill>
-                  <a:srgbClr val="1E293B"/>
-                </a:solidFill>
-                <a:latin typeface="Calibri"/>
-                <a:cs typeface="Calibri"/>
-              </a:rPr>
-              <a:t>Solusi 4 : Membungkus menu utama dan transaksi dengan perulangan do-while.</a:t>
+              <a:t>Solusi 3 : Menggunakan format spesifikasi scanf(" %[^\n]", nama) agar spasi ikut terbaca.</a:t>
             </a:r>
           </a:p>
         </p:txBody>
@@ -3915,8 +3879,8 @@
         </p:nvSpPr>
         <p:spPr>
           <a:xfrm>
-            <a:off x="7772400" y="164592"/>
-            <a:ext cx="3886200" cy="320040"/>
+            <a:off x="7498079" y="164592"/>
+            <a:ext cx="4160520" cy="320040"/>
           </a:xfrm>
           <a:prstGeom prst="rect">
             <a:avLst/>
@@ -4184,7 +4148,7 @@
                 <a:latin typeface="Calibri"/>
                 <a:cs typeface="Calibri"/>
               </a:rPr>
-              <a:t>Seluruh tujuan mini project telah tercapai dengan baik.</a:t>
+              <a:t>Seluruh tujuan mini project telah tercapai.</a:t>
             </a:r>
           </a:p>
           <a:p>
@@ -4202,7 +4166,7 @@
                 <a:latin typeface="Calibri"/>
                 <a:cs typeface="Calibri"/>
               </a:rPr>
-              <a:t>Program Sistem Rental Film dalam bahasa C berhasil menerapkan struktur kontrol if, if-else, while, do-while, dan for tanpa menggunakan array data, struct, maupun pointer.</a:t>
+              <a:t>Program Sistem Rental Film berhasil dibangun menggunakan bahasa C dengan menerapkan do-while, switch-case, if, dan if-else tanpa menggunakan array data, struct, maupun pointer.</a:t>
             </a:r>
           </a:p>
           <a:p>
@@ -4220,7 +4184,7 @@
                 <a:latin typeface="Calibri"/>
                 <a:cs typeface="Calibri"/>
               </a:rPr>
-              <a:t>Kolaborasi Mahasiswa 1, 2, dan 3 terintegrasi dengan baik dan seluruh skenario pengujian (Tepat Waktu &amp; Terlambat) dinyatakan LULUS.</a:t>
+              <a:t>Program berhasil memvalidasi pilihan film, menghitung biaya sewa dan denda keterlambatan, serta menampilkan bukti rental dengan tepat.</a:t>
             </a:r>
           </a:p>
         </p:txBody>
@@ -4354,7 +4318,7 @@
                 <a:latin typeface="Calibri"/>
                 <a:cs typeface="Calibri"/>
               </a:rPr>
-              <a:t>Menggunakan ARRAY untuk menampung lebih banyak katalog film dan riwayat transaksi pelanggan secara dinamis.</a:t>
+              <a:t>Pada tahap selanjutnya, program dapat dikembangkan untuk menyimpan banyak data film dan pelanggan menggunakan ARRAY.</a:t>
             </a:r>
           </a:p>
           <a:p>
@@ -4372,7 +4336,7 @@
                 <a:latin typeface="Calibri"/>
                 <a:cs typeface="Calibri"/>
               </a:rPr>
-              <a:t>Menggunakan STRUCT untuk mengelompokkan data Pelanggan, Film, dan Transaksi agar kode lebih rapi dan modular.</a:t>
+              <a:t>Data pelanggan, film, dan transaksi dapat dikelompokkan menggunakan STRUCT.</a:t>
             </a:r>
           </a:p>
           <a:p>
@@ -4390,7 +4354,7 @@
                 <a:latin typeface="Calibri"/>
                 <a:cs typeface="Calibri"/>
               </a:rPr>
-              <a:t>Menggunakan POINTER untuk manipulasi data antar-fungsi secara efisien serta penyimpanan ke file eksternal.</a:t>
+              <a:t>Manipulasi dan pengelolaan data selanjutnya dapat dioptimalkan menggunakan POINTER.</a:t>
             </a:r>
           </a:p>
         </p:txBody>
@@ -4560,7 +4524,7 @@
                 <a:latin typeface="Calibri"/>
                 <a:cs typeface="Calibri"/>
               </a:rPr>
-              <a:t>3. Dokumentasi C Standard Library (&lt;stdio.h&gt;) — https://en.cppreference.com/w/c</a:t>
+              <a:t>3. Dokumentasi C Standard Library (&lt;stdio.h&gt; &amp; &lt;string.h&gt;) — https://en.cppreference.com/w/c</a:t>
             </a:r>
           </a:p>
         </p:txBody>
@@ -4738,8 +4702,8 @@
         </p:nvSpPr>
         <p:spPr>
           <a:xfrm>
-            <a:off x="7772400" y="164592"/>
-            <a:ext cx="3886200" cy="320040"/>
+            <a:off x="7498079" y="164592"/>
+            <a:ext cx="4160520" cy="320040"/>
           </a:xfrm>
           <a:prstGeom prst="rect">
             <a:avLst/>
@@ -5007,7 +4971,7 @@
                 <a:latin typeface="Calibri"/>
                 <a:cs typeface="Calibri"/>
               </a:rPr>
-              <a:t>Proses penyewaan (rental) film secara manual membutuhkan pencatatan identitas pelanggan, pengecekan ketersediaan judul film, serta perhitungan biaya dan denda yang rentan mengalami kesalahan hitung.</a:t>
+              <a:t>Proses penyewaan film secara manual membutuhkan pencatatan data pelanggan, pemilihan film yang tersedia, serta perhitungan biaya sewa dan denda keterlambatan secara terstruktur.</a:t>
             </a:r>
           </a:p>
           <a:p>
@@ -5025,7 +4989,7 @@
                 <a:latin typeface="Calibri"/>
                 <a:cs typeface="Calibri"/>
               </a:rPr>
-              <a:t>Sering terjadi kekeliruan saat menentukan apakah pengembalian film berstatus TEPAT WAKTU atau TERLAMBAT beserta akumulasi denda hariannya.</a:t>
+              <a:t>Selain itu, pelanggan terkadang membutuhkan perpanjangan masa sewa sebelum mengembalikan film.</a:t>
             </a:r>
           </a:p>
           <a:p>
@@ -5043,7 +5007,7 @@
                 <a:latin typeface="Calibri"/>
                 <a:cs typeface="Calibri"/>
               </a:rPr>
-              <a:t>Oleh karena itu, dibangun program Sistem Rental Film berbasis bahasa C yang terstruktur untuk mengotomatisasi proses pencatatan, validasi input, perhitungan biaya sewa dan denda, hingga pencetakan bukti transaksi.</a:t>
+              <a:t>Oleh karena itu, dibuat program sederhana menggunakan bahasa C untuk membantu proses transaksi rental film mulai dari validasi ketersediaan film hingga pencetakan bukti rental.</a:t>
             </a:r>
           </a:p>
         </p:txBody>
@@ -5177,7 +5141,7 @@
                 <a:latin typeface="Calibri"/>
                 <a:cs typeface="Calibri"/>
               </a:rPr>
-              <a:t>1. Bagaimana merancang dan membangun program Sistem Rental Film menggunakan bahasa C?</a:t>
+              <a:t>1. Bagaimana membuat program Sistem Rental Film menggunakan bahasa C?</a:t>
             </a:r>
           </a:p>
           <a:p>
@@ -5195,7 +5159,7 @@
                 <a:latin typeface="Calibri"/>
                 <a:cs typeface="Calibri"/>
               </a:rPr>
-              <a:t>2. Bagaimana melakukan input data pelanggan serta validasi pilihan film menggunakan perulangan do-while?</a:t>
+              <a:t>2. Bagaimana melakukan input data pelanggan serta validasi pilihan dan ketersediaan stok film menggunakan do-while?</a:t>
             </a:r>
           </a:p>
           <a:p>
@@ -5213,7 +5177,7 @@
                 <a:latin typeface="Calibri"/>
                 <a:cs typeface="Calibri"/>
               </a:rPr>
-              <a:t>3. Bagaimana menentukan biaya sewa, menghitung lama peminjaman, menghitung denda keterlambatan, dan menentukan status pengembalian menggunakan if-else dan perulangan?</a:t>
+              <a:t>3. Bagaimana menentukan biaya sewa, perpanjangan lama peminjaman, denda keterlambatan (Rp2.000/hari), dan status pengembalian menggunakan if-else?</a:t>
             </a:r>
           </a:p>
           <a:p>
@@ -5231,7 +5195,7 @@
                 <a:latin typeface="Calibri"/>
                 <a:cs typeface="Calibri"/>
               </a:rPr>
-              <a:t>4. Bagaimana menampilkan bukti rental, memperbarui status film, serta menguji skenario peminjaman tepat waktu dan terlambat?</a:t>
+              <a:t>4. Bagaimana menampilkan bukti rental lengkap serta menguji skenario peminjaman tepat waktu dan terlambat?</a:t>
             </a:r>
           </a:p>
         </p:txBody>
@@ -5409,8 +5373,8 @@
         </p:nvSpPr>
         <p:spPr>
           <a:xfrm>
-            <a:off x="7772400" y="164592"/>
-            <a:ext cx="3886200" cy="320040"/>
+            <a:off x="7498079" y="164592"/>
+            <a:ext cx="4160520" cy="320040"/>
           </a:xfrm>
           <a:prstGeom prst="rect">
             <a:avLst/>
@@ -5678,7 +5642,7 @@
                 <a:latin typeface="Calibri"/>
                 <a:cs typeface="Calibri"/>
               </a:rPr>
-              <a:t>1. Membuat program Sistem Rental Film yang fungsional menggunakan bahasa pemrograman C.</a:t>
+              <a:t>1. Membuat program Sistem Rental Film menggunakan bahasa C.</a:t>
             </a:r>
           </a:p>
           <a:p>
@@ -5696,7 +5660,7 @@
                 <a:latin typeface="Calibri"/>
                 <a:cs typeface="Calibri"/>
               </a:rPr>
-              <a:t>2. Menerapkan struktur percabangan if dan if-else untuk penentuan tarif film, status pengembalian, dan denda.</a:t>
+              <a:t>2. Menerapkan struktur percabangan if, if-else, dan switch-case.</a:t>
             </a:r>
           </a:p>
           <a:p>
@@ -5714,7 +5678,7 @@
                 <a:latin typeface="Calibri"/>
                 <a:cs typeface="Calibri"/>
               </a:rPr>
-              <a:t>3. Menerapkan struktur perulangan while, do-while, dan for sesuai fungsinya masing-masing.</a:t>
+              <a:t>3. Menerapkan struktur perulangan do-while untuk validasi input pilihan film.</a:t>
             </a:r>
           </a:p>
           <a:p>
@@ -5732,7 +5696,7 @@
                 <a:latin typeface="Calibri"/>
                 <a:cs typeface="Calibri"/>
               </a:rPr>
-              <a:t>4. Menerapkan validasi input agar program tahan terhadap masukan yang tidak valid.</a:t>
+              <a:t>4. Menghitung biaya sewa, perpanjangan durasi, dan denda keterlambatan secara tepat.</a:t>
             </a:r>
           </a:p>
           <a:p>
@@ -5750,7 +5714,7 @@
                 <a:latin typeface="Calibri"/>
                 <a:cs typeface="Calibri"/>
               </a:rPr>
-              <a:t>5. Mengembangkan kemampuan pembagian tugas dan integrasi kode dalam kerja kelompok.</a:t>
+              <a:t>5. Mengembangkan kemampuan bekerja sama dan integrasi kode dalam kelompok.</a:t>
             </a:r>
           </a:p>
         </p:txBody>
@@ -5884,7 +5848,7 @@
                 <a:latin typeface="Calibri"/>
                 <a:cs typeface="Calibri"/>
               </a:rPr>
-              <a:t>Program dibuat menggunakan bahasa pemrograman C (Standard Library stdio.h).</a:t>
+              <a:t>Program dibuat menggunakan bahasa C (&lt;stdio.h&gt; dan &lt;string.h&gt;).</a:t>
             </a:r>
           </a:p>
           <a:p>
@@ -5902,7 +5866,7 @@
                 <a:latin typeface="Calibri"/>
                 <a:cs typeface="Calibri"/>
               </a:rPr>
-              <a:t>Program TIDAK menggunakan array data untuk menyimpan daftar film maupun transaksi.</a:t>
+              <a:t>Program TIDAK menggunakan array untuk menyimpan daftar film (menggunakan #define konstanta).</a:t>
             </a:r>
           </a:p>
           <a:p>
@@ -5920,7 +5884,7 @@
                 <a:latin typeface="Calibri"/>
                 <a:cs typeface="Calibri"/>
               </a:rPr>
-              <a:t>Program TIDAK menggunakan struct ataupun konsep Object-Oriented Programming (OOP).</a:t>
+              <a:t>Program TIDAK menggunakan struct maupun konsep OOP.</a:t>
             </a:r>
           </a:p>
           <a:p>
@@ -5938,7 +5902,7 @@
                 <a:latin typeface="Calibri"/>
                 <a:cs typeface="Calibri"/>
               </a:rPr>
-              <a:t>Program TIDAK menggunakan pointer (*).</a:t>
+              <a:t>Program TIDAK menggunakan pointer.</a:t>
             </a:r>
           </a:p>
           <a:p>
@@ -5956,7 +5920,7 @@
                 <a:latin typeface="Calibri"/>
                 <a:cs typeface="Calibri"/>
               </a:rPr>
-              <a:t>Struktur kontrol yang digunakan dibatasi pada: if, if-else, while, do-while, dan for.</a:t>
+              <a:t>Struktur kontrol yang digunakan adalah do-while, switch-case, if, dan if-else.</a:t>
             </a:r>
           </a:p>
           <a:p>
@@ -5974,7 +5938,7 @@
                 <a:latin typeface="Calibri"/>
                 <a:cs typeface="Calibri"/>
               </a:rPr>
-              <a:t>Data ketersediaan film dan transaksi hanya disimpan selama program berjalan (in-memory).</a:t>
+              <a:t>Denda keterlambatan ditetapkan sebesar Rp2.000 per hari keterlambatan.</a:t>
             </a:r>
           </a:p>
         </p:txBody>
@@ -6152,8 +6116,8 @@
         </p:nvSpPr>
         <p:spPr>
           <a:xfrm>
-            <a:off x="7772400" y="164592"/>
-            <a:ext cx="3886200" cy="320040"/>
+            <a:off x="7498079" y="164592"/>
+            <a:ext cx="4160520" cy="320040"/>
           </a:xfrm>
           <a:prstGeom prst="rect">
             <a:avLst/>
@@ -6421,7 +6385,7 @@
                 <a:latin typeface="Calibri"/>
                 <a:cs typeface="Calibri"/>
               </a:rPr>
-              <a:t>Program dimulai dengan menampilkan menu utama, lalu menerima input ID dan Nama Pelanggan. Selanjutnya program menampilkan 5 pilihan film beserta harga sewa per hari dan statusnya (Tersedia/Dipinjam), lalu memvalidasi pilihan pelanggan menggunakan do-while. Pelanggan memasukkan durasi sewa (1-7 hari) dan lama peminjaman aktual. Program menghitung biaya sewa, menentukan status pengembalian (TEPAT WAKTU / TERLAMBAT) dengan if-else, menghitung denda keterlambatan bertingkat dengan perulangan for, memvalidasi uang pembayaran, dan mencetak Bukti Rental Film.</a:t>
+              <a:t>Program dimulai dengan menerima input ID dan nama pelanggan, lalu menampilkan daftar 5 film beserta biaya/hari dan status ketersediaannya (Tersedia/Dipinjam). Pelanggan memilih nomor film (1-5) dan program memvalidasi pilihan menggunakan do-while &amp; switch-case (jika stok = 0 seperti Interstellar, pelanggan diminta memilih ulang). Selanjutnya pelanggan memasukkan lama peminjaman, opsi perpanjangan (y/n), dan hari pengembalian. Program menghitung biaya sewa, mengecek keterlambatan (if-else) dengan denda Rp2.000/hari, lalu mencetak Bukti Rental.</a:t>
             </a:r>
           </a:p>
         </p:txBody>
@@ -6555,7 +6519,7 @@
                 <a:latin typeface="Calibri"/>
                 <a:cs typeface="Calibri"/>
               </a:rPr>
-              <a:t>ID Pelanggan</a:t>
+              <a:t>ID Pelanggan (id)</a:t>
             </a:r>
           </a:p>
           <a:p>
@@ -6573,7 +6537,7 @@
                 <a:latin typeface="Calibri"/>
                 <a:cs typeface="Calibri"/>
               </a:rPr>
-              <a:t>Nama Pelanggan</a:t>
+              <a:t>Nama Pelanggan (nama)</a:t>
             </a:r>
           </a:p>
           <a:p>
@@ -6591,7 +6555,7 @@
                 <a:latin typeface="Calibri"/>
                 <a:cs typeface="Calibri"/>
               </a:rPr>
-              <a:t>Pilihan Nomor Film (1-5)</a:t>
+              <a:t>Pilihan Nomor Film 1-5 (pilih)</a:t>
             </a:r>
           </a:p>
           <a:p>
@@ -6609,7 +6573,7 @@
                 <a:latin typeface="Calibri"/>
                 <a:cs typeface="Calibri"/>
               </a:rPr>
-              <a:t>Durasi Sewa (1-7 hari)</a:t>
+              <a:t>Lama Peminjaman Awal (lama)</a:t>
             </a:r>
           </a:p>
           <a:p>
@@ -6627,7 +6591,7 @@
                 <a:latin typeface="Calibri"/>
                 <a:cs typeface="Calibri"/>
               </a:rPr>
-              <a:t>Lama Peminjaman Aktual (hari)</a:t>
+              <a:t>Opsi Perpanjang y/n (jawab &amp; tambah)</a:t>
             </a:r>
           </a:p>
           <a:p>
@@ -6645,7 +6609,7 @@
                 <a:latin typeface="Calibri"/>
                 <a:cs typeface="Calibri"/>
               </a:rPr>
-              <a:t>Jumlah Uang Pembayaran (Rp)</a:t>
+              <a:t>Hari Pengembalian Film (hariKembali)</a:t>
             </a:r>
           </a:p>
         </p:txBody>
@@ -6779,7 +6743,7 @@
                 <a:latin typeface="Calibri"/>
                 <a:cs typeface="Calibri"/>
               </a:rPr>
-              <a:t>Validasi pilihan film &amp; ketersediaan (do-while)</a:t>
+              <a:t>Validasi nomor film &amp; cek STOK (do-while &amp; switch)</a:t>
             </a:r>
           </a:p>
           <a:p>
@@ -6797,7 +6761,7 @@
                 <a:latin typeface="Calibri"/>
                 <a:cs typeface="Calibri"/>
               </a:rPr>
-              <a:t>Menentukan harga sewa film (if-else)</a:t>
+              <a:t>Menentukan judul &amp; harga film terpilih</a:t>
             </a:r>
           </a:p>
           <a:p>
@@ -6815,7 +6779,7 @@
                 <a:latin typeface="Calibri"/>
                 <a:cs typeface="Calibri"/>
               </a:rPr>
-              <a:t>Menghitung biaya sewa = harga x durasi</a:t>
+              <a:t>Menambah lama pinjam jika diperpanjang (if)</a:t>
             </a:r>
           </a:p>
           <a:p>
@@ -6833,7 +6797,7 @@
                 <a:latin typeface="Calibri"/>
                 <a:cs typeface="Calibri"/>
               </a:rPr>
-              <a:t>Menentukan status kembali &amp; hari telat (if-else)</a:t>
+              <a:t>Menghitung biaya = harga * lama</a:t>
             </a:r>
           </a:p>
           <a:p>
@@ -6851,7 +6815,7 @@
                 <a:latin typeface="Calibri"/>
                 <a:cs typeface="Calibri"/>
               </a:rPr>
-              <a:t>Menghitung denda bertingkat per hari (for)</a:t>
+              <a:t>Cek hariKembali &gt; lama (if-else)</a:t>
             </a:r>
           </a:p>
           <a:p>
@@ -6869,7 +6833,7 @@
                 <a:latin typeface="Calibri"/>
                 <a:cs typeface="Calibri"/>
               </a:rPr>
-              <a:t>Menghitung total bayar &amp; kembalian</a:t>
+              <a:t>Hitung denda = (hariKembali - lama) * 2000</a:t>
             </a:r>
           </a:p>
         </p:txBody>
@@ -7003,7 +6967,7 @@
                 <a:latin typeface="Calibri"/>
                 <a:cs typeface="Calibri"/>
               </a:rPr>
-              <a:t>Tabel Daftar &amp; Status Ketersediaan Film</a:t>
+              <a:t>Tabel Daftar Film (No, Nama, Biaya/Hari, Status)</a:t>
             </a:r>
           </a:p>
           <a:p>
@@ -7021,7 +6985,7 @@
                 <a:latin typeface="Calibri"/>
                 <a:cs typeface="Calibri"/>
               </a:rPr>
-              <a:t>Bukti Rental Film (ID, Nama, Judul Film)</a:t>
+              <a:t>Konfirmasi Film Terpilih &amp; Harga/Hari</a:t>
             </a:r>
           </a:p>
           <a:p>
@@ -7039,7 +7003,7 @@
                 <a:latin typeface="Calibri"/>
                 <a:cs typeface="Calibri"/>
               </a:rPr>
-              <a:t>Rincian Biaya Sewa &amp; Denda Keterlambatan</a:t>
+              <a:t>Bukti Rental: ID / Nama Pelanggan, Judul Film</a:t>
             </a:r>
           </a:p>
           <a:p>
@@ -7057,7 +7021,7 @@
                 <a:latin typeface="Calibri"/>
                 <a:cs typeface="Calibri"/>
               </a:rPr>
-              <a:t>Total Pembayaran &amp; Uang Kembalian</a:t>
+              <a:t>Lama Pinjam &amp; Hari Dikembalikan</a:t>
             </a:r>
           </a:p>
           <a:p>
@@ -7075,7 +7039,7 @@
                 <a:latin typeface="Calibri"/>
                 <a:cs typeface="Calibri"/>
               </a:rPr>
-              <a:t>Status Pengembalian (TEPAT WAKTU / TERLAMBAT)</a:t>
+              <a:t>Biaya Sewa, Denda, &amp; Total Bayar (biaya + denda)</a:t>
             </a:r>
           </a:p>
           <a:p>
@@ -7093,7 +7057,7 @@
                 <a:latin typeface="Calibri"/>
                 <a:cs typeface="Calibri"/>
               </a:rPr>
-              <a:t>Status Film Terbaru (Dipinjam / Tersedia)</a:t>
+              <a:t>Status Pengembalian (Tepat waktu / Terlambat)</a:t>
             </a:r>
           </a:p>
         </p:txBody>
@@ -7271,8 +7235,8 @@
         </p:nvSpPr>
         <p:spPr>
           <a:xfrm>
-            <a:off x="7772400" y="164592"/>
-            <a:ext cx="3886200" cy="320040"/>
+            <a:off x="7498079" y="164592"/>
+            <a:ext cx="4160520" cy="320040"/>
           </a:xfrm>
           <a:prstGeom prst="rect">
             <a:avLst/>
@@ -7498,7 +7462,7 @@
                 <a:latin typeface="Calibri"/>
                 <a:cs typeface="Calibri"/>
               </a:rPr>
-              <a:t>Algoritma Bagian 1: Input &amp; Validasi (Mahasiswa 1 &amp; 2)</a:t>
+              <a:t>Algoritma Bagian 1: Data Pelanggan &amp; Validasi Film</a:t>
             </a:r>
           </a:p>
         </p:txBody>
@@ -7558,7 +7522,7 @@
                 <a:latin typeface="Consolas"/>
                 <a:cs typeface="Consolas"/>
               </a:rPr>
-              <a:t>  Ulangi (do-while transaksi):</a:t>
+              <a:t>  Input id pelanggan dan nama pelanggan</a:t>
             </a:r>
           </a:p>
           <a:p>
@@ -7576,7 +7540,7 @@
                 <a:latin typeface="Consolas"/>
                 <a:cs typeface="Consolas"/>
               </a:rPr>
-              <a:t>    Input idPelanggan dan namaPelanggan</a:t>
+              <a:t>  Tampilkan tabel 5 film (JUDUL1..5, HARGA1..5, STOK1..5)</a:t>
             </a:r>
           </a:p>
           <a:p>
@@ -7594,7 +7558,7 @@
                 <a:latin typeface="Consolas"/>
                 <a:cs typeface="Consolas"/>
               </a:rPr>
-              <a:t>    Tampilkan daftar 5 film beserta harga &amp; status</a:t>
+              <a:t>  Ulangi (do-while !valid):</a:t>
             </a:r>
           </a:p>
           <a:p>
@@ -7612,7 +7576,7 @@
                 <a:latin typeface="Consolas"/>
                 <a:cs typeface="Consolas"/>
               </a:rPr>
-              <a:t>    Ulangi (do-while validasi film):</a:t>
+              <a:t>    valid = 0</a:t>
             </a:r>
           </a:p>
           <a:p>
@@ -7630,7 +7594,7 @@
                 <a:latin typeface="Consolas"/>
                 <a:cs typeface="Consolas"/>
               </a:rPr>
-              <a:t>      Input pilihanFilm (1..5)</a:t>
+              <a:t>    Input pilih (nomor film 1-5)</a:t>
             </a:r>
           </a:p>
           <a:p>
@@ -7648,7 +7612,7 @@
                 <a:latin typeface="Consolas"/>
                 <a:cs typeface="Consolas"/>
               </a:rPr>
-              <a:t>      Jika pilihanFilm &lt; 1 atau &gt; 5 atau status == Dipinjam:</a:t>
+              <a:t>    Pilih kasus (switch pilih):</a:t>
             </a:r>
           </a:p>
           <a:p>
@@ -7666,7 +7630,7 @@
                 <a:latin typeface="Consolas"/>
                 <a:cs typeface="Consolas"/>
               </a:rPr>
-              <a:t>        Tampilkan pesan kesalahan</a:t>
+              <a:t>      Kasus 1..5:</a:t>
             </a:r>
           </a:p>
           <a:p>
@@ -7684,7 +7648,7 @@
                 <a:latin typeface="Consolas"/>
                 <a:cs typeface="Consolas"/>
               </a:rPr>
-              <a:t>    Selama pilihanFilm tidak valid</a:t>
+              <a:t>        Jika STOK tersedia Maka:</a:t>
             </a:r>
           </a:p>
           <a:p>
@@ -7702,7 +7666,7 @@
                 <a:latin typeface="Consolas"/>
                 <a:cs typeface="Consolas"/>
               </a:rPr>
-              <a:t>    Input durasiSewa (validasi 1..7 hari dengan do-while)</a:t>
+              <a:t>          Salin judul film &amp; simpan harga; valid = 1</a:t>
             </a:r>
           </a:p>
           <a:p>
@@ -7720,7 +7684,7 @@
                 <a:latin typeface="Consolas"/>
                 <a:cs typeface="Consolas"/>
               </a:rPr>
-              <a:t>    Ubah status film terpilih menjadi Dipinjam (0)</a:t>
+              <a:t>        Jika tidak:</a:t>
             </a:r>
           </a:p>
           <a:p>
@@ -7738,7 +7702,43 @@
                 <a:latin typeface="Consolas"/>
                 <a:cs typeface="Consolas"/>
               </a:rPr>
-              <a:t>    Input lamaPinjam aktual (minimal 1 hari)</a:t>
+              <a:t>          Tampilkan 'Film sedang dipinjam, pilih yang lain!'</a:t>
+            </a:r>
+          </a:p>
+          <a:p>
+            <a:pPr algn="l">
+              <a:spcAft>
+                <a:spcPts val="400"/>
+              </a:spcAft>
+              <a:buNone/>
+            </a:pPr>
+            <a:r>
+              <a:rPr lang="id-ID" sz="1100" b="0" i="0" dirty="0">
+                <a:solidFill>
+                  <a:srgbClr val="1E293B"/>
+                </a:solidFill>
+                <a:latin typeface="Consolas"/>
+                <a:cs typeface="Consolas"/>
+              </a:rPr>
+              <a:t>      Default: Tampilkan 'Nomor tidak valid, ulangi!'</a:t>
+            </a:r>
+          </a:p>
+          <a:p>
+            <a:pPr algn="l">
+              <a:spcAft>
+                <a:spcPts val="400"/>
+              </a:spcAft>
+              <a:buNone/>
+            </a:pPr>
+            <a:r>
+              <a:rPr lang="id-ID" sz="1100" b="0" i="0" dirty="0">
+                <a:solidFill>
+                  <a:srgbClr val="1E293B"/>
+                </a:solidFill>
+                <a:latin typeface="Consolas"/>
+                <a:cs typeface="Consolas"/>
+              </a:rPr>
+              <a:t>  Selama valid == 0</a:t>
             </a:r>
           </a:p>
         </p:txBody>
@@ -7830,7 +7830,7 @@
                 <a:latin typeface="Calibri"/>
                 <a:cs typeface="Calibri"/>
               </a:rPr>
-              <a:t>Algoritma Bagian 2: Perhitungan &amp; Output (Mahasiswa 2 &amp; 3)</a:t>
+              <a:t>Algoritma Bagian 2: Proses Sewa, Denda, &amp; Bukti Rental</a:t>
             </a:r>
           </a:p>
         </p:txBody>
@@ -7872,7 +7872,7 @@
                 <a:latin typeface="Consolas"/>
                 <a:cs typeface="Consolas"/>
               </a:rPr>
-              <a:t>    Tentukan hargaPerHari berdasarkan pilihanFilm (if-else)</a:t>
+              <a:t>  Tampilkan judul film dan harga terpilih</a:t>
             </a:r>
           </a:p>
           <a:p>
@@ -7890,7 +7890,7 @@
                 <a:latin typeface="Consolas"/>
                 <a:cs typeface="Consolas"/>
               </a:rPr>
-              <a:t>    biayaSewa = hargaPerHari * durasiSewa</a:t>
+              <a:t>  Input lama peminjaman (hari)</a:t>
             </a:r>
           </a:p>
           <a:p>
@@ -7908,7 +7908,7 @@
                 <a:latin typeface="Consolas"/>
                 <a:cs typeface="Consolas"/>
               </a:rPr>
-              <a:t>    Jika lamaPinjam &gt; durasiSewa Maka:</a:t>
+              <a:t>  Input jawab ('Perpanjang peminjaman? y/n')</a:t>
             </a:r>
           </a:p>
           <a:p>
@@ -7926,7 +7926,7 @@
                 <a:latin typeface="Consolas"/>
                 <a:cs typeface="Consolas"/>
               </a:rPr>
-              <a:t>      hariTerlambat = lamaPinjam - durasiSewa</a:t>
+              <a:t>  Jika jawab == 'y' atau 'Y' Maka:</a:t>
             </a:r>
           </a:p>
           <a:p>
@@ -7944,7 +7944,7 @@
                 <a:latin typeface="Consolas"/>
                 <a:cs typeface="Consolas"/>
               </a:rPr>
-              <a:t>      status = TERLAMBAT</a:t>
+              <a:t>    Input tambah hari; lama = lama + tambah</a:t>
             </a:r>
           </a:p>
           <a:p>
@@ -7962,7 +7962,7 @@
                 <a:latin typeface="Consolas"/>
                 <a:cs typeface="Consolas"/>
               </a:rPr>
-              <a:t>      Untuk hariKe = 1 sampai hariTerlambat (for):</a:t>
+              <a:t>  Input hariKembali ('Film dikembalikan pada hari ke-')</a:t>
             </a:r>
           </a:p>
           <a:p>
@@ -7980,7 +7980,7 @@
                 <a:latin typeface="Consolas"/>
                 <a:cs typeface="Consolas"/>
               </a:rPr>
-              <a:t>        Jika hariKe &lt;= 3: denda += 5000</a:t>
+              <a:t>  biaya = harga * lama</a:t>
             </a:r>
           </a:p>
           <a:p>
@@ -7998,7 +7998,7 @@
                 <a:latin typeface="Consolas"/>
                 <a:cs typeface="Consolas"/>
               </a:rPr>
-              <a:t>        Selain itu      : denda += 10000</a:t>
+              <a:t>  Jika hariKembali &gt; lama Maka:</a:t>
             </a:r>
           </a:p>
           <a:p>
@@ -8016,7 +8016,7 @@
                 <a:latin typeface="Consolas"/>
                 <a:cs typeface="Consolas"/>
               </a:rPr>
-              <a:t>    Selain itu: hariTerlambat = 0, denda = 0, status = TEPAT WAKTU</a:t>
+              <a:t>    denda = (hariKembali - lama) * 2000</a:t>
             </a:r>
           </a:p>
           <a:p>
@@ -8034,7 +8034,7 @@
                 <a:latin typeface="Consolas"/>
                 <a:cs typeface="Consolas"/>
               </a:rPr>
-              <a:t>    totalBayar = biayaSewa + denda</a:t>
+              <a:t>    status = 'Terlambat'</a:t>
             </a:r>
           </a:p>
           <a:p>
@@ -8052,7 +8052,7 @@
                 <a:latin typeface="Consolas"/>
                 <a:cs typeface="Consolas"/>
               </a:rPr>
-              <a:t>    Input uangBayar (do-while uangBayar &gt;= totalBayar)</a:t>
+              <a:t>  Selain itu:</a:t>
             </a:r>
           </a:p>
           <a:p>
@@ -8070,7 +8070,7 @@
                 <a:latin typeface="Consolas"/>
                 <a:cs typeface="Consolas"/>
               </a:rPr>
-              <a:t>    kembalian = uangBayar - totalBayar; Status Film = Tersedia</a:t>
+              <a:t>    denda = 0; status = 'Tepat waktu'</a:t>
             </a:r>
           </a:p>
           <a:p>
@@ -8088,7 +8088,7 @@
                 <a:latin typeface="Consolas"/>
                 <a:cs typeface="Consolas"/>
               </a:rPr>
-              <a:t>    Tampilkan Bukti Rental &amp; Status Film; Tanya transaksi lagi</a:t>
+              <a:t>  Tampilkan Bukti Rental (biaya, denda, total, status)</a:t>
             </a:r>
           </a:p>
           <a:p>
@@ -8284,8 +8284,8 @@
         </p:nvSpPr>
         <p:spPr>
           <a:xfrm>
-            <a:off x="7772400" y="164592"/>
-            <a:ext cx="3886200" cy="320040"/>
+            <a:off x="7498079" y="164592"/>
+            <a:ext cx="4160520" cy="320040"/>
           </a:xfrm>
           <a:prstGeom prst="rect">
             <a:avLst/>
@@ -8313,7 +8313,7 @@
                 <a:latin typeface="Calibri"/>
                 <a:cs typeface="Calibri"/>
               </a:rPr>
-              <a:t>2.4 Alur Eksekusi: Mulai -&gt; Input -&gt; Validasi -&gt; Proses -&gt; Perhitungan -&gt; Output -&gt; Pengulangan -&gt; Selesai</a:t>
+              <a:t>2.4 Alur: Mulai -&gt; Input -&gt; Validasi (do-while) -&gt; Perpanjangan -&gt; Perhitungan -&gt; Output -&gt; Selesai</a:t>
             </a:r>
           </a:p>
         </p:txBody>
@@ -8511,7 +8511,7 @@
                 <a:latin typeface="Calibri"/>
                 <a:cs typeface="Calibri"/>
               </a:rPr>
-              <a:t>1. MULAI</a:t>
+              <a:t>1. MULAI &amp; INPUT</a:t>
             </a:r>
           </a:p>
         </p:txBody>
@@ -8553,9 +8553,9 @@
                 <a:latin typeface="Calibri"/>
                 <a:cs typeface="Calibri"/>
               </a:rPr>
-              <a:t>Tampilkan Menu Utama
-(1. Transaksi, 2. Daftar Film,
-3. Pengujian, 0. Keluar)</a:t>
+              <a:t>Input ID (id) &amp;
+Nama Pelanggan (nama);
+Tampilkan Daftar 5 Film</a:t>
             </a:r>
           </a:p>
         </p:txBody>
@@ -8689,7 +8689,7 @@
                 <a:latin typeface="Calibri"/>
                 <a:cs typeface="Calibri"/>
               </a:rPr>
-              <a:t>2. INPUT DATA</a:t>
+              <a:t>2. PILIH FILM</a:t>
             </a:r>
           </a:p>
         </p:txBody>
@@ -8731,9 +8731,9 @@
                 <a:latin typeface="Calibri"/>
                 <a:cs typeface="Calibri"/>
               </a:rPr>
-              <a:t>Masukkan ID Pelanggan &amp;
-Nama Pelanggan;
-Tampilkan 5 Pilihan Film</a:t>
+              <a:t>Masukkan Nomor Film
+(pilih 1-5) di dalam
+perulangan do-while</a:t>
             </a:r>
           </a:p>
         </p:txBody>
@@ -8867,7 +8867,7 @@
                 <a:latin typeface="Calibri"/>
                 <a:cs typeface="Calibri"/>
               </a:rPr>
-              <a:t>3. VALIDASI (do-while)</a:t>
+              <a:t>3. VALIDASI STOK</a:t>
             </a:r>
           </a:p>
         </p:txBody>
@@ -8909,9 +8909,9 @@
                 <a:latin typeface="Calibri"/>
                 <a:cs typeface="Calibri"/>
               </a:rPr>
-              <a:t>Input Pilihan Film (1-5)
-&amp; Durasi Sewa (1-7 hari).
-Valid &amp; Tersedia?</a:t>
+              <a:t>Cek switch(pilih) &amp; STOK:
+Jika valid &amp; tersedia -&gt; Lanjut
+Jika tidak -&gt; Ulangi input</a:t>
             </a:r>
           </a:p>
         </p:txBody>
@@ -9045,7 +9045,7 @@
                 <a:latin typeface="Calibri"/>
                 <a:cs typeface="Calibri"/>
               </a:rPr>
-              <a:t>4. PROSES PINJAM</a:t>
+              <a:t>4. LAMA PINJAM</a:t>
             </a:r>
           </a:p>
         </p:txBody>
@@ -9087,9 +9087,9 @@
                 <a:latin typeface="Calibri"/>
                 <a:cs typeface="Calibri"/>
               </a:rPr>
-              <a:t>Set Status Film = Dipinjam;
-Input Lama Peminjaman
-Aktual (hari)</a:t>
+              <a:t>Input lama peminjaman;
+Tanya Perpanjang? (y/n)
+Jika 'y': lama += tambah</a:t>
             </a:r>
           </a:p>
         </p:txBody>
@@ -9179,7 +9179,7 @@
             </a:avLst>
           </a:prstGeom>
           <a:solidFill>
-            <a:srgbClr val="DC2626"/>
+            <a:srgbClr val="0284C7"/>
           </a:solidFill>
           <a:ln>
             <a:noFill/>
@@ -9223,7 +9223,7 @@
                 <a:latin typeface="Calibri"/>
                 <a:cs typeface="Calibri"/>
               </a:rPr>
-              <a:t>5. PERHITUNGAN</a:t>
+              <a:t>5. HARI KEMBALI</a:t>
             </a:r>
           </a:p>
         </p:txBody>
@@ -9265,9 +9265,8 @@
                 <a:latin typeface="Calibri"/>
                 <a:cs typeface="Calibri"/>
               </a:rPr>
-              <a:t>Hitung Biaya Sewa;
-Cek Lama &gt; Durasi (if-else);
-Hitung Denda Bertingkat (for)</a:t>
+              <a:t>Input hariKembali;
+Hitung biaya = harga * lama</a:t>
             </a:r>
           </a:p>
         </p:txBody>
@@ -9357,7 +9356,7 @@
             </a:avLst>
           </a:prstGeom>
           <a:solidFill>
-            <a:srgbClr val="059669"/>
+            <a:srgbClr val="DC2626"/>
           </a:solidFill>
           <a:ln>
             <a:noFill/>
@@ -9401,7 +9400,7 @@
                 <a:latin typeface="Calibri"/>
                 <a:cs typeface="Calibri"/>
               </a:rPr>
-              <a:t>6. PEMBAYARAN</a:t>
+              <a:t>6. CEK TERLAMBAT</a:t>
             </a:r>
           </a:p>
         </p:txBody>
@@ -9443,9 +9442,9 @@
                 <a:latin typeface="Calibri"/>
                 <a:cs typeface="Calibri"/>
               </a:rPr>
-              <a:t>Hitung Total = Biaya + Denda;
-Validasi Uang Bayar &gt;= Total;
-Hitung Kembalian</a:t>
+              <a:t>Apakah hariKembali &gt; lama?
+Ya: denda=(hariKembali-lama)*2000
+Tidak: denda = 0</a:t>
             </a:r>
           </a:p>
         </p:txBody>
@@ -9535,7 +9534,7 @@
             </a:avLst>
           </a:prstGeom>
           <a:solidFill>
-            <a:srgbClr val="0284C7"/>
+            <a:srgbClr val="059669"/>
           </a:solidFill>
           <a:ln>
             <a:noFill/>
@@ -9579,7 +9578,7 @@
                 <a:latin typeface="Calibri"/>
                 <a:cs typeface="Calibri"/>
               </a:rPr>
-              <a:t>7. OUTPUT BUKTI</a:t>
+              <a:t>7. STATUS KEMBALI</a:t>
             </a:r>
           </a:p>
         </p:txBody>
@@ -9621,9 +9620,9 @@
                 <a:latin typeface="Calibri"/>
                 <a:cs typeface="Calibri"/>
               </a:rPr>
-              <a:t>Cetak Bukti Rental Lengkap;
-Kembalikan Status Film
-menjadi Tersedia</a:t>
+              <a:t>Ya -&gt; status = 'Terlambat'
+Tidak -&gt; status = 'Tepat waktu'
+Hitung Total = biaya + denda</a:t>
             </a:r>
           </a:p>
         </p:txBody>
@@ -9757,7 +9756,7 @@
                 <a:latin typeface="Calibri"/>
                 <a:cs typeface="Calibri"/>
               </a:rPr>
-              <a:t>8. PENGULANGAN / SELESAI</a:t>
+              <a:t>8. BUKTI &amp; SELESAI</a:t>
             </a:r>
           </a:p>
         </p:txBody>
@@ -9799,9 +9798,9 @@
                 <a:latin typeface="Calibri"/>
                 <a:cs typeface="Calibri"/>
               </a:rPr>
-              <a:t>Transaksi Lagi? (y/t)
-Jika 'y' kembali ke Input;
-Jika 't' -&gt; SELESAI</a:t>
+              <a:t>Cetak BUKTI RENTAL
+lengkap ke layar
+-&gt; SELESAI</a:t>
             </a:r>
           </a:p>
         </p:txBody>
@@ -9979,8 +9978,8 @@
         </p:nvSpPr>
         <p:spPr>
           <a:xfrm>
-            <a:off x="7772400" y="164592"/>
-            <a:ext cx="3886200" cy="320040"/>
+            <a:off x="7498079" y="164592"/>
+            <a:ext cx="4160520" cy="320040"/>
           </a:xfrm>
           <a:prstGeom prst="rect">
             <a:avLst/>
@@ -10248,7 +10247,7 @@
                 <a:latin typeface="Calibri"/>
                 <a:cs typeface="Calibri"/>
               </a:rPr>
-              <a:t>Bahasa Pemrograman : Bahasa C (Standard C99 / C11)</a:t>
+              <a:t>Bahasa Pemrograman : Bahasa C</a:t>
             </a:r>
           </a:p>
           <a:p>
@@ -10266,7 +10265,7 @@
                 <a:latin typeface="Calibri"/>
                 <a:cs typeface="Calibri"/>
               </a:rPr>
-              <a:t>Compiler           : GCC (MinGW-w64) via Terminal</a:t>
+              <a:t>Compiler / IDE     : GCC (MinGW) / Visual Studio Code</a:t>
             </a:r>
           </a:p>
           <a:p>
@@ -10284,7 +10283,7 @@
                 <a:latin typeface="Calibri"/>
                 <a:cs typeface="Calibri"/>
               </a:rPr>
-              <a:t>Perintah Kompilasi : gcc -Wall -Wextra -o rental_film.exe rental_film.c</a:t>
+              <a:t>Sistem Operasi     : Microsoft Windows 10 / 11</a:t>
             </a:r>
           </a:p>
           <a:p>
@@ -10302,7 +10301,7 @@
                 <a:latin typeface="Calibri"/>
                 <a:cs typeface="Calibri"/>
               </a:rPr>
-              <a:t>Sistem Operasi     : Microsoft Windows 10 / 11</a:t>
+              <a:t>Header Library     : &lt;stdio.h&gt; dan &lt;string.h&gt;</a:t>
             </a:r>
           </a:p>
           <a:p>
@@ -10320,25 +10319,7 @@
                 <a:latin typeface="Calibri"/>
                 <a:cs typeface="Calibri"/>
               </a:rPr>
-              <a:t>Text Editor / IDE  : Visual Studio Code</a:t>
-            </a:r>
-          </a:p>
-          <a:p>
-            <a:pPr algn="l" marL="228600" indent="-228600">
-              <a:spcAft>
-                <a:spcPts val="500"/>
-              </a:spcAft>
-              <a:buChar char="•"/>
-            </a:pPr>
-            <a:r>
-              <a:rPr lang="id-ID" sz="1300" b="0" i="0" dirty="0">
-                <a:solidFill>
-                  <a:srgbClr val="1E293B"/>
-                </a:solidFill>
-                <a:latin typeface="Calibri"/>
-                <a:cs typeface="Calibri"/>
-              </a:rPr>
-              <a:t>pustaka (Header)   : #include &lt;stdio.h&gt;</a:t>
+              <a:t>Konstanta Makro    : #define JUDUL1..5, HARGA1..5, STOK1..5, DENDA_PER_HARI 2000</a:t>
             </a:r>
           </a:p>
         </p:txBody>
@@ -10430,7 +10411,7 @@
                 <a:latin typeface="Calibri"/>
                 <a:cs typeface="Calibri"/>
               </a:rPr>
-              <a:t>3.2 Bagian-Bagian Utama Struktur Program</a:t>
+              <a:t>3.2 Struktur Bagian Utama Program</a:t>
             </a:r>
           </a:p>
         </p:txBody>
@@ -10472,7 +10453,7 @@
                 <a:latin typeface="Calibri"/>
                 <a:cs typeface="Calibri"/>
               </a:rPr>
-              <a:t>1. Bagian Input Pelanggan (inputDataPelanggan): Menerima ID dan Nama pelanggan.</a:t>
+              <a:t>1. Definisi Data Film (#define): Menyimpan judul, harga sewa, dan status stok 5 film serta tarif denda Rp2.000/hari.</a:t>
             </a:r>
           </a:p>
           <a:p>
@@ -10490,7 +10471,7 @@
                 <a:latin typeface="Calibri"/>
                 <a:cs typeface="Calibri"/>
               </a:rPr>
-              <a:t>2. Bagian Pemilihan &amp; Validasi Film (tampilkanDaftarFilm, inputDanValidasiFilm): Menampilkan 5 film dan memvalidasi pilihan dengan do-while.</a:t>
+              <a:t>2. Bagian Input Pelanggan (Mahasiswa 1): Menerima input ID pelanggan (int) dan Nama pelanggan (char[]).</a:t>
             </a:r>
           </a:p>
           <a:p>
@@ -10508,7 +10489,7 @@
                 <a:latin typeface="Calibri"/>
                 <a:cs typeface="Calibri"/>
               </a:rPr>
-              <a:t>3. Bagian Input Durasi &amp; Lama Pinjam (inputDurasiDanLamaPinjam): Menerima durasi sewa (1-7 hari) dan lama pinjam aktual.</a:t>
+              <a:t>3. Bagian Daftar &amp; Validasi Film (Mahasiswa 1): Menampilkan tabel 5 film dan memvalidasi pilihan dengan do-while &amp; switch-case.</a:t>
             </a:r>
           </a:p>
           <a:p>
@@ -10526,7 +10507,7 @@
                 <a:latin typeface="Calibri"/>
                 <a:cs typeface="Calibri"/>
               </a:rPr>
-              <a:t>4. Bagian Perhitungan Biaya &amp; Denda (hitungSewaDanDenda): Menghitung biaya sewa, mengecek keterlambatan (if-else), dan menghitung denda (for).</a:t>
+              <a:t>4. Bagian Lama Sewa &amp; Perpanjangan (Mahasiswa 2): Menerima lama pinjam dan opsi perpanjangan durasi (if jawab == 'y').</a:t>
             </a:r>
           </a:p>
           <a:p>
@@ -10544,7 +10525,7 @@
                 <a:latin typeface="Calibri"/>
                 <a:cs typeface="Calibri"/>
               </a:rPr>
-              <a:t>5. Bagian Pembayaran (prosesPembayaran): Memvalidasi uang bayar dan menghitung kembalian.</a:t>
+              <a:t>5. Bagian Perhitungan Biaya &amp; Denda (Mahasiswa 2): Menghitung biaya sewa dan mengecek keterlambatan (if-else hariKembali &gt; lama).</a:t>
             </a:r>
           </a:p>
           <a:p>
@@ -10562,25 +10543,7 @@
                 <a:latin typeface="Calibri"/>
                 <a:cs typeface="Calibri"/>
               </a:rPr>
-              <a:t>6. Bagian Output (tampilkanBuktiRental, tampilkanStatusSemuaFilm): Mencetak struk bukti rental dan status ketersediaan film.</a:t>
-            </a:r>
-          </a:p>
-          <a:p>
-            <a:pPr algn="l" marL="228600" indent="-228600">
-              <a:spcAft>
-                <a:spcPts val="500"/>
-              </a:spcAft>
-              <a:buChar char="•"/>
-            </a:pPr>
-            <a:r>
-              <a:rPr lang="id-ID" sz="1200" b="0" i="0" dirty="0">
-                <a:solidFill>
-                  <a:srgbClr val="1E293B"/>
-                </a:solidFill>
-                <a:latin typeface="Calibri"/>
-                <a:cs typeface="Calibri"/>
-              </a:rPr>
-              <a:t>7. Bagian Pengujian &amp; Pengulangan (pengujianOtomatis, main): Menguji kasus tepat waktu/terlambat dan mengulang transaksi.</a:t>
+              <a:t>6. Bagian Output Bukti Rental (Mahasiswa 3): Menampilkan struk bukti rental lengkap beserta total bayar dan status.</a:t>
             </a:r>
           </a:p>
         </p:txBody>
@@ -10758,8 +10721,8 @@
         </p:nvSpPr>
         <p:spPr>
           <a:xfrm>
-            <a:off x="7772400" y="164592"/>
-            <a:ext cx="3886200" cy="320040"/>
+            <a:off x="7498079" y="164592"/>
+            <a:ext cx="4160520" cy="320040"/>
           </a:xfrm>
           <a:prstGeom prst="rect">
             <a:avLst/>
@@ -11027,7 +10990,7 @@
                 <a:latin typeface="Consolas"/>
                 <a:cs typeface="Consolas"/>
               </a:rPr>
-              <a:t>/* Validasi pilihan film dengan do-while (Mhs 1) */</a:t>
+              <a:t>/* Validasi pilihan film (do-while &amp; switch) */</a:t>
             </a:r>
           </a:p>
           <a:p>
@@ -11063,7 +11026,7 @@
                 <a:latin typeface="Consolas"/>
                 <a:cs typeface="Consolas"/>
               </a:rPr>
-              <a:t>    printf("Pilih nomor film (1-5): ");</a:t>
+              <a:t>    valid = 0;</a:t>
             </a:r>
           </a:p>
           <a:p>
@@ -11081,7 +11044,7 @@
                 <a:latin typeface="Consolas"/>
                 <a:cs typeface="Consolas"/>
               </a:rPr>
-              <a:t>    hasilBaca = scanf("%d", &amp;pilihanFilm);</a:t>
+              <a:t>    printf("\nPilih nomor film (1-5): ");</a:t>
             </a:r>
           </a:p>
           <a:p>
@@ -11099,7 +11062,7 @@
                 <a:latin typeface="Consolas"/>
                 <a:cs typeface="Consolas"/>
               </a:rPr>
-              <a:t>    if (pilihanFilm &lt; 1 || pilihanFilm &gt; 5)</a:t>
+              <a:t>    scanf("%d", &amp;pilih);</a:t>
             </a:r>
           </a:p>
           <a:p>
@@ -11117,7 +11080,7 @@
                 <a:latin typeface="Consolas"/>
                 <a:cs typeface="Consolas"/>
               </a:rPr>
-              <a:t>        valid = 0;</a:t>
+              <a:t>    switch (pilih) {</a:t>
             </a:r>
           </a:p>
           <a:p>
@@ -11135,7 +11098,7 @@
                 <a:latin typeface="Consolas"/>
                 <a:cs typeface="Consolas"/>
               </a:rPr>
-              <a:t>    else if (cekFilmTersedia(pilihanFilm) == 0)</a:t>
+              <a:t>        case 1: if (STOK1) { strcpy(judul, JUDUL1);</a:t>
             </a:r>
           </a:p>
           <a:p>
@@ -11153,7 +11116,7 @@
                 <a:latin typeface="Consolas"/>
                 <a:cs typeface="Consolas"/>
               </a:rPr>
-              <a:t>        valid = 0;</a:t>
+              <a:t>                harga = HARGA1; valid = 1; }</a:t>
             </a:r>
           </a:p>
           <a:p>
@@ -11171,13 +11134,13 @@
                 <a:latin typeface="Consolas"/>
                 <a:cs typeface="Consolas"/>
               </a:rPr>
-              <a:t>    else valid = 1;</a:t>
-            </a:r>
-          </a:p>
-          <a:p>
-            <a:pPr algn="l">
-              <a:spcAft>
-                <a:spcPts val="600"/>
+              <a:t>                else printf("Film sedang dipinjam!\n"); break;</a:t>
+            </a:r>
+          </a:p>
+          <a:p>
+            <a:pPr algn="l">
+              <a:spcAft>
+                <a:spcPts val="400"/>
               </a:spcAft>
               <a:buNone/>
             </a:pPr>
@@ -11189,7 +11152,7 @@
                 <a:latin typeface="Consolas"/>
                 <a:cs typeface="Consolas"/>
               </a:rPr>
-              <a:t>} while (valid == 0);</a:t>
+              <a:t>        /* ... case 2 s/d 5 ... */</a:t>
             </a:r>
           </a:p>
           <a:p>
@@ -11202,18 +11165,18 @@
             <a:r>
               <a:rPr lang="id-ID" sz="1000" b="0" i="0" dirty="0">
                 <a:solidFill>
-                  <a:srgbClr val="059669"/>
+                  <a:srgbClr val="1E293B"/>
                 </a:solidFill>
                 <a:latin typeface="Consolas"/>
                 <a:cs typeface="Consolas"/>
               </a:rPr>
-              <a:t>/* Perhitungan denda dengan for &amp; if-else (Mhs 2) */</a:t>
-            </a:r>
-          </a:p>
-          <a:p>
-            <a:pPr algn="l">
-              <a:spcAft>
-                <a:spcPts val="400"/>
+              <a:t>    }</a:t>
+            </a:r>
+          </a:p>
+          <a:p>
+            <a:pPr algn="l">
+              <a:spcAft>
+                <a:spcPts val="600"/>
               </a:spcAft>
               <a:buNone/>
             </a:pPr>
@@ -11225,7 +11188,7 @@
                 <a:latin typeface="Consolas"/>
                 <a:cs typeface="Consolas"/>
               </a:rPr>
-              <a:t>denda = 0;</a:t>
+              <a:t>} while (!valid);</a:t>
             </a:r>
           </a:p>
           <a:p>
@@ -11238,12 +11201,12 @@
             <a:r>
               <a:rPr lang="id-ID" sz="1000" b="0" i="0" dirty="0">
                 <a:solidFill>
-                  <a:srgbClr val="1E293B"/>
+                  <a:srgbClr val="059669"/>
                 </a:solidFill>
                 <a:latin typeface="Consolas"/>
                 <a:cs typeface="Consolas"/>
               </a:rPr>
-              <a:t>for (hariKe = 1; hariKe &lt;= hariTerlambat; hariKe++) {</a:t>
+              <a:t>/* Perhitungan biaya &amp; denda (if-else) */</a:t>
             </a:r>
           </a:p>
           <a:p>
@@ -11261,7 +11224,7 @@
                 <a:latin typeface="Consolas"/>
                 <a:cs typeface="Consolas"/>
               </a:rPr>
-              <a:t>    if (hariKe &lt;= 3) denda = denda + 5000;</a:t>
+              <a:t>biaya = harga * lama;</a:t>
             </a:r>
           </a:p>
           <a:p>
@@ -11279,7 +11242,7 @@
                 <a:latin typeface="Consolas"/>
                 <a:cs typeface="Consolas"/>
               </a:rPr>
-              <a:t>    else             denda = denda + 10000;</a:t>
+              <a:t>if (hariKembali &gt; lama) {</a:t>
             </a:r>
           </a:p>
           <a:p>
@@ -11297,7 +11260,43 @@
                 <a:latin typeface="Consolas"/>
                 <a:cs typeface="Consolas"/>
               </a:rPr>
-              <a:t>}</a:t>
+              <a:t>    denda = (hariKembali - lama) * DENDA_PER_HARI;</a:t>
+            </a:r>
+          </a:p>
+          <a:p>
+            <a:pPr algn="l">
+              <a:spcAft>
+                <a:spcPts val="400"/>
+              </a:spcAft>
+              <a:buNone/>
+            </a:pPr>
+            <a:r>
+              <a:rPr lang="id-ID" sz="1000" b="0" i="0" dirty="0">
+                <a:solidFill>
+                  <a:srgbClr val="1E293B"/>
+                </a:solidFill>
+                <a:latin typeface="Consolas"/>
+                <a:cs typeface="Consolas"/>
+              </a:rPr>
+              <a:t>    strcpy(status, "Terlambat");</a:t>
+            </a:r>
+          </a:p>
+          <a:p>
+            <a:pPr algn="l">
+              <a:spcAft>
+                <a:spcPts val="400"/>
+              </a:spcAft>
+              <a:buNone/>
+            </a:pPr>
+            <a:r>
+              <a:rPr lang="id-ID" sz="1000" b="0" i="0" dirty="0">
+                <a:solidFill>
+                  <a:srgbClr val="1E293B"/>
+                </a:solidFill>
+                <a:latin typeface="Consolas"/>
+                <a:cs typeface="Consolas"/>
+              </a:rPr>
+              <a:t>} else { denda = 0; strcpy(status, "Tepat waktu"); }</a:t>
             </a:r>
           </a:p>
         </p:txBody>
@@ -11431,7 +11430,7 @@
                 <a:latin typeface="Calibri"/>
                 <a:cs typeface="Calibri"/>
               </a:rPr>
-              <a:t>if &amp; if-else : Memilih judul/harga film (1-5), menentukan status TEPAT WAKTU vs TERLAMBAT, serta membedakan tarif denda hari ke-1..3 (Rp 5.000) dan hari ke-4 dst (Rp 10.000).</a:t>
+              <a:t>if : Mengecek apakah pelanggan ingin memperpanjang lama peminjaman (jawab == 'y' || jawab == 'Y').</a:t>
             </a:r>
           </a:p>
           <a:p>
@@ -11449,7 +11448,7 @@
                 <a:latin typeface="Calibri"/>
                 <a:cs typeface="Calibri"/>
               </a:rPr>
-              <a:t>while : Digunakan pada fungsi bersihkanInput() untuk membuang sisa karakter newline di buffer stdin.</a:t>
+              <a:t>if-else : Mengecek ketersediaan stok film (STOK1..5) serta menentukan apakah pengembalian Terlambat (hariKembali &gt; lama) atau Tepat waktu.</a:t>
             </a:r>
           </a:p>
           <a:p>
@@ -11467,7 +11466,7 @@
                 <a:latin typeface="Calibri"/>
                 <a:cs typeface="Calibri"/>
               </a:rPr>
-              <a:t>do-while : Mengulang menu utama, perulangan transaksi, serta validasi input nomor film, durasi sewa, dan uang pembayaran.</a:t>
+              <a:t>switch-case : Memilih data film ke-1 sampai ke-5 berdasarkan nomor yang diinput pelanggan.</a:t>
             </a:r>
           </a:p>
           <a:p>
@@ -11485,7 +11484,7 @@
                 <a:latin typeface="Calibri"/>
                 <a:cs typeface="Calibri"/>
               </a:rPr>
-              <a:t>for : Mengakumulasi denda per hari keterlambatan dan menampilkan daftar status kelima film.</a:t>
+              <a:t>do-while : Mengulang input pemilihan film selama pilihan tidak valid atau film sedang dipinjam (!valid).</a:t>
             </a:r>
           </a:p>
           <a:p>
@@ -11503,7 +11502,7 @@
                 <a:latin typeface="Calibri"/>
                 <a:cs typeface="Calibri"/>
               </a:rPr>
-              <a:t>Variabel &amp; Operator : Menggunakan tipe int, long, char; operator aritmatika (*, +, -), relasional (&lt;, &gt;, &lt;=, ==), dan logika (||, &amp;&amp;).</a:t>
+              <a:t>Variabel &amp; Operator : Menggunakan tipe int dan char[]; operator aritmatika (*, +, -, +=), relasional (&gt;), logika (||, !), dan ternary (?:).</a:t>
             </a:r>
           </a:p>
           <a:p>
@@ -11521,7 +11520,7 @@
                 <a:latin typeface="Calibri"/>
                 <a:cs typeface="Calibri"/>
               </a:rPr>
-              <a:t>Input / Output : Menggunakan printf() dan scanf() dari &lt;stdio.h&gt;.</a:t>
+              <a:t>Input / Output : Menggunakan printf(), scanf(), dan strcpy().</a:t>
             </a:r>
           </a:p>
         </p:txBody>
@@ -11699,8 +11698,8 @@
         </p:nvSpPr>
         <p:spPr>
           <a:xfrm>
-            <a:off x="7772400" y="164592"/>
-            <a:ext cx="3886200" cy="320040"/>
+            <a:off x="7498079" y="164592"/>
+            <a:ext cx="4160520" cy="320040"/>
           </a:xfrm>
           <a:prstGeom prst="rect">
             <a:avLst/>
@@ -11986,7 +11985,7 @@
                 <a:latin typeface="Calibri"/>
                 <a:cs typeface="Calibri"/>
               </a:rPr>
-              <a:t>Tugas Utama:</a:t>
+              <a:t>Tugas:</a:t>
             </a:r>
           </a:p>
           <a:p>
@@ -12022,7 +12021,7 @@
                 <a:latin typeface="Calibri"/>
                 <a:cs typeface="Calibri"/>
               </a:rPr>
-              <a:t>• Menampilkan daftar pilihan film</a:t>
+              <a:t>• Menampilkan daftar 5 pilihan film</a:t>
             </a:r>
           </a:p>
           <a:p>
@@ -12058,7 +12057,7 @@
                 <a:latin typeface="Calibri"/>
                 <a:cs typeface="Calibri"/>
               </a:rPr>
-              <a:t>• Menerapkan perulangan do-while</a:t>
+              <a:t>• Menggunakan perulangan do-while</a:t>
             </a:r>
           </a:p>
           <a:p>
@@ -12076,7 +12075,7 @@
                 <a:latin typeface="Calibri"/>
                 <a:cs typeface="Calibri"/>
               </a:rPr>
-              <a:t>Fungsi yang Dikerjakan:</a:t>
+              <a:t>Bagian Kode:</a:t>
             </a:r>
           </a:p>
           <a:p>
@@ -12094,7 +12093,7 @@
                 <a:latin typeface="Calibri"/>
                 <a:cs typeface="Calibri"/>
               </a:rPr>
-              <a:t>• inputDataPelanggan()</a:t>
+              <a:t>• Konstanta #define JUDUL1..5, HARGA1..5, STOK1..5</a:t>
             </a:r>
           </a:p>
           <a:p>
@@ -12112,7 +12111,7 @@
                 <a:latin typeface="Calibri"/>
                 <a:cs typeface="Calibri"/>
               </a:rPr>
-              <a:t>• tampilkanDaftarFilm()</a:t>
+              <a:t>• Input id &amp; nama pelanggan</a:t>
             </a:r>
           </a:p>
           <a:p>
@@ -12130,7 +12129,7 @@
                 <a:latin typeface="Calibri"/>
                 <a:cs typeface="Calibri"/>
               </a:rPr>
-              <a:t>• inputDanValidasiFilm()</a:t>
+              <a:t>• Tabel daftar film &amp; blok do-while + switch(pilih)</a:t>
             </a:r>
           </a:p>
           <a:p>
@@ -12148,7 +12147,7 @@
                 <a:latin typeface="Calibri"/>
                 <a:cs typeface="Calibri"/>
               </a:rPr>
-              <a:t>Integrasi: Menyediakan data pelanggan &amp; film valid untuk diproses Mahasiswa 2.</a:t>
+              <a:t>Integrasi: Menyediakan variabel judul &amp; harga film terpilih untuk Mahasiswa 2.</a:t>
             </a:r>
           </a:p>
         </p:txBody>
@@ -12300,7 +12299,7 @@
                 <a:latin typeface="Calibri"/>
                 <a:cs typeface="Calibri"/>
               </a:rPr>
-              <a:t>Tugas Utama:</a:t>
+              <a:t>Tugas:</a:t>
             </a:r>
           </a:p>
           <a:p>
@@ -12318,7 +12317,7 @@
                 <a:latin typeface="Calibri"/>
                 <a:cs typeface="Calibri"/>
               </a:rPr>
-              <a:t>• Menentukan biaya sewa film</a:t>
+              <a:t>• Menentukan biaya sewa</a:t>
             </a:r>
           </a:p>
           <a:p>
@@ -12336,7 +12335,7 @@
                 <a:latin typeface="Calibri"/>
                 <a:cs typeface="Calibri"/>
               </a:rPr>
-              <a:t>• Menghitung lama peminjaman</a:t>
+              <a:t>• Menghitung lama peminjaman &amp; perpanjangan</a:t>
             </a:r>
           </a:p>
           <a:p>
@@ -12390,7 +12389,7 @@
                 <a:latin typeface="Calibri"/>
                 <a:cs typeface="Calibri"/>
               </a:rPr>
-              <a:t>• Menerapkan if-else &amp; perulangan for</a:t>
+              <a:t>Bagian Kode:</a:t>
             </a:r>
           </a:p>
           <a:p>
@@ -12408,7 +12407,7 @@
                 <a:latin typeface="Calibri"/>
                 <a:cs typeface="Calibri"/>
               </a:rPr>
-              <a:t>Fungsi yang Dikerjakan:</a:t>
+              <a:t>• Input lama &amp; perpanjangan (if jawab == 'y')</a:t>
             </a:r>
           </a:p>
           <a:p>
@@ -12426,7 +12425,7 @@
                 <a:latin typeface="Calibri"/>
                 <a:cs typeface="Calibri"/>
               </a:rPr>
-              <a:t>• inputDurasiDanLamaPinjam()</a:t>
+              <a:t>• Input hariKembali &amp; hitung biaya = harga * lama</a:t>
             </a:r>
           </a:p>
           <a:p>
@@ -12444,7 +12443,7 @@
                 <a:latin typeface="Calibri"/>
                 <a:cs typeface="Calibri"/>
               </a:rPr>
-              <a:t>• hitungSewaDanDenda()</a:t>
+              <a:t>• Blok if-else (hariKembali &gt; lama) untuk denda &amp; status</a:t>
             </a:r>
           </a:p>
           <a:p>
@@ -12462,25 +12461,7 @@
                 <a:latin typeface="Calibri"/>
                 <a:cs typeface="Calibri"/>
               </a:rPr>
-              <a:t>• prosesPembayaran()</a:t>
-            </a:r>
-          </a:p>
-          <a:p>
-            <a:pPr algn="l" marL="228600" indent="-228600">
-              <a:spcAft>
-                <a:spcPts val="500"/>
-              </a:spcAft>
-              <a:buChar char="•"/>
-            </a:pPr>
-            <a:r>
-              <a:rPr lang="id-ID" sz="1100" b="0" i="0" dirty="0">
-                <a:solidFill>
-                  <a:srgbClr val="1E293B"/>
-                </a:solidFill>
-                <a:latin typeface="Calibri"/>
-                <a:cs typeface="Calibri"/>
-              </a:rPr>
-              <a:t>Integrasi: Mengolah biaya, denda, &amp; status untuk dicetak Mahasiswa 3.</a:t>
+              <a:t>Integrasi: Menghasilkan nilai biaya, denda, &amp; status untuk Mahasiswa 3.</a:t>
             </a:r>
           </a:p>
         </p:txBody>
@@ -12572,7 +12553,7 @@
                 <a:latin typeface="Calibri"/>
                 <a:cs typeface="Calibri"/>
               </a:rPr>
-              <a:t>4.3 Mahasiswa 3 — Output &amp; Uji</a:t>
+              <a:t>4.3 Mahasiswa 3 — Transaksi &amp; Uji</a:t>
             </a:r>
           </a:p>
         </p:txBody>
@@ -12632,7 +12613,7 @@
                 <a:latin typeface="Calibri"/>
                 <a:cs typeface="Calibri"/>
               </a:rPr>
-              <a:t>Tugas Utama:</a:t>
+              <a:t>Tugas:</a:t>
             </a:r>
           </a:p>
           <a:p>
@@ -12650,7 +12631,7 @@
                 <a:latin typeface="Calibri"/>
                 <a:cs typeface="Calibri"/>
               </a:rPr>
-              <a:t>• Menampilkan bukti rental lengkap</a:t>
+              <a:t>• Menampilkan bukti rental</a:t>
             </a:r>
           </a:p>
           <a:p>
@@ -12668,7 +12649,7 @@
                 <a:latin typeface="Calibri"/>
                 <a:cs typeface="Calibri"/>
               </a:rPr>
-              <a:t>• Menampilkan rincian biaya &amp; denda</a:t>
+              <a:t>• Menampilkan biaya, denda, &amp; total bayar</a:t>
             </a:r>
           </a:p>
           <a:p>
@@ -12686,7 +12667,7 @@
                 <a:latin typeface="Calibri"/>
                 <a:cs typeface="Calibri"/>
               </a:rPr>
-              <a:t>• Menampilkan status ketersediaan film</a:t>
+              <a:t>• Menampilkan status film / pengembalian</a:t>
             </a:r>
           </a:p>
           <a:p>
@@ -12722,7 +12703,7 @@
                 <a:latin typeface="Calibri"/>
                 <a:cs typeface="Calibri"/>
               </a:rPr>
-              <a:t>• Mengintegrasikan seluruh program</a:t>
+              <a:t>Bagian Kode:</a:t>
             </a:r>
           </a:p>
           <a:p>
@@ -12740,7 +12721,7 @@
                 <a:latin typeface="Calibri"/>
                 <a:cs typeface="Calibri"/>
               </a:rPr>
-              <a:t>Fungsi yang Dikerjakan:</a:t>
+              <a:t>• Blok pencetakan BUKTI RENTAL lengkap</a:t>
             </a:r>
           </a:p>
           <a:p>
@@ -12758,7 +12739,7 @@
                 <a:latin typeface="Calibri"/>
                 <a:cs typeface="Calibri"/>
               </a:rPr>
-              <a:t>• tampilkanBuktiRental()</a:t>
+              <a:t>• Integrasi variabel dari Mahasiswa 1 &amp; 2 di main()</a:t>
             </a:r>
           </a:p>
           <a:p>
@@ -12776,7 +12757,7 @@
                 <a:latin typeface="Calibri"/>
                 <a:cs typeface="Calibri"/>
               </a:rPr>
-              <a:t>• tampilkanStatusSemuaFilm()</a:t>
+              <a:t>• Pengujian 5 skenario input &amp; batas</a:t>
             </a:r>
           </a:p>
           <a:p>
@@ -12794,25 +12775,7 @@
                 <a:latin typeface="Calibri"/>
                 <a:cs typeface="Calibri"/>
               </a:rPr>
-              <a:t>• pengujianOtomatis() &amp; main()</a:t>
-            </a:r>
-          </a:p>
-          <a:p>
-            <a:pPr algn="l" marL="228600" indent="-228600">
-              <a:spcAft>
-                <a:spcPts val="500"/>
-              </a:spcAft>
-              <a:buChar char="•"/>
-            </a:pPr>
-            <a:r>
-              <a:rPr lang="id-ID" sz="1100" b="0" i="0" dirty="0">
-                <a:solidFill>
-                  <a:srgbClr val="1E293B"/>
-                </a:solidFill>
-                <a:latin typeface="Calibri"/>
-                <a:cs typeface="Calibri"/>
-              </a:rPr>
-              <a:t>Integrasi: Menyatukan modul Mhs 1 &amp; 2 dalam menu utama interaktif.</a:t>
+              <a:t>Integrasi: Menyatukan seluruh bagian kode menjadi satu program utuh.</a:t>
             </a:r>
           </a:p>
         </p:txBody>

</xml_diff>

<commit_message>
Update PPTX presentasi rental film
</commit_message>
<xml_diff>
--- a/Presentasi_Rental_Film_Kelompok_3.pptx
+++ b/Presentasi_Rental_Film_Kelompok_3.pptx
@@ -19,8 +19,103 @@
     <p:sldId id="267" r:id="rId13"/>
     <p:sldId id="268" r:id="rId14"/>
   </p:sldIdLst>
-  <p:sldSz cx="12192000" cy="6858000" type="custom"/>
+  <p:sldSz cx="12192000" cy="6858000"/>
   <p:notesSz cx="6858000" cy="12192000"/>
+  <p:defaultTextStyle>
+    <a:defPPr>
+      <a:defRPr lang="en-US"/>
+    </a:defPPr>
+    <a:lvl1pPr marL="0" algn="l" defTabSz="914400" rtl="0" eaLnBrk="1" latinLnBrk="0" hangingPunct="1">
+      <a:defRPr sz="1800" kern="1200">
+        <a:solidFill>
+          <a:schemeClr val="tx1"/>
+        </a:solidFill>
+        <a:latin typeface="+mn-lt"/>
+        <a:ea typeface="+mn-ea"/>
+        <a:cs typeface="+mn-cs"/>
+      </a:defRPr>
+    </a:lvl1pPr>
+    <a:lvl2pPr marL="457200" algn="l" defTabSz="914400" rtl="0" eaLnBrk="1" latinLnBrk="0" hangingPunct="1">
+      <a:defRPr sz="1800" kern="1200">
+        <a:solidFill>
+          <a:schemeClr val="tx1"/>
+        </a:solidFill>
+        <a:latin typeface="+mn-lt"/>
+        <a:ea typeface="+mn-ea"/>
+        <a:cs typeface="+mn-cs"/>
+      </a:defRPr>
+    </a:lvl2pPr>
+    <a:lvl3pPr marL="914400" algn="l" defTabSz="914400" rtl="0" eaLnBrk="1" latinLnBrk="0" hangingPunct="1">
+      <a:defRPr sz="1800" kern="1200">
+        <a:solidFill>
+          <a:schemeClr val="tx1"/>
+        </a:solidFill>
+        <a:latin typeface="+mn-lt"/>
+        <a:ea typeface="+mn-ea"/>
+        <a:cs typeface="+mn-cs"/>
+      </a:defRPr>
+    </a:lvl3pPr>
+    <a:lvl4pPr marL="1371600" algn="l" defTabSz="914400" rtl="0" eaLnBrk="1" latinLnBrk="0" hangingPunct="1">
+      <a:defRPr sz="1800" kern="1200">
+        <a:solidFill>
+          <a:schemeClr val="tx1"/>
+        </a:solidFill>
+        <a:latin typeface="+mn-lt"/>
+        <a:ea typeface="+mn-ea"/>
+        <a:cs typeface="+mn-cs"/>
+      </a:defRPr>
+    </a:lvl4pPr>
+    <a:lvl5pPr marL="1828800" algn="l" defTabSz="914400" rtl="0" eaLnBrk="1" latinLnBrk="0" hangingPunct="1">
+      <a:defRPr sz="1800" kern="1200">
+        <a:solidFill>
+          <a:schemeClr val="tx1"/>
+        </a:solidFill>
+        <a:latin typeface="+mn-lt"/>
+        <a:ea typeface="+mn-ea"/>
+        <a:cs typeface="+mn-cs"/>
+      </a:defRPr>
+    </a:lvl5pPr>
+    <a:lvl6pPr marL="2286000" algn="l" defTabSz="914400" rtl="0" eaLnBrk="1" latinLnBrk="0" hangingPunct="1">
+      <a:defRPr sz="1800" kern="1200">
+        <a:solidFill>
+          <a:schemeClr val="tx1"/>
+        </a:solidFill>
+        <a:latin typeface="+mn-lt"/>
+        <a:ea typeface="+mn-ea"/>
+        <a:cs typeface="+mn-cs"/>
+      </a:defRPr>
+    </a:lvl6pPr>
+    <a:lvl7pPr marL="2743200" algn="l" defTabSz="914400" rtl="0" eaLnBrk="1" latinLnBrk="0" hangingPunct="1">
+      <a:defRPr sz="1800" kern="1200">
+        <a:solidFill>
+          <a:schemeClr val="tx1"/>
+        </a:solidFill>
+        <a:latin typeface="+mn-lt"/>
+        <a:ea typeface="+mn-ea"/>
+        <a:cs typeface="+mn-cs"/>
+      </a:defRPr>
+    </a:lvl7pPr>
+    <a:lvl8pPr marL="3200400" algn="l" defTabSz="914400" rtl="0" eaLnBrk="1" latinLnBrk="0" hangingPunct="1">
+      <a:defRPr sz="1800" kern="1200">
+        <a:solidFill>
+          <a:schemeClr val="tx1"/>
+        </a:solidFill>
+        <a:latin typeface="+mn-lt"/>
+        <a:ea typeface="+mn-ea"/>
+        <a:cs typeface="+mn-cs"/>
+      </a:defRPr>
+    </a:lvl8pPr>
+    <a:lvl9pPr marL="3657600" algn="l" defTabSz="914400" rtl="0" eaLnBrk="1" latinLnBrk="0" hangingPunct="1">
+      <a:defRPr sz="1800" kern="1200">
+        <a:solidFill>
+          <a:schemeClr val="tx1"/>
+        </a:solidFill>
+        <a:latin typeface="+mn-lt"/>
+        <a:ea typeface="+mn-ea"/>
+        <a:cs typeface="+mn-cs"/>
+      </a:defRPr>
+    </a:lvl9pPr>
+  </p:defaultTextStyle>
 </p:presentation>
 </file>
 
@@ -77,6 +172,286 @@
   <p:sldLayoutIdLst>
     <p:sldLayoutId id="2147483649" r:id="rId1"/>
   </p:sldLayoutIdLst>
+  <p:txStyles>
+    <p:titleStyle>
+      <a:lvl1pPr algn="l" defTabSz="914400" rtl="0" eaLnBrk="1" latinLnBrk="0" hangingPunct="1">
+        <a:lnSpc>
+          <a:spcPct val="90000"/>
+        </a:lnSpc>
+        <a:spcBef>
+          <a:spcPct val="0"/>
+        </a:spcBef>
+        <a:buNone/>
+        <a:defRPr sz="4400" kern="1200">
+          <a:solidFill>
+            <a:schemeClr val="tx1"/>
+          </a:solidFill>
+          <a:latin typeface="+mj-lt"/>
+          <a:ea typeface="+mj-ea"/>
+          <a:cs typeface="+mj-cs"/>
+        </a:defRPr>
+      </a:lvl1pPr>
+    </p:titleStyle>
+    <p:bodyStyle>
+      <a:lvl1pPr marL="228600" indent="-228600" algn="l" defTabSz="914400" rtl="0" eaLnBrk="1" latinLnBrk="0" hangingPunct="1">
+        <a:lnSpc>
+          <a:spcPct val="90000"/>
+        </a:lnSpc>
+        <a:spcBef>
+          <a:spcPts val="1000"/>
+        </a:spcBef>
+        <a:buFont typeface="Arial" panose="020B0604020202020204" pitchFamily="34" charset="0"/>
+        <a:buChar char="•"/>
+        <a:defRPr sz="2800" kern="1200">
+          <a:solidFill>
+            <a:schemeClr val="tx1"/>
+          </a:solidFill>
+          <a:latin typeface="+mn-lt"/>
+          <a:ea typeface="+mn-ea"/>
+          <a:cs typeface="+mn-cs"/>
+        </a:defRPr>
+      </a:lvl1pPr>
+      <a:lvl2pPr marL="685800" indent="-228600" algn="l" defTabSz="914400" rtl="0" eaLnBrk="1" latinLnBrk="0" hangingPunct="1">
+        <a:lnSpc>
+          <a:spcPct val="90000"/>
+        </a:lnSpc>
+        <a:spcBef>
+          <a:spcPts val="500"/>
+        </a:spcBef>
+        <a:buFont typeface="Arial" panose="020B0604020202020204" pitchFamily="34" charset="0"/>
+        <a:buChar char="•"/>
+        <a:defRPr sz="2400" kern="1200">
+          <a:solidFill>
+            <a:schemeClr val="tx1"/>
+          </a:solidFill>
+          <a:latin typeface="+mn-lt"/>
+          <a:ea typeface="+mn-ea"/>
+          <a:cs typeface="+mn-cs"/>
+        </a:defRPr>
+      </a:lvl2pPr>
+      <a:lvl3pPr marL="1143000" indent="-228600" algn="l" defTabSz="914400" rtl="0" eaLnBrk="1" latinLnBrk="0" hangingPunct="1">
+        <a:lnSpc>
+          <a:spcPct val="90000"/>
+        </a:lnSpc>
+        <a:spcBef>
+          <a:spcPts val="500"/>
+        </a:spcBef>
+        <a:buFont typeface="Arial" panose="020B0604020202020204" pitchFamily="34" charset="0"/>
+        <a:buChar char="•"/>
+        <a:defRPr sz="2000" kern="1200">
+          <a:solidFill>
+            <a:schemeClr val="tx1"/>
+          </a:solidFill>
+          <a:latin typeface="+mn-lt"/>
+          <a:ea typeface="+mn-ea"/>
+          <a:cs typeface="+mn-cs"/>
+        </a:defRPr>
+      </a:lvl3pPr>
+      <a:lvl4pPr marL="1600200" indent="-228600" algn="l" defTabSz="914400" rtl="0" eaLnBrk="1" latinLnBrk="0" hangingPunct="1">
+        <a:lnSpc>
+          <a:spcPct val="90000"/>
+        </a:lnSpc>
+        <a:spcBef>
+          <a:spcPts val="500"/>
+        </a:spcBef>
+        <a:buFont typeface="Arial" panose="020B0604020202020204" pitchFamily="34" charset="0"/>
+        <a:buChar char="•"/>
+        <a:defRPr sz="1800" kern="1200">
+          <a:solidFill>
+            <a:schemeClr val="tx1"/>
+          </a:solidFill>
+          <a:latin typeface="+mn-lt"/>
+          <a:ea typeface="+mn-ea"/>
+          <a:cs typeface="+mn-cs"/>
+        </a:defRPr>
+      </a:lvl4pPr>
+      <a:lvl5pPr marL="2057400" indent="-228600" algn="l" defTabSz="914400" rtl="0" eaLnBrk="1" latinLnBrk="0" hangingPunct="1">
+        <a:lnSpc>
+          <a:spcPct val="90000"/>
+        </a:lnSpc>
+        <a:spcBef>
+          <a:spcPts val="500"/>
+        </a:spcBef>
+        <a:buFont typeface="Arial" panose="020B0604020202020204" pitchFamily="34" charset="0"/>
+        <a:buChar char="•"/>
+        <a:defRPr sz="1800" kern="1200">
+          <a:solidFill>
+            <a:schemeClr val="tx1"/>
+          </a:solidFill>
+          <a:latin typeface="+mn-lt"/>
+          <a:ea typeface="+mn-ea"/>
+          <a:cs typeface="+mn-cs"/>
+        </a:defRPr>
+      </a:lvl5pPr>
+      <a:lvl6pPr marL="2514600" indent="-228600" algn="l" defTabSz="914400" rtl="0" eaLnBrk="1" latinLnBrk="0" hangingPunct="1">
+        <a:lnSpc>
+          <a:spcPct val="90000"/>
+        </a:lnSpc>
+        <a:spcBef>
+          <a:spcPts val="500"/>
+        </a:spcBef>
+        <a:buFont typeface="Arial" panose="020B0604020202020204" pitchFamily="34" charset="0"/>
+        <a:buChar char="•"/>
+        <a:defRPr sz="1800" kern="1200">
+          <a:solidFill>
+            <a:schemeClr val="tx1"/>
+          </a:solidFill>
+          <a:latin typeface="+mn-lt"/>
+          <a:ea typeface="+mn-ea"/>
+          <a:cs typeface="+mn-cs"/>
+        </a:defRPr>
+      </a:lvl6pPr>
+      <a:lvl7pPr marL="2971800" indent="-228600" algn="l" defTabSz="914400" rtl="0" eaLnBrk="1" latinLnBrk="0" hangingPunct="1">
+        <a:lnSpc>
+          <a:spcPct val="90000"/>
+        </a:lnSpc>
+        <a:spcBef>
+          <a:spcPts val="500"/>
+        </a:spcBef>
+        <a:buFont typeface="Arial" panose="020B0604020202020204" pitchFamily="34" charset="0"/>
+        <a:buChar char="•"/>
+        <a:defRPr sz="1800" kern="1200">
+          <a:solidFill>
+            <a:schemeClr val="tx1"/>
+          </a:solidFill>
+          <a:latin typeface="+mn-lt"/>
+          <a:ea typeface="+mn-ea"/>
+          <a:cs typeface="+mn-cs"/>
+        </a:defRPr>
+      </a:lvl7pPr>
+      <a:lvl8pPr marL="3429000" indent="-228600" algn="l" defTabSz="914400" rtl="0" eaLnBrk="1" latinLnBrk="0" hangingPunct="1">
+        <a:lnSpc>
+          <a:spcPct val="90000"/>
+        </a:lnSpc>
+        <a:spcBef>
+          <a:spcPts val="500"/>
+        </a:spcBef>
+        <a:buFont typeface="Arial" panose="020B0604020202020204" pitchFamily="34" charset="0"/>
+        <a:buChar char="•"/>
+        <a:defRPr sz="1800" kern="1200">
+          <a:solidFill>
+            <a:schemeClr val="tx1"/>
+          </a:solidFill>
+          <a:latin typeface="+mn-lt"/>
+          <a:ea typeface="+mn-ea"/>
+          <a:cs typeface="+mn-cs"/>
+        </a:defRPr>
+      </a:lvl8pPr>
+      <a:lvl9pPr marL="3886200" indent="-228600" algn="l" defTabSz="914400" rtl="0" eaLnBrk="1" latinLnBrk="0" hangingPunct="1">
+        <a:lnSpc>
+          <a:spcPct val="90000"/>
+        </a:lnSpc>
+        <a:spcBef>
+          <a:spcPts val="500"/>
+        </a:spcBef>
+        <a:buFont typeface="Arial" panose="020B0604020202020204" pitchFamily="34" charset="0"/>
+        <a:buChar char="•"/>
+        <a:defRPr sz="1800" kern="1200">
+          <a:solidFill>
+            <a:schemeClr val="tx1"/>
+          </a:solidFill>
+          <a:latin typeface="+mn-lt"/>
+          <a:ea typeface="+mn-ea"/>
+          <a:cs typeface="+mn-cs"/>
+        </a:defRPr>
+      </a:lvl9pPr>
+    </p:bodyStyle>
+    <p:otherStyle>
+      <a:defPPr>
+        <a:defRPr lang="en-US"/>
+      </a:defPPr>
+      <a:lvl1pPr marL="0" algn="l" defTabSz="914400" rtl="0" eaLnBrk="1" latinLnBrk="0" hangingPunct="1">
+        <a:defRPr sz="1800" kern="1200">
+          <a:solidFill>
+            <a:schemeClr val="tx1"/>
+          </a:solidFill>
+          <a:latin typeface="+mn-lt"/>
+          <a:ea typeface="+mn-ea"/>
+          <a:cs typeface="+mn-cs"/>
+        </a:defRPr>
+      </a:lvl1pPr>
+      <a:lvl2pPr marL="457200" algn="l" defTabSz="914400" rtl="0" eaLnBrk="1" latinLnBrk="0" hangingPunct="1">
+        <a:defRPr sz="1800" kern="1200">
+          <a:solidFill>
+            <a:schemeClr val="tx1"/>
+          </a:solidFill>
+          <a:latin typeface="+mn-lt"/>
+          <a:ea typeface="+mn-ea"/>
+          <a:cs typeface="+mn-cs"/>
+        </a:defRPr>
+      </a:lvl2pPr>
+      <a:lvl3pPr marL="914400" algn="l" defTabSz="914400" rtl="0" eaLnBrk="1" latinLnBrk="0" hangingPunct="1">
+        <a:defRPr sz="1800" kern="1200">
+          <a:solidFill>
+            <a:schemeClr val="tx1"/>
+          </a:solidFill>
+          <a:latin typeface="+mn-lt"/>
+          <a:ea typeface="+mn-ea"/>
+          <a:cs typeface="+mn-cs"/>
+        </a:defRPr>
+      </a:lvl3pPr>
+      <a:lvl4pPr marL="1371600" algn="l" defTabSz="914400" rtl="0" eaLnBrk="1" latinLnBrk="0" hangingPunct="1">
+        <a:defRPr sz="1800" kern="1200">
+          <a:solidFill>
+            <a:schemeClr val="tx1"/>
+          </a:solidFill>
+          <a:latin typeface="+mn-lt"/>
+          <a:ea typeface="+mn-ea"/>
+          <a:cs typeface="+mn-cs"/>
+        </a:defRPr>
+      </a:lvl4pPr>
+      <a:lvl5pPr marL="1828800" algn="l" defTabSz="914400" rtl="0" eaLnBrk="1" latinLnBrk="0" hangingPunct="1">
+        <a:defRPr sz="1800" kern="1200">
+          <a:solidFill>
+            <a:schemeClr val="tx1"/>
+          </a:solidFill>
+          <a:latin typeface="+mn-lt"/>
+          <a:ea typeface="+mn-ea"/>
+          <a:cs typeface="+mn-cs"/>
+        </a:defRPr>
+      </a:lvl5pPr>
+      <a:lvl6pPr marL="2286000" algn="l" defTabSz="914400" rtl="0" eaLnBrk="1" latinLnBrk="0" hangingPunct="1">
+        <a:defRPr sz="1800" kern="1200">
+          <a:solidFill>
+            <a:schemeClr val="tx1"/>
+          </a:solidFill>
+          <a:latin typeface="+mn-lt"/>
+          <a:ea typeface="+mn-ea"/>
+          <a:cs typeface="+mn-cs"/>
+        </a:defRPr>
+      </a:lvl6pPr>
+      <a:lvl7pPr marL="2743200" algn="l" defTabSz="914400" rtl="0" eaLnBrk="1" latinLnBrk="0" hangingPunct="1">
+        <a:defRPr sz="1800" kern="1200">
+          <a:solidFill>
+            <a:schemeClr val="tx1"/>
+          </a:solidFill>
+          <a:latin typeface="+mn-lt"/>
+          <a:ea typeface="+mn-ea"/>
+          <a:cs typeface="+mn-cs"/>
+        </a:defRPr>
+      </a:lvl7pPr>
+      <a:lvl8pPr marL="3200400" algn="l" defTabSz="914400" rtl="0" eaLnBrk="1" latinLnBrk="0" hangingPunct="1">
+        <a:defRPr sz="1800" kern="1200">
+          <a:solidFill>
+            <a:schemeClr val="tx1"/>
+          </a:solidFill>
+          <a:latin typeface="+mn-lt"/>
+          <a:ea typeface="+mn-ea"/>
+          <a:cs typeface="+mn-cs"/>
+        </a:defRPr>
+      </a:lvl8pPr>
+      <a:lvl9pPr marL="3657600" algn="l" defTabSz="914400" rtl="0" eaLnBrk="1" latinLnBrk="0" hangingPunct="1">
+        <a:defRPr sz="1800" kern="1200">
+          <a:solidFill>
+            <a:schemeClr val="tx1"/>
+          </a:solidFill>
+          <a:latin typeface="+mn-lt"/>
+          <a:ea typeface="+mn-ea"/>
+          <a:cs typeface="+mn-cs"/>
+        </a:defRPr>
+      </a:lvl9pPr>
+    </p:otherStyle>
+  </p:txStyles>
 </p:sldMaster>
 </file>
 
@@ -126,6 +501,13 @@
             <a:noFill/>
           </a:ln>
         </p:spPr>
+        <p:txBody>
+          <a:bodyPr/>
+          <a:lstStyle/>
+          <a:p>
+            <a:endParaRPr lang="en-US"/>
+          </a:p>
+        </p:txBody>
       </p:sp>
       <p:sp>
         <p:nvSpPr>
@@ -148,6 +530,13 @@
             <a:noFill/>
           </a:ln>
         </p:spPr>
+        <p:txBody>
+          <a:bodyPr/>
+          <a:lstStyle/>
+          <a:p>
+            <a:endParaRPr lang="en-US"/>
+          </a:p>
+        </p:txBody>
       </p:sp>
       <p:sp>
         <p:nvSpPr>
@@ -280,6 +669,13 @@
             </a:solidFill>
           </a:ln>
         </p:spPr>
+        <p:txBody>
+          <a:bodyPr/>
+          <a:lstStyle/>
+          <a:p>
+            <a:endParaRPr lang="en-US"/>
+          </a:p>
+        </p:txBody>
       </p:sp>
       <p:sp>
         <p:nvSpPr>
@@ -336,7 +732,47 @@
                 <a:latin typeface="Calibri"/>
                 <a:cs typeface="Calibri"/>
               </a:rPr>
-              <a:t>1. Mahasiswa 1 (NRP: ....................) — Data Pelanggan &amp; Film</a:t>
+              <a:t>1. </a:t>
+            </a:r>
+            <a:r>
+              <a:rPr lang="en-US" sz="1300" b="1" i="0" dirty="0">
+                <a:solidFill>
+                  <a:srgbClr val="FFFFFF"/>
+                </a:solidFill>
+                <a:latin typeface="Calibri"/>
+                <a:cs typeface="Calibri"/>
+              </a:rPr>
+              <a:t>Andra Bima Ananta</a:t>
+            </a:r>
+            <a:r>
+              <a:rPr lang="id-ID" sz="1300" b="1" i="0" dirty="0">
+                <a:solidFill>
+                  <a:srgbClr val="FFFFFF"/>
+                </a:solidFill>
+                <a:latin typeface="Calibri"/>
+                <a:cs typeface="Calibri"/>
+              </a:rPr>
+              <a:t> (NRP:</a:t>
+            </a:r>
+            <a:r>
+              <a:rPr lang="en-US" sz="1300" b="1" i="0" dirty="0">
+                <a:solidFill>
+                  <a:srgbClr val="FFFFFF"/>
+                </a:solidFill>
+                <a:latin typeface="Calibri"/>
+                <a:cs typeface="Calibri"/>
+              </a:rPr>
+              <a:t> 3226600064</a:t>
+            </a:r>
+            <a:r>
+              <a:rPr lang="id-ID" sz="1300" b="1" i="0" dirty="0">
+                <a:solidFill>
+                  <a:srgbClr val="FFFFFF"/>
+                </a:solidFill>
+                <a:latin typeface="Calibri"/>
+                <a:cs typeface="Calibri"/>
+              </a:rPr>
+              <a:t>) — Data Pelanggan &amp; Film</a:t>
             </a:r>
           </a:p>
           <a:p>
@@ -358,11 +794,10 @@
             </a:r>
           </a:p>
           <a:p>
-            <a:pPr algn="l">
+            <a:pPr>
               <a:spcAft>
                 <a:spcPts val="200"/>
               </a:spcAft>
-              <a:buNone/>
             </a:pPr>
             <a:r>
               <a:rPr lang="id-ID" sz="1300" b="1" i="0" dirty="0">
@@ -372,7 +807,56 @@
                 <a:latin typeface="Calibri"/>
                 <a:cs typeface="Calibri"/>
               </a:rPr>
-              <a:t>2. Mahasiswa 2 (NRP: ....................) — Proses Sewa &amp; Denda</a:t>
+              <a:t>2. </a:t>
+            </a:r>
+            <a:r>
+              <a:rPr lang="en-US" sz="1300" b="1" i="0" dirty="0">
+                <a:solidFill>
+                  <a:srgbClr val="FFFFFF"/>
+                </a:solidFill>
+                <a:latin typeface="Calibri"/>
+                <a:cs typeface="Calibri"/>
+              </a:rPr>
+              <a:t>Bayu Arga Pratama </a:t>
+            </a:r>
+            <a:r>
+              <a:rPr lang="en-US" sz="1300" b="1" dirty="0">
+                <a:solidFill>
+                  <a:srgbClr val="FFFFFF"/>
+                </a:solidFill>
+                <a:latin typeface="Calibri"/>
+                <a:cs typeface="Calibri"/>
+              </a:rPr>
+              <a:t>Rinaldi </a:t>
+            </a:r>
+            <a:r>
+              <a:rPr lang="id-ID" sz="1300" b="1" i="0" dirty="0">
+                <a:solidFill>
+                  <a:srgbClr val="FFFFFF"/>
+                </a:solidFill>
+                <a:latin typeface="Calibri"/>
+                <a:cs typeface="Calibri"/>
+              </a:rPr>
+              <a:t>(NRP: </a:t>
+            </a:r>
+            <a:r>
+              <a:rPr lang="en-US" sz="1300" b="1" dirty="0">
+                <a:solidFill>
+                  <a:srgbClr val="FFFFFF"/>
+                </a:solidFill>
+                <a:cs typeface="Calibri"/>
+              </a:rPr>
+              <a:t>3226600066</a:t>
+            </a:r>
+            <a:r>
+              <a:rPr lang="id-ID" sz="1300" b="1" i="0" dirty="0">
+                <a:solidFill>
+                  <a:srgbClr val="FFFFFF"/>
+                </a:solidFill>
+                <a:latin typeface="Calibri"/>
+                <a:cs typeface="Calibri"/>
+              </a:rPr>
+              <a:t>) — Proses Sewa &amp; Denda</a:t>
             </a:r>
           </a:p>
           <a:p>
@@ -408,7 +892,27 @@
                 <a:latin typeface="Calibri"/>
                 <a:cs typeface="Calibri"/>
               </a:rPr>
-              <a:t>3. Mahasiswa 3 (NRP: ....................) — Transaksi &amp; Pengujian</a:t>
+              <a:t>3. Asyraf Rakha Widodo(NRP: 3226600077</a:t>
+            </a:r>
+            <a:r>
+              <a:rPr lang="en-US" sz="1300" b="1" i="0" dirty="0">
+                <a:solidFill>
+                  <a:srgbClr val="FFFFFF"/>
+                </a:solidFill>
+                <a:latin typeface="Calibri"/>
+                <a:cs typeface="Calibri"/>
+              </a:rPr>
+              <a:t>)</a:t>
+            </a:r>
+            <a:r>
+              <a:rPr lang="id-ID" sz="1300" b="1" i="0" dirty="0">
+                <a:solidFill>
+                  <a:srgbClr val="FFFFFF"/>
+                </a:solidFill>
+                <a:latin typeface="Calibri"/>
+                <a:cs typeface="Calibri"/>
+              </a:rPr>
+              <a:t>— Transaksi &amp; Pengujian</a:t>
             </a:r>
           </a:p>
           <a:p>
@@ -456,6 +960,13 @@
             </a:solidFill>
           </a:ln>
         </p:spPr>
+        <p:txBody>
+          <a:bodyPr/>
+          <a:lstStyle/>
+          <a:p>
+            <a:endParaRPr lang="en-US"/>
+          </a:p>
+        </p:txBody>
       </p:sp>
       <p:sp>
         <p:nvSpPr>
@@ -465,8 +976,8 @@
         </p:nvSpPr>
         <p:spPr>
           <a:xfrm>
-            <a:off x="7635240" y="2834640"/>
-            <a:ext cx="3657600" cy="3017520"/>
+            <a:off x="7520940" y="2834640"/>
+            <a:ext cx="3886200" cy="3017520"/>
           </a:xfrm>
           <a:prstGeom prst="rect">
             <a:avLst/>
@@ -530,7 +1041,7 @@
                 <a:latin typeface="Calibri"/>
                 <a:cs typeface="Calibri"/>
               </a:rPr>
-              <a:t>Pemrograman Dasar</a:t>
+              <a:t>Pemrograman</a:t>
             </a:r>
           </a:p>
           <a:p>
@@ -559,15 +1070,22 @@
               <a:buNone/>
             </a:pPr>
             <a:r>
-              <a:rPr lang="id-ID" sz="1300" b="0" i="0" dirty="0">
+              <a:rPr lang="sv-SE" sz="1300" b="0" i="0" dirty="0">
                 <a:solidFill>
                   <a:srgbClr val="FFFFFF"/>
                 </a:solidFill>
                 <a:latin typeface="Calibri"/>
                 <a:cs typeface="Calibri"/>
               </a:rPr>
-              <a:t>................................................</a:t>
-            </a:r>
+              <a:t>Dr.Ir. Sigit Wasista, M.Kom</a:t>
+            </a:r>
+            <a:endParaRPr lang="id-ID" sz="1300" b="0" i="0" dirty="0">
+              <a:solidFill>
+                <a:srgbClr val="FFFFFF"/>
+              </a:solidFill>
+              <a:latin typeface="Calibri"/>
+              <a:cs typeface="Calibri"/>
+            </a:endParaRPr>
           </a:p>
           <a:p>
             <a:pPr algn="l">
@@ -595,15 +1113,82 @@
               <a:buNone/>
             </a:pPr>
             <a:r>
-              <a:rPr lang="id-ID" sz="1300" b="0" i="0" dirty="0">
+              <a:rPr lang="en-US" sz="1300" b="0" i="0" dirty="0">
                 <a:solidFill>
                   <a:srgbClr val="FFFFFF"/>
                 </a:solidFill>
                 <a:latin typeface="Calibri"/>
                 <a:cs typeface="Calibri"/>
               </a:rPr>
-              <a:t>................................................</a:t>
-            </a:r>
+              <a:t>Teknik </a:t>
+            </a:r>
+            <a:r>
+              <a:rPr lang="en-US" sz="1300" b="0" i="0" dirty="0" err="1">
+                <a:solidFill>
+                  <a:srgbClr val="FFFFFF"/>
+                </a:solidFill>
+                <a:latin typeface="Calibri"/>
+                <a:cs typeface="Calibri"/>
+              </a:rPr>
+              <a:t>Komputer</a:t>
+            </a:r>
+            <a:r>
+              <a:rPr lang="en-US" sz="1300" b="0" i="0" dirty="0">
+                <a:solidFill>
+                  <a:srgbClr val="FFFFFF"/>
+                </a:solidFill>
+                <a:latin typeface="Calibri"/>
+                <a:cs typeface="Calibri"/>
+              </a:rPr>
+              <a:t> </a:t>
+            </a:r>
+            <a:r>
+              <a:rPr lang="en-US" sz="1300" b="0" i="0" dirty="0" err="1">
+                <a:solidFill>
+                  <a:srgbClr val="FFFFFF"/>
+                </a:solidFill>
+                <a:latin typeface="Calibri"/>
+                <a:cs typeface="Calibri"/>
+              </a:rPr>
+              <a:t>Politeknik</a:t>
+            </a:r>
+            <a:r>
+              <a:rPr lang="en-US" sz="1300" b="0" i="0" dirty="0">
+                <a:solidFill>
+                  <a:srgbClr val="FFFFFF"/>
+                </a:solidFill>
+                <a:latin typeface="Calibri"/>
+                <a:cs typeface="Calibri"/>
+              </a:rPr>
+              <a:t> </a:t>
+            </a:r>
+            <a:r>
+              <a:rPr lang="en-US" sz="1300" b="0" i="0" dirty="0" err="1">
+                <a:solidFill>
+                  <a:srgbClr val="FFFFFF"/>
+                </a:solidFill>
+                <a:latin typeface="Calibri"/>
+                <a:cs typeface="Calibri"/>
+              </a:rPr>
+              <a:t>Elektronika</a:t>
+            </a:r>
+            <a:r>
+              <a:rPr lang="en-US" sz="1300" b="0" i="0" dirty="0">
+                <a:solidFill>
+                  <a:srgbClr val="FFFFFF"/>
+                </a:solidFill>
+                <a:latin typeface="Calibri"/>
+                <a:cs typeface="Calibri"/>
+              </a:rPr>
+              <a:t> Negeri Surabaya</a:t>
+            </a:r>
+            <a:endParaRPr lang="id-ID" sz="1300" b="0" i="0" dirty="0">
+              <a:solidFill>
+                <a:srgbClr val="FFFFFF"/>
+              </a:solidFill>
+              <a:latin typeface="Calibri"/>
+              <a:cs typeface="Calibri"/>
+            </a:endParaRPr>
           </a:p>
           <a:p>
             <a:pPr algn="l">
@@ -679,6 +1264,13 @@
             <a:noFill/>
           </a:ln>
         </p:spPr>
+        <p:txBody>
+          <a:bodyPr/>
+          <a:lstStyle/>
+          <a:p>
+            <a:endParaRPr lang="en-US"/>
+          </a:p>
+        </p:txBody>
       </p:sp>
       <p:sp>
         <p:nvSpPr>
@@ -701,6 +1293,13 @@
             <a:noFill/>
           </a:ln>
         </p:spPr>
+        <p:txBody>
+          <a:bodyPr/>
+          <a:lstStyle/>
+          <a:p>
+            <a:endParaRPr lang="en-US"/>
+          </a:p>
+        </p:txBody>
       </p:sp>
       <p:sp>
         <p:nvSpPr>
@@ -853,6 +1452,13 @@
             <a:noFill/>
           </a:ln>
         </p:spPr>
+        <p:txBody>
+          <a:bodyPr/>
+          <a:lstStyle/>
+          <a:p>
+            <a:endParaRPr lang="en-US"/>
+          </a:p>
+        </p:txBody>
       </p:sp>
       <p:sp>
         <p:nvSpPr>
@@ -963,6 +1569,13 @@
             </a:solidFill>
           </a:ln>
         </p:spPr>
+        <p:txBody>
+          <a:bodyPr/>
+          <a:lstStyle/>
+          <a:p>
+            <a:endParaRPr lang="en-US"/>
+          </a:p>
+        </p:txBody>
       </p:sp>
       <p:sp>
         <p:nvSpPr>
@@ -987,6 +1600,13 @@
             <a:noFill/>
           </a:ln>
         </p:spPr>
+        <p:txBody>
+          <a:bodyPr/>
+          <a:lstStyle/>
+          <a:p>
+            <a:endParaRPr lang="en-US"/>
+          </a:p>
+        </p:txBody>
       </p:sp>
       <p:sp>
         <p:nvSpPr>
@@ -1133,6 +1753,13 @@
             </a:solidFill>
           </a:ln>
         </p:spPr>
+        <p:txBody>
+          <a:bodyPr/>
+          <a:lstStyle/>
+          <a:p>
+            <a:endParaRPr lang="en-US"/>
+          </a:p>
+        </p:txBody>
       </p:sp>
       <p:sp>
         <p:nvSpPr>
@@ -1157,6 +1784,13 @@
             <a:noFill/>
           </a:ln>
         </p:spPr>
+        <p:txBody>
+          <a:bodyPr/>
+          <a:lstStyle/>
+          <a:p>
+            <a:endParaRPr lang="en-US"/>
+          </a:p>
+        </p:txBody>
       </p:sp>
       <p:sp>
         <p:nvSpPr>
@@ -1303,6 +1937,13 @@
             </a:solidFill>
           </a:ln>
         </p:spPr>
+        <p:txBody>
+          <a:bodyPr/>
+          <a:lstStyle/>
+          <a:p>
+            <a:endParaRPr lang="en-US"/>
+          </a:p>
+        </p:txBody>
       </p:sp>
       <p:sp>
         <p:nvSpPr>
@@ -1327,6 +1968,13 @@
             <a:noFill/>
           </a:ln>
         </p:spPr>
+        <p:txBody>
+          <a:bodyPr/>
+          <a:lstStyle/>
+          <a:p>
+            <a:endParaRPr lang="en-US"/>
+          </a:p>
+        </p:txBody>
       </p:sp>
       <p:sp>
         <p:nvSpPr>
@@ -1473,6 +2121,13 @@
             </a:solidFill>
           </a:ln>
         </p:spPr>
+        <p:txBody>
+          <a:bodyPr/>
+          <a:lstStyle/>
+          <a:p>
+            <a:endParaRPr lang="en-US"/>
+          </a:p>
+        </p:txBody>
       </p:sp>
       <p:sp>
         <p:nvSpPr>
@@ -1497,6 +2152,13 @@
             <a:noFill/>
           </a:ln>
         </p:spPr>
+        <p:txBody>
+          <a:bodyPr/>
+          <a:lstStyle/>
+          <a:p>
+            <a:endParaRPr lang="en-US"/>
+          </a:p>
+        </p:txBody>
       </p:sp>
       <p:sp>
         <p:nvSpPr>
@@ -1643,6 +2305,13 @@
             </a:solidFill>
           </a:ln>
         </p:spPr>
+        <p:txBody>
+          <a:bodyPr/>
+          <a:lstStyle/>
+          <a:p>
+            <a:endParaRPr lang="en-US"/>
+          </a:p>
+        </p:txBody>
       </p:sp>
       <p:sp>
         <p:nvSpPr>
@@ -1667,6 +2336,13 @@
             <a:noFill/>
           </a:ln>
         </p:spPr>
+        <p:txBody>
+          <a:bodyPr/>
+          <a:lstStyle/>
+          <a:p>
+            <a:endParaRPr lang="en-US"/>
+          </a:p>
+        </p:txBody>
       </p:sp>
       <p:sp>
         <p:nvSpPr>
@@ -1842,6 +2518,13 @@
             <a:noFill/>
           </a:ln>
         </p:spPr>
+        <p:txBody>
+          <a:bodyPr/>
+          <a:lstStyle/>
+          <a:p>
+            <a:endParaRPr lang="en-US"/>
+          </a:p>
+        </p:txBody>
       </p:sp>
       <p:sp>
         <p:nvSpPr>
@@ -1864,6 +2547,13 @@
             <a:noFill/>
           </a:ln>
         </p:spPr>
+        <p:txBody>
+          <a:bodyPr/>
+          <a:lstStyle/>
+          <a:p>
+            <a:endParaRPr lang="en-US"/>
+          </a:p>
+        </p:txBody>
       </p:sp>
       <p:sp>
         <p:nvSpPr>
@@ -2016,6 +2706,13 @@
             <a:noFill/>
           </a:ln>
         </p:spPr>
+        <p:txBody>
+          <a:bodyPr/>
+          <a:lstStyle/>
+          <a:p>
+            <a:endParaRPr lang="en-US"/>
+          </a:p>
+        </p:txBody>
       </p:sp>
       <p:sp>
         <p:nvSpPr>
@@ -2126,6 +2823,13 @@
             </a:solidFill>
           </a:ln>
         </p:spPr>
+        <p:txBody>
+          <a:bodyPr/>
+          <a:lstStyle/>
+          <a:p>
+            <a:endParaRPr lang="en-US"/>
+          </a:p>
+        </p:txBody>
       </p:sp>
       <p:sp>
         <p:nvSpPr>
@@ -2150,6 +2854,13 @@
             <a:noFill/>
           </a:ln>
         </p:spPr>
+        <p:txBody>
+          <a:bodyPr/>
+          <a:lstStyle/>
+          <a:p>
+            <a:endParaRPr lang="en-US"/>
+          </a:p>
+        </p:txBody>
       </p:sp>
       <p:sp>
         <p:nvSpPr>
@@ -2566,6 +3277,13 @@
             </a:solidFill>
           </a:ln>
         </p:spPr>
+        <p:txBody>
+          <a:bodyPr/>
+          <a:lstStyle/>
+          <a:p>
+            <a:endParaRPr lang="en-US"/>
+          </a:p>
+        </p:txBody>
       </p:sp>
       <p:sp>
         <p:nvSpPr>
@@ -2590,6 +3308,13 @@
             <a:noFill/>
           </a:ln>
         </p:spPr>
+        <p:txBody>
+          <a:bodyPr/>
+          <a:lstStyle/>
+          <a:p>
+            <a:endParaRPr lang="en-US"/>
+          </a:p>
+        </p:txBody>
       </p:sp>
       <p:sp>
         <p:nvSpPr>
@@ -3017,6 +3742,13 @@
             <a:noFill/>
           </a:ln>
         </p:spPr>
+        <p:txBody>
+          <a:bodyPr/>
+          <a:lstStyle/>
+          <a:p>
+            <a:endParaRPr lang="en-US"/>
+          </a:p>
+        </p:txBody>
       </p:sp>
       <p:sp>
         <p:nvSpPr>
@@ -3039,6 +3771,13 @@
             <a:noFill/>
           </a:ln>
         </p:spPr>
+        <p:txBody>
+          <a:bodyPr/>
+          <a:lstStyle/>
+          <a:p>
+            <a:endParaRPr lang="en-US"/>
+          </a:p>
+        </p:txBody>
       </p:sp>
       <p:sp>
         <p:nvSpPr>
@@ -3191,6 +3930,13 @@
             <a:noFill/>
           </a:ln>
         </p:spPr>
+        <p:txBody>
+          <a:bodyPr/>
+          <a:lstStyle/>
+          <a:p>
+            <a:endParaRPr lang="en-US"/>
+          </a:p>
+        </p:txBody>
       </p:sp>
       <p:sp>
         <p:nvSpPr>
@@ -3301,6 +4047,13 @@
             </a:solidFill>
           </a:ln>
         </p:spPr>
+        <p:txBody>
+          <a:bodyPr/>
+          <a:lstStyle/>
+          <a:p>
+            <a:endParaRPr lang="en-US"/>
+          </a:p>
+        </p:txBody>
       </p:sp>
       <p:sp>
         <p:nvSpPr>
@@ -3325,6 +4078,13 @@
             <a:noFill/>
           </a:ln>
         </p:spPr>
+        <p:txBody>
+          <a:bodyPr/>
+          <a:lstStyle/>
+          <a:p>
+            <a:endParaRPr lang="en-US"/>
+          </a:p>
+        </p:txBody>
       </p:sp>
       <p:sp>
         <p:nvSpPr>
@@ -3391,7 +4151,7 @@
           <a:bodyPr wrap="square" lIns="91440" tIns="68580" rIns="91440" bIns="68580" anchor="t"/>
           <a:lstStyle/>
           <a:p>
-            <a:pPr algn="l" marL="228600" indent="-228600">
+            <a:pPr marL="228600" indent="-228600" algn="l">
               <a:spcAft>
                 <a:spcPts val="500"/>
               </a:spcAft>
@@ -3409,7 +4169,7 @@
             </a:r>
           </a:p>
           <a:p>
-            <a:pPr algn="l" marL="228600" indent="-228600">
+            <a:pPr marL="228600" indent="-228600" algn="l">
               <a:spcAft>
                 <a:spcPts val="500"/>
               </a:spcAft>
@@ -3427,7 +4187,7 @@
             </a:r>
           </a:p>
           <a:p>
-            <a:pPr algn="l" marL="228600" indent="-228600">
+            <a:pPr marL="228600" indent="-228600" algn="l">
               <a:spcAft>
                 <a:spcPts val="500"/>
               </a:spcAft>
@@ -3445,7 +4205,7 @@
             </a:r>
           </a:p>
           <a:p>
-            <a:pPr algn="l" marL="228600" indent="-228600">
+            <a:pPr marL="228600" indent="-228600" algn="l">
               <a:spcAft>
                 <a:spcPts val="500"/>
               </a:spcAft>
@@ -3463,7 +4223,7 @@
             </a:r>
           </a:p>
           <a:p>
-            <a:pPr algn="l" marL="228600" indent="-228600">
+            <a:pPr marL="228600" indent="-228600" algn="l">
               <a:spcAft>
                 <a:spcPts val="500"/>
               </a:spcAft>
@@ -3507,6 +4267,13 @@
             </a:solidFill>
           </a:ln>
         </p:spPr>
+        <p:txBody>
+          <a:bodyPr/>
+          <a:lstStyle/>
+          <a:p>
+            <a:endParaRPr lang="en-US"/>
+          </a:p>
+        </p:txBody>
       </p:sp>
       <p:sp>
         <p:nvSpPr>
@@ -3531,6 +4298,13 @@
             <a:noFill/>
           </a:ln>
         </p:spPr>
+        <p:txBody>
+          <a:bodyPr/>
+          <a:lstStyle/>
+          <a:p>
+            <a:endParaRPr lang="en-US"/>
+          </a:p>
+        </p:txBody>
       </p:sp>
       <p:sp>
         <p:nvSpPr>
@@ -3597,7 +4371,7 @@
           <a:bodyPr wrap="square" lIns="91440" tIns="68580" rIns="91440" bIns="68580" anchor="t"/>
           <a:lstStyle/>
           <a:p>
-            <a:pPr algn="l" marL="228600" indent="-228600">
+            <a:pPr marL="228600" indent="-228600" algn="l">
               <a:spcAft>
                 <a:spcPts val="500"/>
               </a:spcAft>
@@ -3615,7 +4389,7 @@
             </a:r>
           </a:p>
           <a:p>
-            <a:pPr algn="l" marL="228600" indent="-228600">
+            <a:pPr marL="228600" indent="-228600" algn="l">
               <a:spcAft>
                 <a:spcPts val="500"/>
               </a:spcAft>
@@ -3633,7 +4407,7 @@
             </a:r>
           </a:p>
           <a:p>
-            <a:pPr algn="l" marL="228600" indent="-228600">
+            <a:pPr marL="228600" indent="-228600" algn="l">
               <a:spcAft>
                 <a:spcPts val="500"/>
               </a:spcAft>
@@ -3651,7 +4425,7 @@
             </a:r>
           </a:p>
           <a:p>
-            <a:pPr algn="l" marL="228600" indent="-228600">
+            <a:pPr marL="228600" indent="-228600" algn="l">
               <a:spcAft>
                 <a:spcPts val="500"/>
               </a:spcAft>
@@ -3669,7 +4443,7 @@
             </a:r>
           </a:p>
           <a:p>
-            <a:pPr algn="l" marL="228600" indent="-228600">
+            <a:pPr marL="228600" indent="-228600" algn="l">
               <a:spcAft>
                 <a:spcPts val="500"/>
               </a:spcAft>
@@ -3687,7 +4461,7 @@
             </a:r>
           </a:p>
           <a:p>
-            <a:pPr algn="l" marL="228600" indent="-228600">
+            <a:pPr marL="228600" indent="-228600" algn="l">
               <a:spcAft>
                 <a:spcPts val="500"/>
               </a:spcAft>
@@ -3760,6 +4534,13 @@
             <a:noFill/>
           </a:ln>
         </p:spPr>
+        <p:txBody>
+          <a:bodyPr/>
+          <a:lstStyle/>
+          <a:p>
+            <a:endParaRPr lang="en-US"/>
+          </a:p>
+        </p:txBody>
       </p:sp>
       <p:sp>
         <p:nvSpPr>
@@ -3782,6 +4563,13 @@
             <a:noFill/>
           </a:ln>
         </p:spPr>
+        <p:txBody>
+          <a:bodyPr/>
+          <a:lstStyle/>
+          <a:p>
+            <a:endParaRPr lang="en-US"/>
+          </a:p>
+        </p:txBody>
       </p:sp>
       <p:sp>
         <p:nvSpPr>
@@ -3934,6 +4722,13 @@
             <a:noFill/>
           </a:ln>
         </p:spPr>
+        <p:txBody>
+          <a:bodyPr/>
+          <a:lstStyle/>
+          <a:p>
+            <a:endParaRPr lang="en-US"/>
+          </a:p>
+        </p:txBody>
       </p:sp>
       <p:sp>
         <p:nvSpPr>
@@ -4044,6 +4839,13 @@
             </a:solidFill>
           </a:ln>
         </p:spPr>
+        <p:txBody>
+          <a:bodyPr/>
+          <a:lstStyle/>
+          <a:p>
+            <a:endParaRPr lang="en-US"/>
+          </a:p>
+        </p:txBody>
       </p:sp>
       <p:sp>
         <p:nvSpPr>
@@ -4068,6 +4870,13 @@
             <a:noFill/>
           </a:ln>
         </p:spPr>
+        <p:txBody>
+          <a:bodyPr/>
+          <a:lstStyle/>
+          <a:p>
+            <a:endParaRPr lang="en-US"/>
+          </a:p>
+        </p:txBody>
       </p:sp>
       <p:sp>
         <p:nvSpPr>
@@ -4134,7 +4943,7 @@
           <a:bodyPr wrap="square" lIns="91440" tIns="68580" rIns="91440" bIns="68580" anchor="t"/>
           <a:lstStyle/>
           <a:p>
-            <a:pPr algn="l" marL="228600" indent="-228600">
+            <a:pPr marL="228600" indent="-228600" algn="l">
               <a:spcAft>
                 <a:spcPts val="500"/>
               </a:spcAft>
@@ -4152,7 +4961,7 @@
             </a:r>
           </a:p>
           <a:p>
-            <a:pPr algn="l" marL="228600" indent="-228600">
+            <a:pPr marL="228600" indent="-228600" algn="l">
               <a:spcAft>
                 <a:spcPts val="500"/>
               </a:spcAft>
@@ -4170,7 +4979,7 @@
             </a:r>
           </a:p>
           <a:p>
-            <a:pPr algn="l" marL="228600" indent="-228600">
+            <a:pPr marL="228600" indent="-228600" algn="l">
               <a:spcAft>
                 <a:spcPts val="500"/>
               </a:spcAft>
@@ -4214,6 +5023,13 @@
             </a:solidFill>
           </a:ln>
         </p:spPr>
+        <p:txBody>
+          <a:bodyPr/>
+          <a:lstStyle/>
+          <a:p>
+            <a:endParaRPr lang="en-US"/>
+          </a:p>
+        </p:txBody>
       </p:sp>
       <p:sp>
         <p:nvSpPr>
@@ -4238,6 +5054,13 @@
             <a:noFill/>
           </a:ln>
         </p:spPr>
+        <p:txBody>
+          <a:bodyPr/>
+          <a:lstStyle/>
+          <a:p>
+            <a:endParaRPr lang="en-US"/>
+          </a:p>
+        </p:txBody>
       </p:sp>
       <p:sp>
         <p:nvSpPr>
@@ -4304,7 +5127,7 @@
           <a:bodyPr wrap="square" lIns="91440" tIns="68580" rIns="91440" bIns="68580" anchor="t"/>
           <a:lstStyle/>
           <a:p>
-            <a:pPr algn="l" marL="228600" indent="-228600">
+            <a:pPr marL="228600" indent="-228600" algn="l">
               <a:spcAft>
                 <a:spcPts val="500"/>
               </a:spcAft>
@@ -4322,7 +5145,7 @@
             </a:r>
           </a:p>
           <a:p>
-            <a:pPr algn="l" marL="228600" indent="-228600">
+            <a:pPr marL="228600" indent="-228600" algn="l">
               <a:spcAft>
                 <a:spcPts val="500"/>
               </a:spcAft>
@@ -4340,7 +5163,7 @@
             </a:r>
           </a:p>
           <a:p>
-            <a:pPr algn="l" marL="228600" indent="-228600">
+            <a:pPr marL="228600" indent="-228600" algn="l">
               <a:spcAft>
                 <a:spcPts val="500"/>
               </a:spcAft>
@@ -4384,6 +5207,13 @@
             </a:solidFill>
           </a:ln>
         </p:spPr>
+        <p:txBody>
+          <a:bodyPr/>
+          <a:lstStyle/>
+          <a:p>
+            <a:endParaRPr lang="en-US"/>
+          </a:p>
+        </p:txBody>
       </p:sp>
       <p:sp>
         <p:nvSpPr>
@@ -4408,6 +5238,13 @@
             <a:noFill/>
           </a:ln>
         </p:spPr>
+        <p:txBody>
+          <a:bodyPr/>
+          <a:lstStyle/>
+          <a:p>
+            <a:endParaRPr lang="en-US"/>
+          </a:p>
+        </p:txBody>
       </p:sp>
       <p:sp>
         <p:nvSpPr>
@@ -4474,7 +5311,7 @@
           <a:bodyPr wrap="square" lIns="91440" tIns="68580" rIns="91440" bIns="68580" anchor="t"/>
           <a:lstStyle/>
           <a:p>
-            <a:pPr algn="l" marL="228600" indent="-228600">
+            <a:pPr marL="228600" indent="-228600" algn="l">
               <a:spcAft>
                 <a:spcPts val="500"/>
               </a:spcAft>
@@ -4492,7 +5329,7 @@
             </a:r>
           </a:p>
           <a:p>
-            <a:pPr algn="l" marL="228600" indent="-228600">
+            <a:pPr marL="228600" indent="-228600" algn="l">
               <a:spcAft>
                 <a:spcPts val="500"/>
               </a:spcAft>
@@ -4510,7 +5347,7 @@
             </a:r>
           </a:p>
           <a:p>
-            <a:pPr algn="l" marL="228600" indent="-228600">
+            <a:pPr marL="228600" indent="-228600" algn="l">
               <a:spcAft>
                 <a:spcPts val="500"/>
               </a:spcAft>
@@ -4583,6 +5420,13 @@
             <a:noFill/>
           </a:ln>
         </p:spPr>
+        <p:txBody>
+          <a:bodyPr/>
+          <a:lstStyle/>
+          <a:p>
+            <a:endParaRPr lang="en-US"/>
+          </a:p>
+        </p:txBody>
       </p:sp>
       <p:sp>
         <p:nvSpPr>
@@ -4605,6 +5449,13 @@
             <a:noFill/>
           </a:ln>
         </p:spPr>
+        <p:txBody>
+          <a:bodyPr/>
+          <a:lstStyle/>
+          <a:p>
+            <a:endParaRPr lang="en-US"/>
+          </a:p>
+        </p:txBody>
       </p:sp>
       <p:sp>
         <p:nvSpPr>
@@ -4757,6 +5608,13 @@
             <a:noFill/>
           </a:ln>
         </p:spPr>
+        <p:txBody>
+          <a:bodyPr/>
+          <a:lstStyle/>
+          <a:p>
+            <a:endParaRPr lang="en-US"/>
+          </a:p>
+        </p:txBody>
       </p:sp>
       <p:sp>
         <p:nvSpPr>
@@ -4867,6 +5725,13 @@
             </a:solidFill>
           </a:ln>
         </p:spPr>
+        <p:txBody>
+          <a:bodyPr/>
+          <a:lstStyle/>
+          <a:p>
+            <a:endParaRPr lang="en-US"/>
+          </a:p>
+        </p:txBody>
       </p:sp>
       <p:sp>
         <p:nvSpPr>
@@ -4891,6 +5756,13 @@
             <a:noFill/>
           </a:ln>
         </p:spPr>
+        <p:txBody>
+          <a:bodyPr/>
+          <a:lstStyle/>
+          <a:p>
+            <a:endParaRPr lang="en-US"/>
+          </a:p>
+        </p:txBody>
       </p:sp>
       <p:sp>
         <p:nvSpPr>
@@ -4957,7 +5829,7 @@
           <a:bodyPr wrap="square" lIns="91440" tIns="68580" rIns="91440" bIns="68580" anchor="t"/>
           <a:lstStyle/>
           <a:p>
-            <a:pPr algn="l" marL="228600" indent="-228600">
+            <a:pPr marL="228600" indent="-228600" algn="l">
               <a:spcAft>
                 <a:spcPts val="500"/>
               </a:spcAft>
@@ -4975,7 +5847,7 @@
             </a:r>
           </a:p>
           <a:p>
-            <a:pPr algn="l" marL="228600" indent="-228600">
+            <a:pPr marL="228600" indent="-228600" algn="l">
               <a:spcAft>
                 <a:spcPts val="500"/>
               </a:spcAft>
@@ -4993,7 +5865,7 @@
             </a:r>
           </a:p>
           <a:p>
-            <a:pPr algn="l" marL="228600" indent="-228600">
+            <a:pPr marL="228600" indent="-228600" algn="l">
               <a:spcAft>
                 <a:spcPts val="500"/>
               </a:spcAft>
@@ -5037,6 +5909,13 @@
             </a:solidFill>
           </a:ln>
         </p:spPr>
+        <p:txBody>
+          <a:bodyPr/>
+          <a:lstStyle/>
+          <a:p>
+            <a:endParaRPr lang="en-US"/>
+          </a:p>
+        </p:txBody>
       </p:sp>
       <p:sp>
         <p:nvSpPr>
@@ -5061,6 +5940,13 @@
             <a:noFill/>
           </a:ln>
         </p:spPr>
+        <p:txBody>
+          <a:bodyPr/>
+          <a:lstStyle/>
+          <a:p>
+            <a:endParaRPr lang="en-US"/>
+          </a:p>
+        </p:txBody>
       </p:sp>
       <p:sp>
         <p:nvSpPr>
@@ -5127,7 +6013,7 @@
           <a:bodyPr wrap="square" lIns="91440" tIns="68580" rIns="91440" bIns="68580" anchor="t"/>
           <a:lstStyle/>
           <a:p>
-            <a:pPr algn="l" marL="228600" indent="-228600">
+            <a:pPr marL="228600" indent="-228600" algn="l">
               <a:spcAft>
                 <a:spcPts val="500"/>
               </a:spcAft>
@@ -5145,7 +6031,7 @@
             </a:r>
           </a:p>
           <a:p>
-            <a:pPr algn="l" marL="228600" indent="-228600">
+            <a:pPr marL="228600" indent="-228600" algn="l">
               <a:spcAft>
                 <a:spcPts val="500"/>
               </a:spcAft>
@@ -5163,7 +6049,7 @@
             </a:r>
           </a:p>
           <a:p>
-            <a:pPr algn="l" marL="228600" indent="-228600">
+            <a:pPr marL="228600" indent="-228600" algn="l">
               <a:spcAft>
                 <a:spcPts val="500"/>
               </a:spcAft>
@@ -5181,7 +6067,7 @@
             </a:r>
           </a:p>
           <a:p>
-            <a:pPr algn="l" marL="228600" indent="-228600">
+            <a:pPr marL="228600" indent="-228600" algn="l">
               <a:spcAft>
                 <a:spcPts val="500"/>
               </a:spcAft>
@@ -5254,6 +6140,13 @@
             <a:noFill/>
           </a:ln>
         </p:spPr>
+        <p:txBody>
+          <a:bodyPr/>
+          <a:lstStyle/>
+          <a:p>
+            <a:endParaRPr lang="en-US"/>
+          </a:p>
+        </p:txBody>
       </p:sp>
       <p:sp>
         <p:nvSpPr>
@@ -5276,6 +6169,13 @@
             <a:noFill/>
           </a:ln>
         </p:spPr>
+        <p:txBody>
+          <a:bodyPr/>
+          <a:lstStyle/>
+          <a:p>
+            <a:endParaRPr lang="en-US"/>
+          </a:p>
+        </p:txBody>
       </p:sp>
       <p:sp>
         <p:nvSpPr>
@@ -5428,6 +6328,13 @@
             <a:noFill/>
           </a:ln>
         </p:spPr>
+        <p:txBody>
+          <a:bodyPr/>
+          <a:lstStyle/>
+          <a:p>
+            <a:endParaRPr lang="en-US"/>
+          </a:p>
+        </p:txBody>
       </p:sp>
       <p:sp>
         <p:nvSpPr>
@@ -5538,6 +6445,13 @@
             </a:solidFill>
           </a:ln>
         </p:spPr>
+        <p:txBody>
+          <a:bodyPr/>
+          <a:lstStyle/>
+          <a:p>
+            <a:endParaRPr lang="en-US"/>
+          </a:p>
+        </p:txBody>
       </p:sp>
       <p:sp>
         <p:nvSpPr>
@@ -5562,6 +6476,13 @@
             <a:noFill/>
           </a:ln>
         </p:spPr>
+        <p:txBody>
+          <a:bodyPr/>
+          <a:lstStyle/>
+          <a:p>
+            <a:endParaRPr lang="en-US"/>
+          </a:p>
+        </p:txBody>
       </p:sp>
       <p:sp>
         <p:nvSpPr>
@@ -5628,7 +6549,7 @@
           <a:bodyPr wrap="square" lIns="91440" tIns="68580" rIns="91440" bIns="68580" anchor="t"/>
           <a:lstStyle/>
           <a:p>
-            <a:pPr algn="l" marL="228600" indent="-228600">
+            <a:pPr marL="228600" indent="-228600" algn="l">
               <a:spcAft>
                 <a:spcPts val="500"/>
               </a:spcAft>
@@ -5646,7 +6567,7 @@
             </a:r>
           </a:p>
           <a:p>
-            <a:pPr algn="l" marL="228600" indent="-228600">
+            <a:pPr marL="228600" indent="-228600" algn="l">
               <a:spcAft>
                 <a:spcPts val="500"/>
               </a:spcAft>
@@ -5664,7 +6585,7 @@
             </a:r>
           </a:p>
           <a:p>
-            <a:pPr algn="l" marL="228600" indent="-228600">
+            <a:pPr marL="228600" indent="-228600" algn="l">
               <a:spcAft>
                 <a:spcPts val="500"/>
               </a:spcAft>
@@ -5682,7 +6603,7 @@
             </a:r>
           </a:p>
           <a:p>
-            <a:pPr algn="l" marL="228600" indent="-228600">
+            <a:pPr marL="228600" indent="-228600" algn="l">
               <a:spcAft>
                 <a:spcPts val="500"/>
               </a:spcAft>
@@ -5700,7 +6621,7 @@
             </a:r>
           </a:p>
           <a:p>
-            <a:pPr algn="l" marL="228600" indent="-228600">
+            <a:pPr marL="228600" indent="-228600" algn="l">
               <a:spcAft>
                 <a:spcPts val="500"/>
               </a:spcAft>
@@ -5744,6 +6665,13 @@
             </a:solidFill>
           </a:ln>
         </p:spPr>
+        <p:txBody>
+          <a:bodyPr/>
+          <a:lstStyle/>
+          <a:p>
+            <a:endParaRPr lang="en-US"/>
+          </a:p>
+        </p:txBody>
       </p:sp>
       <p:sp>
         <p:nvSpPr>
@@ -5768,6 +6696,13 @@
             <a:noFill/>
           </a:ln>
         </p:spPr>
+        <p:txBody>
+          <a:bodyPr/>
+          <a:lstStyle/>
+          <a:p>
+            <a:endParaRPr lang="en-US"/>
+          </a:p>
+        </p:txBody>
       </p:sp>
       <p:sp>
         <p:nvSpPr>
@@ -5834,7 +6769,7 @@
           <a:bodyPr wrap="square" lIns="91440" tIns="68580" rIns="91440" bIns="68580" anchor="t"/>
           <a:lstStyle/>
           <a:p>
-            <a:pPr algn="l" marL="228600" indent="-228600">
+            <a:pPr marL="228600" indent="-228600" algn="l">
               <a:spcAft>
                 <a:spcPts val="500"/>
               </a:spcAft>
@@ -5852,7 +6787,7 @@
             </a:r>
           </a:p>
           <a:p>
-            <a:pPr algn="l" marL="228600" indent="-228600">
+            <a:pPr marL="228600" indent="-228600" algn="l">
               <a:spcAft>
                 <a:spcPts val="500"/>
               </a:spcAft>
@@ -5870,7 +6805,7 @@
             </a:r>
           </a:p>
           <a:p>
-            <a:pPr algn="l" marL="228600" indent="-228600">
+            <a:pPr marL="228600" indent="-228600" algn="l">
               <a:spcAft>
                 <a:spcPts val="500"/>
               </a:spcAft>
@@ -5888,7 +6823,7 @@
             </a:r>
           </a:p>
           <a:p>
-            <a:pPr algn="l" marL="228600" indent="-228600">
+            <a:pPr marL="228600" indent="-228600" algn="l">
               <a:spcAft>
                 <a:spcPts val="500"/>
               </a:spcAft>
@@ -5906,7 +6841,7 @@
             </a:r>
           </a:p>
           <a:p>
-            <a:pPr algn="l" marL="228600" indent="-228600">
+            <a:pPr marL="228600" indent="-228600" algn="l">
               <a:spcAft>
                 <a:spcPts val="500"/>
               </a:spcAft>
@@ -5924,7 +6859,7 @@
             </a:r>
           </a:p>
           <a:p>
-            <a:pPr algn="l" marL="228600" indent="-228600">
+            <a:pPr marL="228600" indent="-228600" algn="l">
               <a:spcAft>
                 <a:spcPts val="500"/>
               </a:spcAft>
@@ -5997,6 +6932,13 @@
             <a:noFill/>
           </a:ln>
         </p:spPr>
+        <p:txBody>
+          <a:bodyPr/>
+          <a:lstStyle/>
+          <a:p>
+            <a:endParaRPr lang="en-US"/>
+          </a:p>
+        </p:txBody>
       </p:sp>
       <p:sp>
         <p:nvSpPr>
@@ -6019,6 +6961,13 @@
             <a:noFill/>
           </a:ln>
         </p:spPr>
+        <p:txBody>
+          <a:bodyPr/>
+          <a:lstStyle/>
+          <a:p>
+            <a:endParaRPr lang="en-US"/>
+          </a:p>
+        </p:txBody>
       </p:sp>
       <p:sp>
         <p:nvSpPr>
@@ -6171,6 +7120,13 @@
             <a:noFill/>
           </a:ln>
         </p:spPr>
+        <p:txBody>
+          <a:bodyPr/>
+          <a:lstStyle/>
+          <a:p>
+            <a:endParaRPr lang="en-US"/>
+          </a:p>
+        </p:txBody>
       </p:sp>
       <p:sp>
         <p:nvSpPr>
@@ -6281,6 +7237,13 @@
             </a:solidFill>
           </a:ln>
         </p:spPr>
+        <p:txBody>
+          <a:bodyPr/>
+          <a:lstStyle/>
+          <a:p>
+            <a:endParaRPr lang="en-US"/>
+          </a:p>
+        </p:txBody>
       </p:sp>
       <p:sp>
         <p:nvSpPr>
@@ -6305,6 +7268,13 @@
             <a:noFill/>
           </a:ln>
         </p:spPr>
+        <p:txBody>
+          <a:bodyPr/>
+          <a:lstStyle/>
+          <a:p>
+            <a:endParaRPr lang="en-US"/>
+          </a:p>
+        </p:txBody>
       </p:sp>
       <p:sp>
         <p:nvSpPr>
@@ -6371,7 +7341,7 @@
           <a:bodyPr wrap="square" lIns="91440" tIns="68580" rIns="91440" bIns="68580" anchor="t"/>
           <a:lstStyle/>
           <a:p>
-            <a:pPr algn="l" marL="228600" indent="-228600">
+            <a:pPr marL="228600" indent="-228600" algn="l">
               <a:spcAft>
                 <a:spcPts val="500"/>
               </a:spcAft>
@@ -6415,6 +7385,13 @@
             </a:solidFill>
           </a:ln>
         </p:spPr>
+        <p:txBody>
+          <a:bodyPr/>
+          <a:lstStyle/>
+          <a:p>
+            <a:endParaRPr lang="en-US"/>
+          </a:p>
+        </p:txBody>
       </p:sp>
       <p:sp>
         <p:nvSpPr>
@@ -6439,6 +7416,13 @@
             <a:noFill/>
           </a:ln>
         </p:spPr>
+        <p:txBody>
+          <a:bodyPr/>
+          <a:lstStyle/>
+          <a:p>
+            <a:endParaRPr lang="en-US"/>
+          </a:p>
+        </p:txBody>
       </p:sp>
       <p:sp>
         <p:nvSpPr>
@@ -6505,7 +7489,7 @@
           <a:bodyPr wrap="square" lIns="91440" tIns="68580" rIns="91440" bIns="68580" anchor="t"/>
           <a:lstStyle/>
           <a:p>
-            <a:pPr algn="l" marL="228600" indent="-228600">
+            <a:pPr marL="228600" indent="-228600" algn="l">
               <a:spcAft>
                 <a:spcPts val="500"/>
               </a:spcAft>
@@ -6523,7 +7507,7 @@
             </a:r>
           </a:p>
           <a:p>
-            <a:pPr algn="l" marL="228600" indent="-228600">
+            <a:pPr marL="228600" indent="-228600" algn="l">
               <a:spcAft>
                 <a:spcPts val="500"/>
               </a:spcAft>
@@ -6541,7 +7525,7 @@
             </a:r>
           </a:p>
           <a:p>
-            <a:pPr algn="l" marL="228600" indent="-228600">
+            <a:pPr marL="228600" indent="-228600" algn="l">
               <a:spcAft>
                 <a:spcPts val="500"/>
               </a:spcAft>
@@ -6559,7 +7543,7 @@
             </a:r>
           </a:p>
           <a:p>
-            <a:pPr algn="l" marL="228600" indent="-228600">
+            <a:pPr marL="228600" indent="-228600" algn="l">
               <a:spcAft>
                 <a:spcPts val="500"/>
               </a:spcAft>
@@ -6577,7 +7561,7 @@
             </a:r>
           </a:p>
           <a:p>
-            <a:pPr algn="l" marL="228600" indent="-228600">
+            <a:pPr marL="228600" indent="-228600" algn="l">
               <a:spcAft>
                 <a:spcPts val="500"/>
               </a:spcAft>
@@ -6595,7 +7579,7 @@
             </a:r>
           </a:p>
           <a:p>
-            <a:pPr algn="l" marL="228600" indent="-228600">
+            <a:pPr marL="228600" indent="-228600" algn="l">
               <a:spcAft>
                 <a:spcPts val="500"/>
               </a:spcAft>
@@ -6639,6 +7623,13 @@
             </a:solidFill>
           </a:ln>
         </p:spPr>
+        <p:txBody>
+          <a:bodyPr/>
+          <a:lstStyle/>
+          <a:p>
+            <a:endParaRPr lang="en-US"/>
+          </a:p>
+        </p:txBody>
       </p:sp>
       <p:sp>
         <p:nvSpPr>
@@ -6663,6 +7654,13 @@
             <a:noFill/>
           </a:ln>
         </p:spPr>
+        <p:txBody>
+          <a:bodyPr/>
+          <a:lstStyle/>
+          <a:p>
+            <a:endParaRPr lang="en-US"/>
+          </a:p>
+        </p:txBody>
       </p:sp>
       <p:sp>
         <p:nvSpPr>
@@ -6729,7 +7727,7 @@
           <a:bodyPr wrap="square" lIns="91440" tIns="68580" rIns="91440" bIns="68580" anchor="t"/>
           <a:lstStyle/>
           <a:p>
-            <a:pPr algn="l" marL="228600" indent="-228600">
+            <a:pPr marL="228600" indent="-228600" algn="l">
               <a:spcAft>
                 <a:spcPts val="500"/>
               </a:spcAft>
@@ -6747,7 +7745,7 @@
             </a:r>
           </a:p>
           <a:p>
-            <a:pPr algn="l" marL="228600" indent="-228600">
+            <a:pPr marL="228600" indent="-228600" algn="l">
               <a:spcAft>
                 <a:spcPts val="500"/>
               </a:spcAft>
@@ -6765,7 +7763,7 @@
             </a:r>
           </a:p>
           <a:p>
-            <a:pPr algn="l" marL="228600" indent="-228600">
+            <a:pPr marL="228600" indent="-228600" algn="l">
               <a:spcAft>
                 <a:spcPts val="500"/>
               </a:spcAft>
@@ -6783,7 +7781,7 @@
             </a:r>
           </a:p>
           <a:p>
-            <a:pPr algn="l" marL="228600" indent="-228600">
+            <a:pPr marL="228600" indent="-228600" algn="l">
               <a:spcAft>
                 <a:spcPts val="500"/>
               </a:spcAft>
@@ -6801,7 +7799,7 @@
             </a:r>
           </a:p>
           <a:p>
-            <a:pPr algn="l" marL="228600" indent="-228600">
+            <a:pPr marL="228600" indent="-228600" algn="l">
               <a:spcAft>
                 <a:spcPts val="500"/>
               </a:spcAft>
@@ -6819,7 +7817,7 @@
             </a:r>
           </a:p>
           <a:p>
-            <a:pPr algn="l" marL="228600" indent="-228600">
+            <a:pPr marL="228600" indent="-228600" algn="l">
               <a:spcAft>
                 <a:spcPts val="500"/>
               </a:spcAft>
@@ -6863,6 +7861,13 @@
             </a:solidFill>
           </a:ln>
         </p:spPr>
+        <p:txBody>
+          <a:bodyPr/>
+          <a:lstStyle/>
+          <a:p>
+            <a:endParaRPr lang="en-US"/>
+          </a:p>
+        </p:txBody>
       </p:sp>
       <p:sp>
         <p:nvSpPr>
@@ -6887,6 +7892,13 @@
             <a:noFill/>
           </a:ln>
         </p:spPr>
+        <p:txBody>
+          <a:bodyPr/>
+          <a:lstStyle/>
+          <a:p>
+            <a:endParaRPr lang="en-US"/>
+          </a:p>
+        </p:txBody>
       </p:sp>
       <p:sp>
         <p:nvSpPr>
@@ -6953,7 +7965,7 @@
           <a:bodyPr wrap="square" lIns="91440" tIns="68580" rIns="91440" bIns="68580" anchor="t"/>
           <a:lstStyle/>
           <a:p>
-            <a:pPr algn="l" marL="228600" indent="-228600">
+            <a:pPr marL="228600" indent="-228600" algn="l">
               <a:spcAft>
                 <a:spcPts val="500"/>
               </a:spcAft>
@@ -6971,7 +7983,7 @@
             </a:r>
           </a:p>
           <a:p>
-            <a:pPr algn="l" marL="228600" indent="-228600">
+            <a:pPr marL="228600" indent="-228600" algn="l">
               <a:spcAft>
                 <a:spcPts val="500"/>
               </a:spcAft>
@@ -6989,7 +8001,7 @@
             </a:r>
           </a:p>
           <a:p>
-            <a:pPr algn="l" marL="228600" indent="-228600">
+            <a:pPr marL="228600" indent="-228600" algn="l">
               <a:spcAft>
                 <a:spcPts val="500"/>
               </a:spcAft>
@@ -7007,7 +8019,7 @@
             </a:r>
           </a:p>
           <a:p>
-            <a:pPr algn="l" marL="228600" indent="-228600">
+            <a:pPr marL="228600" indent="-228600" algn="l">
               <a:spcAft>
                 <a:spcPts val="500"/>
               </a:spcAft>
@@ -7025,7 +8037,7 @@
             </a:r>
           </a:p>
           <a:p>
-            <a:pPr algn="l" marL="228600" indent="-228600">
+            <a:pPr marL="228600" indent="-228600" algn="l">
               <a:spcAft>
                 <a:spcPts val="500"/>
               </a:spcAft>
@@ -7043,7 +8055,7 @@
             </a:r>
           </a:p>
           <a:p>
-            <a:pPr algn="l" marL="228600" indent="-228600">
+            <a:pPr marL="228600" indent="-228600" algn="l">
               <a:spcAft>
                 <a:spcPts val="500"/>
               </a:spcAft>
@@ -7116,6 +8128,13 @@
             <a:noFill/>
           </a:ln>
         </p:spPr>
+        <p:txBody>
+          <a:bodyPr/>
+          <a:lstStyle/>
+          <a:p>
+            <a:endParaRPr lang="en-US"/>
+          </a:p>
+        </p:txBody>
       </p:sp>
       <p:sp>
         <p:nvSpPr>
@@ -7138,6 +8157,13 @@
             <a:noFill/>
           </a:ln>
         </p:spPr>
+        <p:txBody>
+          <a:bodyPr/>
+          <a:lstStyle/>
+          <a:p>
+            <a:endParaRPr lang="en-US"/>
+          </a:p>
+        </p:txBody>
       </p:sp>
       <p:sp>
         <p:nvSpPr>
@@ -7290,6 +8316,13 @@
             <a:noFill/>
           </a:ln>
         </p:spPr>
+        <p:txBody>
+          <a:bodyPr/>
+          <a:lstStyle/>
+          <a:p>
+            <a:endParaRPr lang="en-US"/>
+          </a:p>
+        </p:txBody>
       </p:sp>
       <p:sp>
         <p:nvSpPr>
@@ -7400,6 +8433,13 @@
             </a:solidFill>
           </a:ln>
         </p:spPr>
+        <p:txBody>
+          <a:bodyPr/>
+          <a:lstStyle/>
+          <a:p>
+            <a:endParaRPr lang="en-US"/>
+          </a:p>
+        </p:txBody>
       </p:sp>
       <p:sp>
         <p:nvSpPr>
@@ -7424,6 +8464,13 @@
             <a:noFill/>
           </a:ln>
         </p:spPr>
+        <p:txBody>
+          <a:bodyPr/>
+          <a:lstStyle/>
+          <a:p>
+            <a:endParaRPr lang="en-US"/>
+          </a:p>
+        </p:txBody>
       </p:sp>
       <p:sp>
         <p:nvSpPr>
@@ -7768,6 +8815,13 @@
             </a:solidFill>
           </a:ln>
         </p:spPr>
+        <p:txBody>
+          <a:bodyPr/>
+          <a:lstStyle/>
+          <a:p>
+            <a:endParaRPr lang="en-US"/>
+          </a:p>
+        </p:txBody>
       </p:sp>
       <p:sp>
         <p:nvSpPr>
@@ -7792,6 +8846,13 @@
             <a:noFill/>
           </a:ln>
         </p:spPr>
+        <p:txBody>
+          <a:bodyPr/>
+          <a:lstStyle/>
+          <a:p>
+            <a:endParaRPr lang="en-US"/>
+          </a:p>
+        </p:txBody>
       </p:sp>
       <p:sp>
         <p:nvSpPr>
@@ -8165,6 +9226,13 @@
             <a:noFill/>
           </a:ln>
         </p:spPr>
+        <p:txBody>
+          <a:bodyPr/>
+          <a:lstStyle/>
+          <a:p>
+            <a:endParaRPr lang="en-US"/>
+          </a:p>
+        </p:txBody>
       </p:sp>
       <p:sp>
         <p:nvSpPr>
@@ -8187,6 +9255,13 @@
             <a:noFill/>
           </a:ln>
         </p:spPr>
+        <p:txBody>
+          <a:bodyPr/>
+          <a:lstStyle/>
+          <a:p>
+            <a:endParaRPr lang="en-US"/>
+          </a:p>
+        </p:txBody>
       </p:sp>
       <p:sp>
         <p:nvSpPr>
@@ -8339,6 +9414,13 @@
             <a:noFill/>
           </a:ln>
         </p:spPr>
+        <p:txBody>
+          <a:bodyPr/>
+          <a:lstStyle/>
+          <a:p>
+            <a:endParaRPr lang="en-US"/>
+          </a:p>
+        </p:txBody>
       </p:sp>
       <p:sp>
         <p:nvSpPr>
@@ -8426,590 +9508,6 @@
       </p:sp>
       <p:sp>
         <p:nvSpPr>
-          <p:cNvPr id="10" name="Rect10"/>
-          <p:cNvSpPr/>
-          <p:nvPr/>
-        </p:nvSpPr>
-        <p:spPr>
-          <a:xfrm>
-            <a:off x="502920" y="1508760"/>
-            <a:ext cx="2560320" cy="1920240"/>
-          </a:xfrm>
-          <a:prstGeom prst="roundRect">
-            <a:avLst>
-              <a:gd name="adj" fmla="val 4000"/>
-            </a:avLst>
-          </a:prstGeom>
-          <a:solidFill>
-            <a:srgbClr val="FFFFFF"/>
-          </a:solidFill>
-          <a:ln w="12700">
-            <a:solidFill>
-              <a:srgbClr val="CBD5E1"/>
-            </a:solidFill>
-          </a:ln>
-        </p:spPr>
-      </p:sp>
-      <p:sp>
-        <p:nvSpPr>
-          <p:cNvPr id="11" name="Rect11"/>
-          <p:cNvSpPr/>
-          <p:nvPr/>
-        </p:nvSpPr>
-        <p:spPr>
-          <a:xfrm>
-            <a:off x="502920" y="1508760"/>
-            <a:ext cx="2560320" cy="384048"/>
-          </a:xfrm>
-          <a:prstGeom prst="roundRect">
-            <a:avLst>
-              <a:gd name="adj" fmla="val 4000"/>
-            </a:avLst>
-          </a:prstGeom>
-          <a:solidFill>
-            <a:srgbClr val="0F172A"/>
-          </a:solidFill>
-          <a:ln>
-            <a:noFill/>
-          </a:ln>
-        </p:spPr>
-      </p:sp>
-      <p:sp>
-        <p:nvSpPr>
-          <p:cNvPr id="12" name="TextBox12"/>
-          <p:cNvSpPr txBox="1"/>
-          <p:nvPr/>
-        </p:nvSpPr>
-        <p:spPr>
-          <a:xfrm>
-            <a:off x="667512" y="1554480"/>
-            <a:ext cx="2231136" cy="310896"/>
-          </a:xfrm>
-          <a:prstGeom prst="rect">
-            <a:avLst/>
-          </a:prstGeom>
-          <a:noFill/>
-          <a:ln>
-            <a:noFill/>
-          </a:ln>
-        </p:spPr>
-        <p:txBody>
-          <a:bodyPr wrap="square" lIns="0" tIns="0" rIns="0" bIns="0" anchor="ctr"/>
-          <a:lstStyle/>
-          <a:p>
-            <a:pPr algn="l">
-              <a:spcAft>
-                <a:spcPts val="400"/>
-              </a:spcAft>
-              <a:buNone/>
-            </a:pPr>
-            <a:r>
-              <a:rPr lang="id-ID" sz="1300" b="1" i="0" dirty="0">
-                <a:solidFill>
-                  <a:srgbClr val="FFFFFF"/>
-                </a:solidFill>
-                <a:latin typeface="Calibri"/>
-                <a:cs typeface="Calibri"/>
-              </a:rPr>
-              <a:t>1. MULAI &amp; INPUT</a:t>
-            </a:r>
-          </a:p>
-        </p:txBody>
-      </p:sp>
-      <p:sp>
-        <p:nvSpPr>
-          <p:cNvPr id="13" name="TextBox13"/>
-          <p:cNvSpPr txBox="1"/>
-          <p:nvPr/>
-        </p:nvSpPr>
-        <p:spPr>
-          <a:xfrm>
-            <a:off x="640080" y="1947672"/>
-            <a:ext cx="2286000" cy="1417320"/>
-          </a:xfrm>
-          <a:prstGeom prst="rect">
-            <a:avLst/>
-          </a:prstGeom>
-          <a:noFill/>
-          <a:ln>
-            <a:noFill/>
-          </a:ln>
-        </p:spPr>
-        <p:txBody>
-          <a:bodyPr wrap="square" lIns="91440" tIns="68580" rIns="91440" bIns="68580" anchor="t"/>
-          <a:lstStyle/>
-          <a:p>
-            <a:pPr algn="ctr">
-              <a:spcAft>
-                <a:spcPts val="400"/>
-              </a:spcAft>
-              <a:buNone/>
-            </a:pPr>
-            <a:r>
-              <a:rPr lang="id-ID" sz="1200" b="0" i="0" dirty="0">
-                <a:solidFill>
-                  <a:srgbClr val="1E293B"/>
-                </a:solidFill>
-                <a:latin typeface="Calibri"/>
-                <a:cs typeface="Calibri"/>
-              </a:rPr>
-              <a:t>Input ID (id) &amp;
-Nama Pelanggan (nama);
-Tampilkan Daftar 5 Film</a:t>
-            </a:r>
-          </a:p>
-        </p:txBody>
-      </p:sp>
-      <p:sp>
-        <p:nvSpPr>
-          <p:cNvPr id="14" name="TextBox14"/>
-          <p:cNvSpPr txBox="1"/>
-          <p:nvPr/>
-        </p:nvSpPr>
-        <p:spPr>
-          <a:xfrm>
-            <a:off x="3063240" y="2194560"/>
-            <a:ext cx="274320" cy="457200"/>
-          </a:xfrm>
-          <a:prstGeom prst="rect">
-            <a:avLst/>
-          </a:prstGeom>
-          <a:noFill/>
-          <a:ln>
-            <a:noFill/>
-          </a:ln>
-        </p:spPr>
-        <p:txBody>
-          <a:bodyPr wrap="square" lIns="0" tIns="0" rIns="0" bIns="0" anchor="t"/>
-          <a:lstStyle/>
-          <a:p>
-            <a:pPr algn="ctr">
-              <a:spcAft>
-                <a:spcPts val="400"/>
-              </a:spcAft>
-              <a:buNone/>
-            </a:pPr>
-            <a:r>
-              <a:rPr lang="id-ID" sz="2000" b="1" i="0" dirty="0">
-                <a:solidFill>
-                  <a:srgbClr val="0284C7"/>
-                </a:solidFill>
-                <a:latin typeface="Calibri"/>
-                <a:cs typeface="Calibri"/>
-              </a:rPr>
-              <a:t>➔</a:t>
-            </a:r>
-          </a:p>
-        </p:txBody>
-      </p:sp>
-      <p:sp>
-        <p:nvSpPr>
-          <p:cNvPr id="15" name="Rect15"/>
-          <p:cNvSpPr/>
-          <p:nvPr/>
-        </p:nvSpPr>
-        <p:spPr>
-          <a:xfrm>
-            <a:off x="3337560" y="1508760"/>
-            <a:ext cx="2560320" cy="1920240"/>
-          </a:xfrm>
-          <a:prstGeom prst="roundRect">
-            <a:avLst>
-              <a:gd name="adj" fmla="val 4000"/>
-            </a:avLst>
-          </a:prstGeom>
-          <a:solidFill>
-            <a:srgbClr val="FFFFFF"/>
-          </a:solidFill>
-          <a:ln w="12700">
-            <a:solidFill>
-              <a:srgbClr val="CBD5E1"/>
-            </a:solidFill>
-          </a:ln>
-        </p:spPr>
-      </p:sp>
-      <p:sp>
-        <p:nvSpPr>
-          <p:cNvPr id="16" name="Rect16"/>
-          <p:cNvSpPr/>
-          <p:nvPr/>
-        </p:nvSpPr>
-        <p:spPr>
-          <a:xfrm>
-            <a:off x="3337560" y="1508760"/>
-            <a:ext cx="2560320" cy="384048"/>
-          </a:xfrm>
-          <a:prstGeom prst="roundRect">
-            <a:avLst>
-              <a:gd name="adj" fmla="val 4000"/>
-            </a:avLst>
-          </a:prstGeom>
-          <a:solidFill>
-            <a:srgbClr val="0284C7"/>
-          </a:solidFill>
-          <a:ln>
-            <a:noFill/>
-          </a:ln>
-        </p:spPr>
-      </p:sp>
-      <p:sp>
-        <p:nvSpPr>
-          <p:cNvPr id="17" name="TextBox17"/>
-          <p:cNvSpPr txBox="1"/>
-          <p:nvPr/>
-        </p:nvSpPr>
-        <p:spPr>
-          <a:xfrm>
-            <a:off x="3502152" y="1554480"/>
-            <a:ext cx="2231136" cy="310896"/>
-          </a:xfrm>
-          <a:prstGeom prst="rect">
-            <a:avLst/>
-          </a:prstGeom>
-          <a:noFill/>
-          <a:ln>
-            <a:noFill/>
-          </a:ln>
-        </p:spPr>
-        <p:txBody>
-          <a:bodyPr wrap="square" lIns="0" tIns="0" rIns="0" bIns="0" anchor="ctr"/>
-          <a:lstStyle/>
-          <a:p>
-            <a:pPr algn="l">
-              <a:spcAft>
-                <a:spcPts val="400"/>
-              </a:spcAft>
-              <a:buNone/>
-            </a:pPr>
-            <a:r>
-              <a:rPr lang="id-ID" sz="1300" b="1" i="0" dirty="0">
-                <a:solidFill>
-                  <a:srgbClr val="FFFFFF"/>
-                </a:solidFill>
-                <a:latin typeface="Calibri"/>
-                <a:cs typeface="Calibri"/>
-              </a:rPr>
-              <a:t>2. PILIH FILM</a:t>
-            </a:r>
-          </a:p>
-        </p:txBody>
-      </p:sp>
-      <p:sp>
-        <p:nvSpPr>
-          <p:cNvPr id="18" name="TextBox18"/>
-          <p:cNvSpPr txBox="1"/>
-          <p:nvPr/>
-        </p:nvSpPr>
-        <p:spPr>
-          <a:xfrm>
-            <a:off x="3474720" y="1947672"/>
-            <a:ext cx="2286000" cy="1417320"/>
-          </a:xfrm>
-          <a:prstGeom prst="rect">
-            <a:avLst/>
-          </a:prstGeom>
-          <a:noFill/>
-          <a:ln>
-            <a:noFill/>
-          </a:ln>
-        </p:spPr>
-        <p:txBody>
-          <a:bodyPr wrap="square" lIns="91440" tIns="68580" rIns="91440" bIns="68580" anchor="t"/>
-          <a:lstStyle/>
-          <a:p>
-            <a:pPr algn="ctr">
-              <a:spcAft>
-                <a:spcPts val="400"/>
-              </a:spcAft>
-              <a:buNone/>
-            </a:pPr>
-            <a:r>
-              <a:rPr lang="id-ID" sz="1200" b="0" i="0" dirty="0">
-                <a:solidFill>
-                  <a:srgbClr val="1E293B"/>
-                </a:solidFill>
-                <a:latin typeface="Calibri"/>
-                <a:cs typeface="Calibri"/>
-              </a:rPr>
-              <a:t>Masukkan Nomor Film
-(pilih 1-5) di dalam
-perulangan do-while</a:t>
-            </a:r>
-          </a:p>
-        </p:txBody>
-      </p:sp>
-      <p:sp>
-        <p:nvSpPr>
-          <p:cNvPr id="19" name="TextBox19"/>
-          <p:cNvSpPr txBox="1"/>
-          <p:nvPr/>
-        </p:nvSpPr>
-        <p:spPr>
-          <a:xfrm>
-            <a:off x="5897880" y="2194560"/>
-            <a:ext cx="274320" cy="457200"/>
-          </a:xfrm>
-          <a:prstGeom prst="rect">
-            <a:avLst/>
-          </a:prstGeom>
-          <a:noFill/>
-          <a:ln>
-            <a:noFill/>
-          </a:ln>
-        </p:spPr>
-        <p:txBody>
-          <a:bodyPr wrap="square" lIns="0" tIns="0" rIns="0" bIns="0" anchor="t"/>
-          <a:lstStyle/>
-          <a:p>
-            <a:pPr algn="ctr">
-              <a:spcAft>
-                <a:spcPts val="400"/>
-              </a:spcAft>
-              <a:buNone/>
-            </a:pPr>
-            <a:r>
-              <a:rPr lang="id-ID" sz="2000" b="1" i="0" dirty="0">
-                <a:solidFill>
-                  <a:srgbClr val="0284C7"/>
-                </a:solidFill>
-                <a:latin typeface="Calibri"/>
-                <a:cs typeface="Calibri"/>
-              </a:rPr>
-              <a:t>➔</a:t>
-            </a:r>
-          </a:p>
-        </p:txBody>
-      </p:sp>
-      <p:sp>
-        <p:nvSpPr>
-          <p:cNvPr id="20" name="Rect20"/>
-          <p:cNvSpPr/>
-          <p:nvPr/>
-        </p:nvSpPr>
-        <p:spPr>
-          <a:xfrm>
-            <a:off x="6172200" y="1508760"/>
-            <a:ext cx="2560320" cy="1920240"/>
-          </a:xfrm>
-          <a:prstGeom prst="roundRect">
-            <a:avLst>
-              <a:gd name="adj" fmla="val 4000"/>
-            </a:avLst>
-          </a:prstGeom>
-          <a:solidFill>
-            <a:srgbClr val="FFFFFF"/>
-          </a:solidFill>
-          <a:ln w="12700">
-            <a:solidFill>
-              <a:srgbClr val="CBD5E1"/>
-            </a:solidFill>
-          </a:ln>
-        </p:spPr>
-      </p:sp>
-      <p:sp>
-        <p:nvSpPr>
-          <p:cNvPr id="21" name="Rect21"/>
-          <p:cNvSpPr/>
-          <p:nvPr/>
-        </p:nvSpPr>
-        <p:spPr>
-          <a:xfrm>
-            <a:off x="6172200" y="1508760"/>
-            <a:ext cx="2560320" cy="384048"/>
-          </a:xfrm>
-          <a:prstGeom prst="roundRect">
-            <a:avLst>
-              <a:gd name="adj" fmla="val 4000"/>
-            </a:avLst>
-          </a:prstGeom>
-          <a:solidFill>
-            <a:srgbClr val="D97706"/>
-          </a:solidFill>
-          <a:ln>
-            <a:noFill/>
-          </a:ln>
-        </p:spPr>
-      </p:sp>
-      <p:sp>
-        <p:nvSpPr>
-          <p:cNvPr id="22" name="TextBox22"/>
-          <p:cNvSpPr txBox="1"/>
-          <p:nvPr/>
-        </p:nvSpPr>
-        <p:spPr>
-          <a:xfrm>
-            <a:off x="6336792" y="1554480"/>
-            <a:ext cx="2231136" cy="310896"/>
-          </a:xfrm>
-          <a:prstGeom prst="rect">
-            <a:avLst/>
-          </a:prstGeom>
-          <a:noFill/>
-          <a:ln>
-            <a:noFill/>
-          </a:ln>
-        </p:spPr>
-        <p:txBody>
-          <a:bodyPr wrap="square" lIns="0" tIns="0" rIns="0" bIns="0" anchor="ctr"/>
-          <a:lstStyle/>
-          <a:p>
-            <a:pPr algn="l">
-              <a:spcAft>
-                <a:spcPts val="400"/>
-              </a:spcAft>
-              <a:buNone/>
-            </a:pPr>
-            <a:r>
-              <a:rPr lang="id-ID" sz="1300" b="1" i="0" dirty="0">
-                <a:solidFill>
-                  <a:srgbClr val="FFFFFF"/>
-                </a:solidFill>
-                <a:latin typeface="Calibri"/>
-                <a:cs typeface="Calibri"/>
-              </a:rPr>
-              <a:t>3. VALIDASI STOK</a:t>
-            </a:r>
-          </a:p>
-        </p:txBody>
-      </p:sp>
-      <p:sp>
-        <p:nvSpPr>
-          <p:cNvPr id="23" name="TextBox23"/>
-          <p:cNvSpPr txBox="1"/>
-          <p:nvPr/>
-        </p:nvSpPr>
-        <p:spPr>
-          <a:xfrm>
-            <a:off x="6309360" y="1947672"/>
-            <a:ext cx="2286000" cy="1417320"/>
-          </a:xfrm>
-          <a:prstGeom prst="rect">
-            <a:avLst/>
-          </a:prstGeom>
-          <a:noFill/>
-          <a:ln>
-            <a:noFill/>
-          </a:ln>
-        </p:spPr>
-        <p:txBody>
-          <a:bodyPr wrap="square" lIns="91440" tIns="68580" rIns="91440" bIns="68580" anchor="t"/>
-          <a:lstStyle/>
-          <a:p>
-            <a:pPr algn="ctr">
-              <a:spcAft>
-                <a:spcPts val="400"/>
-              </a:spcAft>
-              <a:buNone/>
-            </a:pPr>
-            <a:r>
-              <a:rPr lang="id-ID" sz="1200" b="0" i="0" dirty="0">
-                <a:solidFill>
-                  <a:srgbClr val="1E293B"/>
-                </a:solidFill>
-                <a:latin typeface="Calibri"/>
-                <a:cs typeface="Calibri"/>
-              </a:rPr>
-              <a:t>Cek switch(pilih) &amp; STOK:
-Jika valid &amp; tersedia -&gt; Lanjut
-Jika tidak -&gt; Ulangi input</a:t>
-            </a:r>
-          </a:p>
-        </p:txBody>
-      </p:sp>
-      <p:sp>
-        <p:nvSpPr>
-          <p:cNvPr id="24" name="TextBox24"/>
-          <p:cNvSpPr txBox="1"/>
-          <p:nvPr/>
-        </p:nvSpPr>
-        <p:spPr>
-          <a:xfrm>
-            <a:off x="8732520" y="2194560"/>
-            <a:ext cx="274320" cy="457200"/>
-          </a:xfrm>
-          <a:prstGeom prst="rect">
-            <a:avLst/>
-          </a:prstGeom>
-          <a:noFill/>
-          <a:ln>
-            <a:noFill/>
-          </a:ln>
-        </p:spPr>
-        <p:txBody>
-          <a:bodyPr wrap="square" lIns="0" tIns="0" rIns="0" bIns="0" anchor="t"/>
-          <a:lstStyle/>
-          <a:p>
-            <a:pPr algn="ctr">
-              <a:spcAft>
-                <a:spcPts val="400"/>
-              </a:spcAft>
-              <a:buNone/>
-            </a:pPr>
-            <a:r>
-              <a:rPr lang="id-ID" sz="2000" b="1" i="0" dirty="0">
-                <a:solidFill>
-                  <a:srgbClr val="0284C7"/>
-                </a:solidFill>
-                <a:latin typeface="Calibri"/>
-                <a:cs typeface="Calibri"/>
-              </a:rPr>
-              <a:t>➔</a:t>
-            </a:r>
-          </a:p>
-        </p:txBody>
-      </p:sp>
-      <p:sp>
-        <p:nvSpPr>
-          <p:cNvPr id="25" name="Rect25"/>
-          <p:cNvSpPr/>
-          <p:nvPr/>
-        </p:nvSpPr>
-        <p:spPr>
-          <a:xfrm>
-            <a:off x="9006840" y="1508760"/>
-            <a:ext cx="2560320" cy="1920240"/>
-          </a:xfrm>
-          <a:prstGeom prst="roundRect">
-            <a:avLst>
-              <a:gd name="adj" fmla="val 4000"/>
-            </a:avLst>
-          </a:prstGeom>
-          <a:solidFill>
-            <a:srgbClr val="FFFFFF"/>
-          </a:solidFill>
-          <a:ln w="12700">
-            <a:solidFill>
-              <a:srgbClr val="CBD5E1"/>
-            </a:solidFill>
-          </a:ln>
-        </p:spPr>
-      </p:sp>
-      <p:sp>
-        <p:nvSpPr>
-          <p:cNvPr id="26" name="Rect26"/>
-          <p:cNvSpPr/>
-          <p:nvPr/>
-        </p:nvSpPr>
-        <p:spPr>
-          <a:xfrm>
-            <a:off x="9006840" y="1508760"/>
-            <a:ext cx="2560320" cy="384048"/>
-          </a:xfrm>
-          <a:prstGeom prst="roundRect">
-            <a:avLst>
-              <a:gd name="adj" fmla="val 4000"/>
-            </a:avLst>
-          </a:prstGeom>
-          <a:solidFill>
-            <a:srgbClr val="7C3AED"/>
-          </a:solidFill>
-          <a:ln>
-            <a:noFill/>
-          </a:ln>
-        </p:spPr>
-      </p:sp>
-      <p:sp>
-        <p:nvSpPr>
           <p:cNvPr id="27" name="TextBox27"/>
           <p:cNvSpPr txBox="1"/>
           <p:nvPr/>
@@ -9050,761 +9548,42 @@
           </a:p>
         </p:txBody>
       </p:sp>
-      <p:sp>
-        <p:nvSpPr>
-          <p:cNvPr id="28" name="TextBox28"/>
-          <p:cNvSpPr txBox="1"/>
-          <p:nvPr/>
-        </p:nvSpPr>
-        <p:spPr>
-          <a:xfrm>
-            <a:off x="9144000" y="1947672"/>
-            <a:ext cx="2286000" cy="1417320"/>
-          </a:xfrm>
-          <a:prstGeom prst="rect">
-            <a:avLst/>
-          </a:prstGeom>
-          <a:noFill/>
-          <a:ln>
-            <a:noFill/>
-          </a:ln>
-        </p:spPr>
-        <p:txBody>
-          <a:bodyPr wrap="square" lIns="91440" tIns="68580" rIns="91440" bIns="68580" anchor="t"/>
-          <a:lstStyle/>
-          <a:p>
-            <a:pPr algn="ctr">
-              <a:spcAft>
-                <a:spcPts val="400"/>
-              </a:spcAft>
-              <a:buNone/>
-            </a:pPr>
-            <a:r>
-              <a:rPr lang="id-ID" sz="1200" b="0" i="0" dirty="0">
-                <a:solidFill>
-                  <a:srgbClr val="1E293B"/>
-                </a:solidFill>
-                <a:latin typeface="Calibri"/>
-                <a:cs typeface="Calibri"/>
-              </a:rPr>
-              <a:t>Input lama peminjaman;
-Tanya Perpanjang? (y/n)
-Jika 'y': lama += tambah</a:t>
-            </a:r>
-          </a:p>
-        </p:txBody>
-      </p:sp>
-      <p:sp>
-        <p:nvSpPr>
-          <p:cNvPr id="29" name="TextBox29"/>
-          <p:cNvSpPr txBox="1"/>
-          <p:nvPr/>
-        </p:nvSpPr>
-        <p:spPr>
-          <a:xfrm>
-            <a:off x="9784080" y="3474720"/>
-            <a:ext cx="1097280" cy="411480"/>
-          </a:xfrm>
-          <a:prstGeom prst="rect">
-            <a:avLst/>
-          </a:prstGeom>
-          <a:noFill/>
-          <a:ln>
-            <a:noFill/>
-          </a:ln>
-        </p:spPr>
-        <p:txBody>
-          <a:bodyPr wrap="square" lIns="0" tIns="0" rIns="0" bIns="0" anchor="t"/>
-          <a:lstStyle/>
-          <a:p>
-            <a:pPr algn="ctr">
-              <a:spcAft>
-                <a:spcPts val="400"/>
-              </a:spcAft>
-              <a:buNone/>
-            </a:pPr>
-            <a:r>
-              <a:rPr lang="id-ID" sz="1300" b="1" i="0" dirty="0">
-                <a:solidFill>
-                  <a:srgbClr val="0284C7"/>
-                </a:solidFill>
-                <a:latin typeface="Calibri"/>
-                <a:cs typeface="Calibri"/>
-              </a:rPr>
-              <a:t>⬇ Lanjut</a:t>
-            </a:r>
-          </a:p>
-        </p:txBody>
-      </p:sp>
-      <p:sp>
-        <p:nvSpPr>
-          <p:cNvPr id="30" name="Rect30"/>
-          <p:cNvSpPr/>
-          <p:nvPr/>
-        </p:nvSpPr>
-        <p:spPr>
-          <a:xfrm>
-            <a:off x="502920" y="3977639"/>
-            <a:ext cx="2560320" cy="1920240"/>
-          </a:xfrm>
-          <a:prstGeom prst="roundRect">
-            <a:avLst>
-              <a:gd name="adj" fmla="val 4000"/>
-            </a:avLst>
-          </a:prstGeom>
-          <a:solidFill>
-            <a:srgbClr val="FFFFFF"/>
-          </a:solidFill>
-          <a:ln w="12700">
-            <a:solidFill>
-              <a:srgbClr val="CBD5E1"/>
-            </a:solidFill>
-          </a:ln>
-        </p:spPr>
-      </p:sp>
-      <p:sp>
-        <p:nvSpPr>
-          <p:cNvPr id="31" name="Rect31"/>
-          <p:cNvSpPr/>
-          <p:nvPr/>
-        </p:nvSpPr>
-        <p:spPr>
-          <a:xfrm>
-            <a:off x="502920" y="3977639"/>
-            <a:ext cx="2560320" cy="384048"/>
-          </a:xfrm>
-          <a:prstGeom prst="roundRect">
-            <a:avLst>
-              <a:gd name="adj" fmla="val 4000"/>
-            </a:avLst>
-          </a:prstGeom>
-          <a:solidFill>
-            <a:srgbClr val="0284C7"/>
-          </a:solidFill>
-          <a:ln>
-            <a:noFill/>
-          </a:ln>
-        </p:spPr>
-      </p:sp>
-      <p:sp>
-        <p:nvSpPr>
-          <p:cNvPr id="32" name="TextBox32"/>
-          <p:cNvSpPr txBox="1"/>
-          <p:nvPr/>
-        </p:nvSpPr>
-        <p:spPr>
-          <a:xfrm>
-            <a:off x="667512" y="4023359"/>
-            <a:ext cx="2231136" cy="310896"/>
-          </a:xfrm>
-          <a:prstGeom prst="rect">
-            <a:avLst/>
-          </a:prstGeom>
-          <a:noFill/>
-          <a:ln>
-            <a:noFill/>
-          </a:ln>
-        </p:spPr>
-        <p:txBody>
-          <a:bodyPr wrap="square" lIns="0" tIns="0" rIns="0" bIns="0" anchor="ctr"/>
-          <a:lstStyle/>
-          <a:p>
-            <a:pPr algn="l">
-              <a:spcAft>
-                <a:spcPts val="400"/>
-              </a:spcAft>
-              <a:buNone/>
-            </a:pPr>
-            <a:r>
-              <a:rPr lang="id-ID" sz="1300" b="1" i="0" dirty="0">
-                <a:solidFill>
-                  <a:srgbClr val="FFFFFF"/>
-                </a:solidFill>
-                <a:latin typeface="Calibri"/>
-                <a:cs typeface="Calibri"/>
-              </a:rPr>
-              <a:t>5. HARI KEMBALI</a:t>
-            </a:r>
-          </a:p>
-        </p:txBody>
-      </p:sp>
-      <p:sp>
-        <p:nvSpPr>
-          <p:cNvPr id="33" name="TextBox33"/>
-          <p:cNvSpPr txBox="1"/>
-          <p:nvPr/>
-        </p:nvSpPr>
-        <p:spPr>
-          <a:xfrm>
-            <a:off x="640080" y="4416551"/>
-            <a:ext cx="2286000" cy="1417320"/>
-          </a:xfrm>
-          <a:prstGeom prst="rect">
-            <a:avLst/>
-          </a:prstGeom>
-          <a:noFill/>
-          <a:ln>
-            <a:noFill/>
-          </a:ln>
-        </p:spPr>
-        <p:txBody>
-          <a:bodyPr wrap="square" lIns="91440" tIns="68580" rIns="91440" bIns="68580" anchor="t"/>
-          <a:lstStyle/>
-          <a:p>
-            <a:pPr algn="ctr">
-              <a:spcAft>
-                <a:spcPts val="400"/>
-              </a:spcAft>
-              <a:buNone/>
-            </a:pPr>
-            <a:r>
-              <a:rPr lang="id-ID" sz="1200" b="0" i="0" dirty="0">
-                <a:solidFill>
-                  <a:srgbClr val="1E293B"/>
-                </a:solidFill>
-                <a:latin typeface="Calibri"/>
-                <a:cs typeface="Calibri"/>
-              </a:rPr>
-              <a:t>Input hariKembali;
-Hitung biaya = harga * lama</a:t>
-            </a:r>
-          </a:p>
-        </p:txBody>
-      </p:sp>
-      <p:sp>
-        <p:nvSpPr>
-          <p:cNvPr id="34" name="TextBox34"/>
-          <p:cNvSpPr txBox="1"/>
-          <p:nvPr/>
-        </p:nvSpPr>
-        <p:spPr>
-          <a:xfrm>
-            <a:off x="3063240" y="4663439"/>
-            <a:ext cx="274320" cy="457200"/>
-          </a:xfrm>
-          <a:prstGeom prst="rect">
-            <a:avLst/>
-          </a:prstGeom>
-          <a:noFill/>
-          <a:ln>
-            <a:noFill/>
-          </a:ln>
-        </p:spPr>
-        <p:txBody>
-          <a:bodyPr wrap="square" lIns="0" tIns="0" rIns="0" bIns="0" anchor="t"/>
-          <a:lstStyle/>
-          <a:p>
-            <a:pPr algn="ctr">
-              <a:spcAft>
-                <a:spcPts val="400"/>
-              </a:spcAft>
-              <a:buNone/>
-            </a:pPr>
-            <a:r>
-              <a:rPr lang="id-ID" sz="2000" b="1" i="0" dirty="0">
-                <a:solidFill>
-                  <a:srgbClr val="0284C7"/>
-                </a:solidFill>
-                <a:latin typeface="Calibri"/>
-                <a:cs typeface="Calibri"/>
-              </a:rPr>
-              <a:t>➔</a:t>
-            </a:r>
-          </a:p>
-        </p:txBody>
-      </p:sp>
-      <p:sp>
-        <p:nvSpPr>
-          <p:cNvPr id="35" name="Rect35"/>
-          <p:cNvSpPr/>
-          <p:nvPr/>
-        </p:nvSpPr>
-        <p:spPr>
-          <a:xfrm>
-            <a:off x="3337560" y="3977639"/>
-            <a:ext cx="2560320" cy="1920240"/>
-          </a:xfrm>
-          <a:prstGeom prst="roundRect">
-            <a:avLst>
-              <a:gd name="adj" fmla="val 4000"/>
-            </a:avLst>
-          </a:prstGeom>
-          <a:solidFill>
-            <a:srgbClr val="FFFFFF"/>
-          </a:solidFill>
-          <a:ln w="12700">
-            <a:solidFill>
-              <a:srgbClr val="CBD5E1"/>
-            </a:solidFill>
-          </a:ln>
-        </p:spPr>
-      </p:sp>
-      <p:sp>
-        <p:nvSpPr>
-          <p:cNvPr id="36" name="Rect36"/>
-          <p:cNvSpPr/>
-          <p:nvPr/>
-        </p:nvSpPr>
-        <p:spPr>
-          <a:xfrm>
-            <a:off x="3337560" y="3977639"/>
-            <a:ext cx="2560320" cy="384048"/>
-          </a:xfrm>
-          <a:prstGeom prst="roundRect">
-            <a:avLst>
-              <a:gd name="adj" fmla="val 4000"/>
-            </a:avLst>
-          </a:prstGeom>
-          <a:solidFill>
-            <a:srgbClr val="DC2626"/>
-          </a:solidFill>
-          <a:ln>
-            <a:noFill/>
-          </a:ln>
-        </p:spPr>
-      </p:sp>
-      <p:sp>
-        <p:nvSpPr>
-          <p:cNvPr id="37" name="TextBox37"/>
-          <p:cNvSpPr txBox="1"/>
-          <p:nvPr/>
-        </p:nvSpPr>
-        <p:spPr>
-          <a:xfrm>
-            <a:off x="3502152" y="4023359"/>
-            <a:ext cx="2231136" cy="310896"/>
-          </a:xfrm>
-          <a:prstGeom prst="rect">
-            <a:avLst/>
-          </a:prstGeom>
-          <a:noFill/>
-          <a:ln>
-            <a:noFill/>
-          </a:ln>
-        </p:spPr>
-        <p:txBody>
-          <a:bodyPr wrap="square" lIns="0" tIns="0" rIns="0" bIns="0" anchor="ctr"/>
-          <a:lstStyle/>
-          <a:p>
-            <a:pPr algn="l">
-              <a:spcAft>
-                <a:spcPts val="400"/>
-              </a:spcAft>
-              <a:buNone/>
-            </a:pPr>
-            <a:r>
-              <a:rPr lang="id-ID" sz="1300" b="1" i="0" dirty="0">
-                <a:solidFill>
-                  <a:srgbClr val="FFFFFF"/>
-                </a:solidFill>
-                <a:latin typeface="Calibri"/>
-                <a:cs typeface="Calibri"/>
-              </a:rPr>
-              <a:t>6. CEK TERLAMBAT</a:t>
-            </a:r>
-          </a:p>
-        </p:txBody>
-      </p:sp>
-      <p:sp>
-        <p:nvSpPr>
-          <p:cNvPr id="38" name="TextBox38"/>
-          <p:cNvSpPr txBox="1"/>
-          <p:nvPr/>
-        </p:nvSpPr>
-        <p:spPr>
-          <a:xfrm>
-            <a:off x="3474720" y="4416551"/>
-            <a:ext cx="2286000" cy="1417320"/>
-          </a:xfrm>
-          <a:prstGeom prst="rect">
-            <a:avLst/>
-          </a:prstGeom>
-          <a:noFill/>
-          <a:ln>
-            <a:noFill/>
-          </a:ln>
-        </p:spPr>
-        <p:txBody>
-          <a:bodyPr wrap="square" lIns="91440" tIns="68580" rIns="91440" bIns="68580" anchor="t"/>
-          <a:lstStyle/>
-          <a:p>
-            <a:pPr algn="ctr">
-              <a:spcAft>
-                <a:spcPts val="400"/>
-              </a:spcAft>
-              <a:buNone/>
-            </a:pPr>
-            <a:r>
-              <a:rPr lang="id-ID" sz="1200" b="0" i="0" dirty="0">
-                <a:solidFill>
-                  <a:srgbClr val="1E293B"/>
-                </a:solidFill>
-                <a:latin typeface="Calibri"/>
-                <a:cs typeface="Calibri"/>
-              </a:rPr>
-              <a:t>Apakah hariKembali &gt; lama?
-Ya: denda=(hariKembali-lama)*2000
-Tidak: denda = 0</a:t>
-            </a:r>
-          </a:p>
-        </p:txBody>
-      </p:sp>
-      <p:sp>
-        <p:nvSpPr>
-          <p:cNvPr id="39" name="TextBox39"/>
-          <p:cNvSpPr txBox="1"/>
-          <p:nvPr/>
-        </p:nvSpPr>
-        <p:spPr>
-          <a:xfrm>
-            <a:off x="5897880" y="4663439"/>
-            <a:ext cx="274320" cy="457200"/>
-          </a:xfrm>
-          <a:prstGeom prst="rect">
-            <a:avLst/>
-          </a:prstGeom>
-          <a:noFill/>
-          <a:ln>
-            <a:noFill/>
-          </a:ln>
-        </p:spPr>
-        <p:txBody>
-          <a:bodyPr wrap="square" lIns="0" tIns="0" rIns="0" bIns="0" anchor="t"/>
-          <a:lstStyle/>
-          <a:p>
-            <a:pPr algn="ctr">
-              <a:spcAft>
-                <a:spcPts val="400"/>
-              </a:spcAft>
-              <a:buNone/>
-            </a:pPr>
-            <a:r>
-              <a:rPr lang="id-ID" sz="2000" b="1" i="0" dirty="0">
-                <a:solidFill>
-                  <a:srgbClr val="0284C7"/>
-                </a:solidFill>
-                <a:latin typeface="Calibri"/>
-                <a:cs typeface="Calibri"/>
-              </a:rPr>
-              <a:t>➔</a:t>
-            </a:r>
-          </a:p>
-        </p:txBody>
-      </p:sp>
-      <p:sp>
-        <p:nvSpPr>
-          <p:cNvPr id="40" name="Rect40"/>
-          <p:cNvSpPr/>
-          <p:nvPr/>
-        </p:nvSpPr>
-        <p:spPr>
-          <a:xfrm>
-            <a:off x="6172200" y="3977639"/>
-            <a:ext cx="2560320" cy="1920240"/>
-          </a:xfrm>
-          <a:prstGeom prst="roundRect">
-            <a:avLst>
-              <a:gd name="adj" fmla="val 4000"/>
-            </a:avLst>
-          </a:prstGeom>
-          <a:solidFill>
-            <a:srgbClr val="FFFFFF"/>
-          </a:solidFill>
-          <a:ln w="12700">
-            <a:solidFill>
-              <a:srgbClr val="CBD5E1"/>
-            </a:solidFill>
-          </a:ln>
-        </p:spPr>
-      </p:sp>
-      <p:sp>
-        <p:nvSpPr>
-          <p:cNvPr id="41" name="Rect41"/>
-          <p:cNvSpPr/>
-          <p:nvPr/>
-        </p:nvSpPr>
-        <p:spPr>
-          <a:xfrm>
-            <a:off x="6172200" y="3977639"/>
-            <a:ext cx="2560320" cy="384048"/>
-          </a:xfrm>
-          <a:prstGeom prst="roundRect">
-            <a:avLst>
-              <a:gd name="adj" fmla="val 4000"/>
-            </a:avLst>
-          </a:prstGeom>
-          <a:solidFill>
-            <a:srgbClr val="059669"/>
-          </a:solidFill>
-          <a:ln>
-            <a:noFill/>
-          </a:ln>
-        </p:spPr>
-      </p:sp>
-      <p:sp>
-        <p:nvSpPr>
-          <p:cNvPr id="42" name="TextBox42"/>
-          <p:cNvSpPr txBox="1"/>
-          <p:nvPr/>
-        </p:nvSpPr>
-        <p:spPr>
-          <a:xfrm>
-            <a:off x="6336792" y="4023359"/>
-            <a:ext cx="2231136" cy="310896"/>
-          </a:xfrm>
-          <a:prstGeom prst="rect">
-            <a:avLst/>
-          </a:prstGeom>
-          <a:noFill/>
-          <a:ln>
-            <a:noFill/>
-          </a:ln>
-        </p:spPr>
-        <p:txBody>
-          <a:bodyPr wrap="square" lIns="0" tIns="0" rIns="0" bIns="0" anchor="ctr"/>
-          <a:lstStyle/>
-          <a:p>
-            <a:pPr algn="l">
-              <a:spcAft>
-                <a:spcPts val="400"/>
-              </a:spcAft>
-              <a:buNone/>
-            </a:pPr>
-            <a:r>
-              <a:rPr lang="id-ID" sz="1300" b="1" i="0" dirty="0">
-                <a:solidFill>
-                  <a:srgbClr val="FFFFFF"/>
-                </a:solidFill>
-                <a:latin typeface="Calibri"/>
-                <a:cs typeface="Calibri"/>
-              </a:rPr>
-              <a:t>7. STATUS KEMBALI</a:t>
-            </a:r>
-          </a:p>
-        </p:txBody>
-      </p:sp>
-      <p:sp>
-        <p:nvSpPr>
-          <p:cNvPr id="43" name="TextBox43"/>
-          <p:cNvSpPr txBox="1"/>
-          <p:nvPr/>
-        </p:nvSpPr>
-        <p:spPr>
-          <a:xfrm>
-            <a:off x="6309360" y="4416551"/>
-            <a:ext cx="2286000" cy="1417320"/>
-          </a:xfrm>
-          <a:prstGeom prst="rect">
-            <a:avLst/>
-          </a:prstGeom>
-          <a:noFill/>
-          <a:ln>
-            <a:noFill/>
-          </a:ln>
-        </p:spPr>
-        <p:txBody>
-          <a:bodyPr wrap="square" lIns="91440" tIns="68580" rIns="91440" bIns="68580" anchor="t"/>
-          <a:lstStyle/>
-          <a:p>
-            <a:pPr algn="ctr">
-              <a:spcAft>
-                <a:spcPts val="400"/>
-              </a:spcAft>
-              <a:buNone/>
-            </a:pPr>
-            <a:r>
-              <a:rPr lang="id-ID" sz="1200" b="0" i="0" dirty="0">
-                <a:solidFill>
-                  <a:srgbClr val="1E293B"/>
-                </a:solidFill>
-                <a:latin typeface="Calibri"/>
-                <a:cs typeface="Calibri"/>
-              </a:rPr>
-              <a:t>Ya -&gt; status = 'Terlambat'
-Tidak -&gt; status = 'Tepat waktu'
-Hitung Total = biaya + denda</a:t>
-            </a:r>
-          </a:p>
-        </p:txBody>
-      </p:sp>
-      <p:sp>
-        <p:nvSpPr>
-          <p:cNvPr id="44" name="TextBox44"/>
-          <p:cNvSpPr txBox="1"/>
-          <p:nvPr/>
-        </p:nvSpPr>
-        <p:spPr>
-          <a:xfrm>
-            <a:off x="8732520" y="4663439"/>
-            <a:ext cx="274320" cy="457200"/>
-          </a:xfrm>
-          <a:prstGeom prst="rect">
-            <a:avLst/>
-          </a:prstGeom>
-          <a:noFill/>
-          <a:ln>
-            <a:noFill/>
-          </a:ln>
-        </p:spPr>
-        <p:txBody>
-          <a:bodyPr wrap="square" lIns="0" tIns="0" rIns="0" bIns="0" anchor="t"/>
-          <a:lstStyle/>
-          <a:p>
-            <a:pPr algn="ctr">
-              <a:spcAft>
-                <a:spcPts val="400"/>
-              </a:spcAft>
-              <a:buNone/>
-            </a:pPr>
-            <a:r>
-              <a:rPr lang="id-ID" sz="2000" b="1" i="0" dirty="0">
-                <a:solidFill>
-                  <a:srgbClr val="0284C7"/>
-                </a:solidFill>
-                <a:latin typeface="Calibri"/>
-                <a:cs typeface="Calibri"/>
-              </a:rPr>
-              <a:t>➔</a:t>
-            </a:r>
-          </a:p>
-        </p:txBody>
-      </p:sp>
-      <p:sp>
-        <p:nvSpPr>
-          <p:cNvPr id="45" name="Rect45"/>
-          <p:cNvSpPr/>
-          <p:nvPr/>
-        </p:nvSpPr>
-        <p:spPr>
-          <a:xfrm>
-            <a:off x="9006840" y="3977639"/>
-            <a:ext cx="2560320" cy="1920240"/>
-          </a:xfrm>
-          <a:prstGeom prst="roundRect">
-            <a:avLst>
-              <a:gd name="adj" fmla="val 4000"/>
-            </a:avLst>
-          </a:prstGeom>
-          <a:solidFill>
-            <a:srgbClr val="FFFFFF"/>
-          </a:solidFill>
-          <a:ln w="12700">
-            <a:solidFill>
-              <a:srgbClr val="CBD5E1"/>
-            </a:solidFill>
-          </a:ln>
-        </p:spPr>
-      </p:sp>
-      <p:sp>
-        <p:nvSpPr>
-          <p:cNvPr id="46" name="Rect46"/>
-          <p:cNvSpPr/>
-          <p:nvPr/>
-        </p:nvSpPr>
-        <p:spPr>
-          <a:xfrm>
-            <a:off x="9006840" y="3977639"/>
-            <a:ext cx="2560320" cy="384048"/>
-          </a:xfrm>
-          <a:prstGeom prst="roundRect">
-            <a:avLst>
-              <a:gd name="adj" fmla="val 4000"/>
-            </a:avLst>
-          </a:prstGeom>
-          <a:solidFill>
-            <a:srgbClr val="0F172A"/>
-          </a:solidFill>
-          <a:ln>
-            <a:noFill/>
-          </a:ln>
-        </p:spPr>
-      </p:sp>
-      <p:sp>
-        <p:nvSpPr>
-          <p:cNvPr id="47" name="TextBox47"/>
-          <p:cNvSpPr txBox="1"/>
-          <p:nvPr/>
-        </p:nvSpPr>
-        <p:spPr>
-          <a:xfrm>
-            <a:off x="9171432" y="4023359"/>
-            <a:ext cx="2231136" cy="310896"/>
-          </a:xfrm>
-          <a:prstGeom prst="rect">
-            <a:avLst/>
-          </a:prstGeom>
-          <a:noFill/>
-          <a:ln>
-            <a:noFill/>
-          </a:ln>
-        </p:spPr>
-        <p:txBody>
-          <a:bodyPr wrap="square" lIns="0" tIns="0" rIns="0" bIns="0" anchor="ctr"/>
-          <a:lstStyle/>
-          <a:p>
-            <a:pPr algn="l">
-              <a:spcAft>
-                <a:spcPts val="400"/>
-              </a:spcAft>
-              <a:buNone/>
-            </a:pPr>
-            <a:r>
-              <a:rPr lang="id-ID" sz="1300" b="1" i="0" dirty="0">
-                <a:solidFill>
-                  <a:srgbClr val="FFFFFF"/>
-                </a:solidFill>
-                <a:latin typeface="Calibri"/>
-                <a:cs typeface="Calibri"/>
-              </a:rPr>
-              <a:t>8. BUKTI &amp; SELESAI</a:t>
-            </a:r>
-          </a:p>
-        </p:txBody>
-      </p:sp>
-      <p:sp>
-        <p:nvSpPr>
-          <p:cNvPr id="48" name="TextBox48"/>
-          <p:cNvSpPr txBox="1"/>
-          <p:nvPr/>
-        </p:nvSpPr>
-        <p:spPr>
-          <a:xfrm>
-            <a:off x="9144000" y="4416551"/>
-            <a:ext cx="2286000" cy="1417320"/>
-          </a:xfrm>
-          <a:prstGeom prst="rect">
-            <a:avLst/>
-          </a:prstGeom>
-          <a:noFill/>
-          <a:ln>
-            <a:noFill/>
-          </a:ln>
-        </p:spPr>
-        <p:txBody>
-          <a:bodyPr wrap="square" lIns="91440" tIns="68580" rIns="91440" bIns="68580" anchor="t"/>
-          <a:lstStyle/>
-          <a:p>
-            <a:pPr algn="ctr">
-              <a:spcAft>
-                <a:spcPts val="400"/>
-              </a:spcAft>
-              <a:buNone/>
-            </a:pPr>
-            <a:r>
-              <a:rPr lang="id-ID" sz="1200" b="0" i="0" dirty="0">
-                <a:solidFill>
-                  <a:srgbClr val="1E293B"/>
-                </a:solidFill>
-                <a:latin typeface="Calibri"/>
-                <a:cs typeface="Calibri"/>
-              </a:rPr>
-              <a:t>Cetak BUKTI RENTAL
-lengkap ke layar
--&gt; SELESAI</a:t>
-            </a:r>
-          </a:p>
-        </p:txBody>
-      </p:sp>
+      <p:pic>
+        <p:nvPicPr>
+          <p:cNvPr id="54" name="Picture 53">
+            <a:extLst>
+              <a:ext uri="{FF2B5EF4-FFF2-40B4-BE49-F238E27FC236}">
+                <a16:creationId xmlns:a16="http://schemas.microsoft.com/office/drawing/2014/main" id="{C99DE75D-0EFD-58B2-48C0-F7591474AF60}"/>
+              </a:ext>
+            </a:extLst>
+          </p:cNvPr>
+          <p:cNvPicPr>
+            <a:picLocks noChangeAspect="1"/>
+          </p:cNvPicPr>
+          <p:nvPr/>
+        </p:nvPicPr>
+        <p:blipFill>
+          <a:blip r:embed="rId2">
+            <a:extLst>
+              <a:ext uri="{28A0092B-C50C-407E-A947-70E740481C1C}">
+                <a14:useLocalDpi xmlns:a14="http://schemas.microsoft.com/office/drawing/2010/main" val="0"/>
+              </a:ext>
+            </a:extLst>
+          </a:blip>
+          <a:stretch>
+            <a:fillRect/>
+          </a:stretch>
+        </p:blipFill>
+        <p:spPr>
+          <a:xfrm>
+            <a:off x="3808814" y="1179576"/>
+            <a:ext cx="3689265" cy="5274553"/>
+          </a:xfrm>
+          <a:prstGeom prst="rect">
+            <a:avLst/>
+          </a:prstGeom>
+        </p:spPr>
+      </p:pic>
     </p:spTree>
   </p:cSld>
   <p:clrMapOvr>
@@ -9859,6 +9638,13 @@
             <a:noFill/>
           </a:ln>
         </p:spPr>
+        <p:txBody>
+          <a:bodyPr/>
+          <a:lstStyle/>
+          <a:p>
+            <a:endParaRPr lang="en-US"/>
+          </a:p>
+        </p:txBody>
       </p:sp>
       <p:sp>
         <p:nvSpPr>
@@ -9881,6 +9667,13 @@
             <a:noFill/>
           </a:ln>
         </p:spPr>
+        <p:txBody>
+          <a:bodyPr/>
+          <a:lstStyle/>
+          <a:p>
+            <a:endParaRPr lang="en-US"/>
+          </a:p>
+        </p:txBody>
       </p:sp>
       <p:sp>
         <p:nvSpPr>
@@ -10033,6 +9826,13 @@
             <a:noFill/>
           </a:ln>
         </p:spPr>
+        <p:txBody>
+          <a:bodyPr/>
+          <a:lstStyle/>
+          <a:p>
+            <a:endParaRPr lang="en-US"/>
+          </a:p>
+        </p:txBody>
       </p:sp>
       <p:sp>
         <p:nvSpPr>
@@ -10143,6 +9943,13 @@
             </a:solidFill>
           </a:ln>
         </p:spPr>
+        <p:txBody>
+          <a:bodyPr/>
+          <a:lstStyle/>
+          <a:p>
+            <a:endParaRPr lang="en-US"/>
+          </a:p>
+        </p:txBody>
       </p:sp>
       <p:sp>
         <p:nvSpPr>
@@ -10167,6 +9974,13 @@
             <a:noFill/>
           </a:ln>
         </p:spPr>
+        <p:txBody>
+          <a:bodyPr/>
+          <a:lstStyle/>
+          <a:p>
+            <a:endParaRPr lang="en-US"/>
+          </a:p>
+        </p:txBody>
       </p:sp>
       <p:sp>
         <p:nvSpPr>
@@ -10233,7 +10047,7 @@
           <a:bodyPr wrap="square" lIns="91440" tIns="68580" rIns="91440" bIns="68580" anchor="t"/>
           <a:lstStyle/>
           <a:p>
-            <a:pPr algn="l" marL="228600" indent="-228600">
+            <a:pPr marL="228600" indent="-228600" algn="l">
               <a:spcAft>
                 <a:spcPts val="500"/>
               </a:spcAft>
@@ -10251,7 +10065,7 @@
             </a:r>
           </a:p>
           <a:p>
-            <a:pPr algn="l" marL="228600" indent="-228600">
+            <a:pPr marL="228600" indent="-228600" algn="l">
               <a:spcAft>
                 <a:spcPts val="500"/>
               </a:spcAft>
@@ -10269,7 +10083,7 @@
             </a:r>
           </a:p>
           <a:p>
-            <a:pPr algn="l" marL="228600" indent="-228600">
+            <a:pPr marL="228600" indent="-228600" algn="l">
               <a:spcAft>
                 <a:spcPts val="500"/>
               </a:spcAft>
@@ -10287,7 +10101,7 @@
             </a:r>
           </a:p>
           <a:p>
-            <a:pPr algn="l" marL="228600" indent="-228600">
+            <a:pPr marL="228600" indent="-228600" algn="l">
               <a:spcAft>
                 <a:spcPts val="500"/>
               </a:spcAft>
@@ -10305,7 +10119,7 @@
             </a:r>
           </a:p>
           <a:p>
-            <a:pPr algn="l" marL="228600" indent="-228600">
+            <a:pPr marL="228600" indent="-228600" algn="l">
               <a:spcAft>
                 <a:spcPts val="500"/>
               </a:spcAft>
@@ -10349,6 +10163,13 @@
             </a:solidFill>
           </a:ln>
         </p:spPr>
+        <p:txBody>
+          <a:bodyPr/>
+          <a:lstStyle/>
+          <a:p>
+            <a:endParaRPr lang="en-US"/>
+          </a:p>
+        </p:txBody>
       </p:sp>
       <p:sp>
         <p:nvSpPr>
@@ -10373,6 +10194,13 @@
             <a:noFill/>
           </a:ln>
         </p:spPr>
+        <p:txBody>
+          <a:bodyPr/>
+          <a:lstStyle/>
+          <a:p>
+            <a:endParaRPr lang="en-US"/>
+          </a:p>
+        </p:txBody>
       </p:sp>
       <p:sp>
         <p:nvSpPr>
@@ -10439,7 +10267,7 @@
           <a:bodyPr wrap="square" lIns="91440" tIns="68580" rIns="91440" bIns="68580" anchor="t"/>
           <a:lstStyle/>
           <a:p>
-            <a:pPr algn="l" marL="228600" indent="-228600">
+            <a:pPr marL="228600" indent="-228600" algn="l">
               <a:spcAft>
                 <a:spcPts val="500"/>
               </a:spcAft>
@@ -10457,7 +10285,7 @@
             </a:r>
           </a:p>
           <a:p>
-            <a:pPr algn="l" marL="228600" indent="-228600">
+            <a:pPr marL="228600" indent="-228600" algn="l">
               <a:spcAft>
                 <a:spcPts val="500"/>
               </a:spcAft>
@@ -10475,7 +10303,7 @@
             </a:r>
           </a:p>
           <a:p>
-            <a:pPr algn="l" marL="228600" indent="-228600">
+            <a:pPr marL="228600" indent="-228600" algn="l">
               <a:spcAft>
                 <a:spcPts val="500"/>
               </a:spcAft>
@@ -10493,7 +10321,7 @@
             </a:r>
           </a:p>
           <a:p>
-            <a:pPr algn="l" marL="228600" indent="-228600">
+            <a:pPr marL="228600" indent="-228600" algn="l">
               <a:spcAft>
                 <a:spcPts val="500"/>
               </a:spcAft>
@@ -10511,7 +10339,7 @@
             </a:r>
           </a:p>
           <a:p>
-            <a:pPr algn="l" marL="228600" indent="-228600">
+            <a:pPr marL="228600" indent="-228600" algn="l">
               <a:spcAft>
                 <a:spcPts val="500"/>
               </a:spcAft>
@@ -10529,7 +10357,7 @@
             </a:r>
           </a:p>
           <a:p>
-            <a:pPr algn="l" marL="228600" indent="-228600">
+            <a:pPr marL="228600" indent="-228600" algn="l">
               <a:spcAft>
                 <a:spcPts val="500"/>
               </a:spcAft>
@@ -10602,6 +10430,13 @@
             <a:noFill/>
           </a:ln>
         </p:spPr>
+        <p:txBody>
+          <a:bodyPr/>
+          <a:lstStyle/>
+          <a:p>
+            <a:endParaRPr lang="en-US"/>
+          </a:p>
+        </p:txBody>
       </p:sp>
       <p:sp>
         <p:nvSpPr>
@@ -10624,6 +10459,13 @@
             <a:noFill/>
           </a:ln>
         </p:spPr>
+        <p:txBody>
+          <a:bodyPr/>
+          <a:lstStyle/>
+          <a:p>
+            <a:endParaRPr lang="en-US"/>
+          </a:p>
+        </p:txBody>
       </p:sp>
       <p:sp>
         <p:nvSpPr>
@@ -10776,6 +10618,13 @@
             <a:noFill/>
           </a:ln>
         </p:spPr>
+        <p:txBody>
+          <a:bodyPr/>
+          <a:lstStyle/>
+          <a:p>
+            <a:endParaRPr lang="en-US"/>
+          </a:p>
+        </p:txBody>
       </p:sp>
       <p:sp>
         <p:nvSpPr>
@@ -10886,6 +10735,13 @@
             </a:solidFill>
           </a:ln>
         </p:spPr>
+        <p:txBody>
+          <a:bodyPr/>
+          <a:lstStyle/>
+          <a:p>
+            <a:endParaRPr lang="en-US"/>
+          </a:p>
+        </p:txBody>
       </p:sp>
       <p:sp>
         <p:nvSpPr>
@@ -10910,6 +10766,13 @@
             <a:noFill/>
           </a:ln>
         </p:spPr>
+        <p:txBody>
+          <a:bodyPr/>
+          <a:lstStyle/>
+          <a:p>
+            <a:endParaRPr lang="en-US"/>
+          </a:p>
+        </p:txBody>
       </p:sp>
       <p:sp>
         <p:nvSpPr>
@@ -11326,6 +11189,13 @@
             </a:solidFill>
           </a:ln>
         </p:spPr>
+        <p:txBody>
+          <a:bodyPr/>
+          <a:lstStyle/>
+          <a:p>
+            <a:endParaRPr lang="en-US"/>
+          </a:p>
+        </p:txBody>
       </p:sp>
       <p:sp>
         <p:nvSpPr>
@@ -11350,6 +11220,13 @@
             <a:noFill/>
           </a:ln>
         </p:spPr>
+        <p:txBody>
+          <a:bodyPr/>
+          <a:lstStyle/>
+          <a:p>
+            <a:endParaRPr lang="en-US"/>
+          </a:p>
+        </p:txBody>
       </p:sp>
       <p:sp>
         <p:nvSpPr>
@@ -11416,7 +11293,7 @@
           <a:bodyPr wrap="square" lIns="91440" tIns="68580" rIns="91440" bIns="68580" anchor="t"/>
           <a:lstStyle/>
           <a:p>
-            <a:pPr algn="l" marL="228600" indent="-228600">
+            <a:pPr marL="228600" indent="-228600" algn="l">
               <a:spcAft>
                 <a:spcPts val="500"/>
               </a:spcAft>
@@ -11434,7 +11311,7 @@
             </a:r>
           </a:p>
           <a:p>
-            <a:pPr algn="l" marL="228600" indent="-228600">
+            <a:pPr marL="228600" indent="-228600" algn="l">
               <a:spcAft>
                 <a:spcPts val="500"/>
               </a:spcAft>
@@ -11452,7 +11329,7 @@
             </a:r>
           </a:p>
           <a:p>
-            <a:pPr algn="l" marL="228600" indent="-228600">
+            <a:pPr marL="228600" indent="-228600" algn="l">
               <a:spcAft>
                 <a:spcPts val="500"/>
               </a:spcAft>
@@ -11470,7 +11347,7 @@
             </a:r>
           </a:p>
           <a:p>
-            <a:pPr algn="l" marL="228600" indent="-228600">
+            <a:pPr marL="228600" indent="-228600" algn="l">
               <a:spcAft>
                 <a:spcPts val="500"/>
               </a:spcAft>
@@ -11488,7 +11365,7 @@
             </a:r>
           </a:p>
           <a:p>
-            <a:pPr algn="l" marL="228600" indent="-228600">
+            <a:pPr marL="228600" indent="-228600" algn="l">
               <a:spcAft>
                 <a:spcPts val="500"/>
               </a:spcAft>
@@ -11506,7 +11383,7 @@
             </a:r>
           </a:p>
           <a:p>
-            <a:pPr algn="l" marL="228600" indent="-228600">
+            <a:pPr marL="228600" indent="-228600" algn="l">
               <a:spcAft>
                 <a:spcPts val="500"/>
               </a:spcAft>
@@ -11579,6 +11456,13 @@
             <a:noFill/>
           </a:ln>
         </p:spPr>
+        <p:txBody>
+          <a:bodyPr/>
+          <a:lstStyle/>
+          <a:p>
+            <a:endParaRPr lang="en-US"/>
+          </a:p>
+        </p:txBody>
       </p:sp>
       <p:sp>
         <p:nvSpPr>
@@ -11601,6 +11485,13 @@
             <a:noFill/>
           </a:ln>
         </p:spPr>
+        <p:txBody>
+          <a:bodyPr/>
+          <a:lstStyle/>
+          <a:p>
+            <a:endParaRPr lang="en-US"/>
+          </a:p>
+        </p:txBody>
       </p:sp>
       <p:sp>
         <p:nvSpPr>
@@ -11753,6 +11644,13 @@
             <a:noFill/>
           </a:ln>
         </p:spPr>
+        <p:txBody>
+          <a:bodyPr/>
+          <a:lstStyle/>
+          <a:p>
+            <a:endParaRPr lang="en-US"/>
+          </a:p>
+        </p:txBody>
       </p:sp>
       <p:sp>
         <p:nvSpPr>
@@ -11863,6 +11761,13 @@
             </a:solidFill>
           </a:ln>
         </p:spPr>
+        <p:txBody>
+          <a:bodyPr/>
+          <a:lstStyle/>
+          <a:p>
+            <a:endParaRPr lang="en-US"/>
+          </a:p>
+        </p:txBody>
       </p:sp>
       <p:sp>
         <p:nvSpPr>
@@ -11887,6 +11792,13 @@
             <a:noFill/>
           </a:ln>
         </p:spPr>
+        <p:txBody>
+          <a:bodyPr/>
+          <a:lstStyle/>
+          <a:p>
+            <a:endParaRPr lang="en-US"/>
+          </a:p>
+        </p:txBody>
       </p:sp>
       <p:sp>
         <p:nvSpPr>
@@ -11953,7 +11865,7 @@
           <a:bodyPr wrap="square" lIns="91440" tIns="68580" rIns="91440" bIns="68580" anchor="t"/>
           <a:lstStyle/>
           <a:p>
-            <a:pPr algn="l" marL="228600" indent="-228600">
+            <a:pPr marL="228600" indent="-228600" algn="l">
               <a:spcAft>
                 <a:spcPts val="500"/>
               </a:spcAft>
@@ -11971,7 +11883,7 @@
             </a:r>
           </a:p>
           <a:p>
-            <a:pPr algn="l" marL="228600" indent="-228600">
+            <a:pPr marL="228600" indent="-228600" algn="l">
               <a:spcAft>
                 <a:spcPts val="500"/>
               </a:spcAft>
@@ -11989,7 +11901,7 @@
             </a:r>
           </a:p>
           <a:p>
-            <a:pPr algn="l" marL="228600" indent="-228600">
+            <a:pPr marL="228600" indent="-228600" algn="l">
               <a:spcAft>
                 <a:spcPts val="500"/>
               </a:spcAft>
@@ -12007,7 +11919,7 @@
             </a:r>
           </a:p>
           <a:p>
-            <a:pPr algn="l" marL="228600" indent="-228600">
+            <a:pPr marL="228600" indent="-228600" algn="l">
               <a:spcAft>
                 <a:spcPts val="500"/>
               </a:spcAft>
@@ -12025,7 +11937,7 @@
             </a:r>
           </a:p>
           <a:p>
-            <a:pPr algn="l" marL="228600" indent="-228600">
+            <a:pPr marL="228600" indent="-228600" algn="l">
               <a:spcAft>
                 <a:spcPts val="500"/>
               </a:spcAft>
@@ -12043,7 +11955,7 @@
             </a:r>
           </a:p>
           <a:p>
-            <a:pPr algn="l" marL="228600" indent="-228600">
+            <a:pPr marL="228600" indent="-228600" algn="l">
               <a:spcAft>
                 <a:spcPts val="500"/>
               </a:spcAft>
@@ -12061,7 +11973,7 @@
             </a:r>
           </a:p>
           <a:p>
-            <a:pPr algn="l" marL="228600" indent="-228600">
+            <a:pPr marL="228600" indent="-228600" algn="l">
               <a:spcAft>
                 <a:spcPts val="500"/>
               </a:spcAft>
@@ -12079,7 +11991,7 @@
             </a:r>
           </a:p>
           <a:p>
-            <a:pPr algn="l" marL="228600" indent="-228600">
+            <a:pPr marL="228600" indent="-228600" algn="l">
               <a:spcAft>
                 <a:spcPts val="500"/>
               </a:spcAft>
@@ -12097,7 +12009,7 @@
             </a:r>
           </a:p>
           <a:p>
-            <a:pPr algn="l" marL="228600" indent="-228600">
+            <a:pPr marL="228600" indent="-228600" algn="l">
               <a:spcAft>
                 <a:spcPts val="500"/>
               </a:spcAft>
@@ -12115,7 +12027,7 @@
             </a:r>
           </a:p>
           <a:p>
-            <a:pPr algn="l" marL="228600" indent="-228600">
+            <a:pPr marL="228600" indent="-228600" algn="l">
               <a:spcAft>
                 <a:spcPts val="500"/>
               </a:spcAft>
@@ -12133,7 +12045,7 @@
             </a:r>
           </a:p>
           <a:p>
-            <a:pPr algn="l" marL="228600" indent="-228600">
+            <a:pPr marL="228600" indent="-228600" algn="l">
               <a:spcAft>
                 <a:spcPts val="500"/>
               </a:spcAft>
@@ -12177,6 +12089,13 @@
             </a:solidFill>
           </a:ln>
         </p:spPr>
+        <p:txBody>
+          <a:bodyPr/>
+          <a:lstStyle/>
+          <a:p>
+            <a:endParaRPr lang="en-US"/>
+          </a:p>
+        </p:txBody>
       </p:sp>
       <p:sp>
         <p:nvSpPr>
@@ -12201,6 +12120,13 @@
             <a:noFill/>
           </a:ln>
         </p:spPr>
+        <p:txBody>
+          <a:bodyPr/>
+          <a:lstStyle/>
+          <a:p>
+            <a:endParaRPr lang="en-US"/>
+          </a:p>
+        </p:txBody>
       </p:sp>
       <p:sp>
         <p:nvSpPr>
@@ -12267,7 +12193,7 @@
           <a:bodyPr wrap="square" lIns="91440" tIns="68580" rIns="91440" bIns="68580" anchor="t"/>
           <a:lstStyle/>
           <a:p>
-            <a:pPr algn="l" marL="228600" indent="-228600">
+            <a:pPr marL="228600" indent="-228600" algn="l">
               <a:spcAft>
                 <a:spcPts val="500"/>
               </a:spcAft>
@@ -12285,7 +12211,7 @@
             </a:r>
           </a:p>
           <a:p>
-            <a:pPr algn="l" marL="228600" indent="-228600">
+            <a:pPr marL="228600" indent="-228600" algn="l">
               <a:spcAft>
                 <a:spcPts val="500"/>
               </a:spcAft>
@@ -12303,7 +12229,7 @@
             </a:r>
           </a:p>
           <a:p>
-            <a:pPr algn="l" marL="228600" indent="-228600">
+            <a:pPr marL="228600" indent="-228600" algn="l">
               <a:spcAft>
                 <a:spcPts val="500"/>
               </a:spcAft>
@@ -12321,7 +12247,7 @@
             </a:r>
           </a:p>
           <a:p>
-            <a:pPr algn="l" marL="228600" indent="-228600">
+            <a:pPr marL="228600" indent="-228600" algn="l">
               <a:spcAft>
                 <a:spcPts val="500"/>
               </a:spcAft>
@@ -12339,7 +12265,7 @@
             </a:r>
           </a:p>
           <a:p>
-            <a:pPr algn="l" marL="228600" indent="-228600">
+            <a:pPr marL="228600" indent="-228600" algn="l">
               <a:spcAft>
                 <a:spcPts val="500"/>
               </a:spcAft>
@@ -12357,7 +12283,7 @@
             </a:r>
           </a:p>
           <a:p>
-            <a:pPr algn="l" marL="228600" indent="-228600">
+            <a:pPr marL="228600" indent="-228600" algn="l">
               <a:spcAft>
                 <a:spcPts val="500"/>
               </a:spcAft>
@@ -12375,7 +12301,7 @@
             </a:r>
           </a:p>
           <a:p>
-            <a:pPr algn="l" marL="228600" indent="-228600">
+            <a:pPr marL="228600" indent="-228600" algn="l">
               <a:spcAft>
                 <a:spcPts val="500"/>
               </a:spcAft>
@@ -12393,7 +12319,7 @@
             </a:r>
           </a:p>
           <a:p>
-            <a:pPr algn="l" marL="228600" indent="-228600">
+            <a:pPr marL="228600" indent="-228600" algn="l">
               <a:spcAft>
                 <a:spcPts val="500"/>
               </a:spcAft>
@@ -12411,7 +12337,7 @@
             </a:r>
           </a:p>
           <a:p>
-            <a:pPr algn="l" marL="228600" indent="-228600">
+            <a:pPr marL="228600" indent="-228600" algn="l">
               <a:spcAft>
                 <a:spcPts val="500"/>
               </a:spcAft>
@@ -12429,7 +12355,7 @@
             </a:r>
           </a:p>
           <a:p>
-            <a:pPr algn="l" marL="228600" indent="-228600">
+            <a:pPr marL="228600" indent="-228600" algn="l">
               <a:spcAft>
                 <a:spcPts val="500"/>
               </a:spcAft>
@@ -12447,7 +12373,7 @@
             </a:r>
           </a:p>
           <a:p>
-            <a:pPr algn="l" marL="228600" indent="-228600">
+            <a:pPr marL="228600" indent="-228600" algn="l">
               <a:spcAft>
                 <a:spcPts val="500"/>
               </a:spcAft>
@@ -12491,6 +12417,13 @@
             </a:solidFill>
           </a:ln>
         </p:spPr>
+        <p:txBody>
+          <a:bodyPr/>
+          <a:lstStyle/>
+          <a:p>
+            <a:endParaRPr lang="en-US"/>
+          </a:p>
+        </p:txBody>
       </p:sp>
       <p:sp>
         <p:nvSpPr>
@@ -12515,6 +12448,13 @@
             <a:noFill/>
           </a:ln>
         </p:spPr>
+        <p:txBody>
+          <a:bodyPr/>
+          <a:lstStyle/>
+          <a:p>
+            <a:endParaRPr lang="en-US"/>
+          </a:p>
+        </p:txBody>
       </p:sp>
       <p:sp>
         <p:nvSpPr>
@@ -12581,7 +12521,7 @@
           <a:bodyPr wrap="square" lIns="91440" tIns="68580" rIns="91440" bIns="68580" anchor="t"/>
           <a:lstStyle/>
           <a:p>
-            <a:pPr algn="l" marL="228600" indent="-228600">
+            <a:pPr marL="228600" indent="-228600" algn="l">
               <a:spcAft>
                 <a:spcPts val="500"/>
               </a:spcAft>
@@ -12599,7 +12539,7 @@
             </a:r>
           </a:p>
           <a:p>
-            <a:pPr algn="l" marL="228600" indent="-228600">
+            <a:pPr marL="228600" indent="-228600" algn="l">
               <a:spcAft>
                 <a:spcPts val="500"/>
               </a:spcAft>
@@ -12617,7 +12557,7 @@
             </a:r>
           </a:p>
           <a:p>
-            <a:pPr algn="l" marL="228600" indent="-228600">
+            <a:pPr marL="228600" indent="-228600" algn="l">
               <a:spcAft>
                 <a:spcPts val="500"/>
               </a:spcAft>
@@ -12635,7 +12575,7 @@
             </a:r>
           </a:p>
           <a:p>
-            <a:pPr algn="l" marL="228600" indent="-228600">
+            <a:pPr marL="228600" indent="-228600" algn="l">
               <a:spcAft>
                 <a:spcPts val="500"/>
               </a:spcAft>
@@ -12653,7 +12593,7 @@
             </a:r>
           </a:p>
           <a:p>
-            <a:pPr algn="l" marL="228600" indent="-228600">
+            <a:pPr marL="228600" indent="-228600" algn="l">
               <a:spcAft>
                 <a:spcPts val="500"/>
               </a:spcAft>
@@ -12671,7 +12611,7 @@
             </a:r>
           </a:p>
           <a:p>
-            <a:pPr algn="l" marL="228600" indent="-228600">
+            <a:pPr marL="228600" indent="-228600" algn="l">
               <a:spcAft>
                 <a:spcPts val="500"/>
               </a:spcAft>
@@ -12689,7 +12629,7 @@
             </a:r>
           </a:p>
           <a:p>
-            <a:pPr algn="l" marL="228600" indent="-228600">
+            <a:pPr marL="228600" indent="-228600" algn="l">
               <a:spcAft>
                 <a:spcPts val="500"/>
               </a:spcAft>
@@ -12707,7 +12647,7 @@
             </a:r>
           </a:p>
           <a:p>
-            <a:pPr algn="l" marL="228600" indent="-228600">
+            <a:pPr marL="228600" indent="-228600" algn="l">
               <a:spcAft>
                 <a:spcPts val="500"/>
               </a:spcAft>
@@ -12725,7 +12665,7 @@
             </a:r>
           </a:p>
           <a:p>
-            <a:pPr algn="l" marL="228600" indent="-228600">
+            <a:pPr marL="228600" indent="-228600" algn="l">
               <a:spcAft>
                 <a:spcPts val="500"/>
               </a:spcAft>
@@ -12743,7 +12683,7 @@
             </a:r>
           </a:p>
           <a:p>
-            <a:pPr algn="l" marL="228600" indent="-228600">
+            <a:pPr marL="228600" indent="-228600" algn="l">
               <a:spcAft>
                 <a:spcPts val="500"/>
               </a:spcAft>
@@ -12761,7 +12701,7 @@
             </a:r>
           </a:p>
           <a:p>
-            <a:pPr algn="l" marL="228600" indent="-228600">
+            <a:pPr marL="228600" indent="-228600" algn="l">
               <a:spcAft>
                 <a:spcPts val="500"/>
               </a:spcAft>
@@ -12894,5 +12834,7 @@
       </a:bgFillStyleLst>
     </a:fmtScheme>
   </a:themeElements>
+  <a:objectDefaults/>
+  <a:extraClrSchemeLst/>
 </a:theme>
 </file>
</xml_diff>